<commit_message>
Media nav; expand Pledges to 10 + donut; Coalition Room instant-minutes + deck slide
</commit_message>
<xml_diff>
--- a/MazingiraKenya-Partner-Pitch.pptx
+++ b/MazingiraKenya-Partner-Pitch.pptx
@@ -16,9 +16,10 @@
     <p:sldId id="264" r:id="rId10"/>
     <p:sldId id="265" r:id="rId11"/>
     <p:sldId id="266" r:id="rId12"/>
+    <p:sldId id="267" r:id="rId13"/>
   </p:sldIdLst>
   <p:notesMasterIdLst>
-    <p:notesMasterId r:id="rId13"/>
+    <p:notesMasterId r:id="rId14"/>
   </p:notesMasterIdLst>
   <p:sldSz cx="12192000" cy="6858000"/>
   <p:notesSz cx="6858000" cy="12192000"/>
@@ -712,6 +713,94 @@
             <a:fld id="{F7021451-1387-4CA6-816F-3879F97B5CBC}" type="slidenum">
               <a:rPr lang="en-US"/>
               <a:t>11</a:t>
+            </a:fld>
+            <a:endParaRPr lang="en-US"/>
+          </a:p>
+        </p:txBody>
+      </p:sp>
+    </p:spTree>
+    <p:extLst>
+      <p:ext uri="{BB962C8B-B14F-4D97-AF65-F5344CB8AC3E}">
+        <p14:creationId xmlns:p14="http://schemas.microsoft.com/office/powerpoint/2010/main" val="1024086991"/>
+      </p:ext>
+    </p:extLst>
+  </p:cSld>
+  <p:clrMapOvr>
+    <a:masterClrMapping/>
+  </p:clrMapOvr>
+</p:notes>
+</file>
+
+<file path=ppt/notesSlides/notesSlide12.xml><?xml version="1.0" encoding="utf-8"?>
+<p:notes xmlns:a="http://schemas.openxmlformats.org/drawingml/2006/main" xmlns:r="http://schemas.openxmlformats.org/officeDocument/2006/relationships" xmlns:p="http://schemas.openxmlformats.org/presentationml/2006/main">
+  <p:cSld>
+    <p:spTree>
+      <p:nvGrpSpPr>
+        <p:cNvPr id="1" name=""/>
+        <p:cNvGrpSpPr/>
+        <p:nvPr/>
+      </p:nvGrpSpPr>
+      <p:grpSpPr>
+        <a:xfrm>
+          <a:off x="0" y="0"/>
+          <a:ext cx="0" cy="0"/>
+          <a:chOff x="0" y="0"/>
+          <a:chExt cx="0" cy="0"/>
+        </a:xfrm>
+      </p:grpSpPr>
+      <p:sp>
+        <p:nvSpPr>
+          <p:cNvPr id="2" name="Slide Image Placeholder 1"/>
+          <p:cNvSpPr>
+            <a:spLocks noGrp="1" noRot="1" noChangeAspect="1"/>
+          </p:cNvSpPr>
+          <p:nvPr>
+            <p:ph type="sldImg"/>
+          </p:nvPr>
+        </p:nvSpPr>
+        <p:spPr/>
+      </p:sp>
+      <p:sp>
+        <p:nvSpPr>
+          <p:cNvPr id="3" name="Notes Placeholder 2"/>
+          <p:cNvSpPr>
+            <a:spLocks noGrp="1"/>
+          </p:cNvSpPr>
+          <p:nvPr>
+            <p:ph type="body" idx="1"/>
+          </p:nvPr>
+        </p:nvSpPr>
+        <p:spPr/>
+        <p:txBody>
+          <a:bodyPr/>
+          <a:lstStyle/>
+          <a:p>
+            <a:r>
+              <a:rPr lang="en-US" dirty="0"/>
+              <a:t/>
+            </a:r>
+            <a:endParaRPr lang="en-US" dirty="0"/>
+          </a:p>
+        </p:txBody>
+      </p:sp>
+      <p:sp>
+        <p:nvSpPr>
+          <p:cNvPr id="4" name="Slide Number Placeholder 3"/>
+          <p:cNvSpPr>
+            <a:spLocks noGrp="1"/>
+          </p:cNvSpPr>
+          <p:nvPr>
+            <p:ph type="sldNum" sz="quarter" idx="10"/>
+          </p:nvPr>
+        </p:nvSpPr>
+        <p:spPr/>
+        <p:txBody>
+          <a:bodyPr/>
+          <a:lstStyle/>
+          <a:p>
+            <a:fld id="{F7021451-1387-4CA6-816F-3879F97B5CBC}" type="slidenum">
+              <a:rPr lang="en-US"/>
+              <a:t>12</a:t>
             </a:fld>
             <a:endParaRPr lang="en-US"/>
           </a:p>
@@ -2029,6 +2118,590 @@
                 <a:ea typeface="Calibri" pitchFamily="34" charset="-122"/>
                 <a:cs typeface="Calibri" pitchFamily="34" charset="-120"/>
               </a:rPr>
+              <a:t>THE RECEIPTS</a:t>
+            </a:r>
+            <a:endParaRPr lang="en-US" sz="1200" dirty="0"/>
+          </a:p>
+        </p:txBody>
+      </p:sp>
+      <p:sp>
+        <p:nvSpPr>
+          <p:cNvPr id="3" name="Text 1"/>
+          <p:cNvSpPr/>
+          <p:nvPr/>
+        </p:nvSpPr>
+        <p:spPr>
+          <a:xfrm>
+            <a:off x="548640" y="658368"/>
+            <a:ext cx="11064240" cy="640080"/>
+          </a:xfrm>
+          <a:prstGeom prst="rect">
+            <a:avLst/>
+          </a:prstGeom>
+          <a:noFill/>
+          <a:ln/>
+        </p:spPr>
+        <p:txBody>
+          <a:bodyPr wrap="square" lIns="0" tIns="0" rIns="0" bIns="0" rtlCol="0" anchor="ctr"/>
+          <a:lstStyle/>
+          <a:p>
+            <a:pPr indent="0" marL="0">
+              <a:buNone/>
+            </a:pPr>
+            <a:r>
+              <a:rPr lang="en-US" sz="3000" b="1" dirty="0">
+                <a:solidFill>
+                  <a:srgbClr val="1B6B4A"/>
+                </a:solidFill>
+                <a:latin typeface="Cambria" pitchFamily="34" charset="0"/>
+                <a:ea typeface="Cambria" pitchFamily="34" charset="-122"/>
+                <a:cs typeface="Cambria" pitchFamily="34" charset="-120"/>
+              </a:rPr>
+              <a:t>An accountability index with sources</a:t>
+            </a:r>
+            <a:endParaRPr lang="en-US" sz="3000" dirty="0"/>
+          </a:p>
+        </p:txBody>
+      </p:sp>
+      <p:sp>
+        <p:nvSpPr>
+          <p:cNvPr id="4" name="Text 2"/>
+          <p:cNvSpPr/>
+          <p:nvPr/>
+        </p:nvSpPr>
+        <p:spPr>
+          <a:xfrm>
+            <a:off x="548640" y="1417320"/>
+            <a:ext cx="10972800" cy="822960"/>
+          </a:xfrm>
+          <a:prstGeom prst="rect">
+            <a:avLst/>
+          </a:prstGeom>
+          <a:noFill/>
+          <a:ln/>
+        </p:spPr>
+        <p:txBody>
+          <a:bodyPr wrap="square" lIns="0" tIns="0" rIns="0" bIns="0" rtlCol="0" anchor="t"/>
+          <a:lstStyle/>
+          <a:p>
+            <a:pPr indent="0" marL="0">
+              <a:buNone/>
+            </a:pPr>
+            <a:r>
+              <a:rPr lang="en-US" sz="1400" dirty="0">
+                <a:solidFill>
+                  <a:srgbClr val="5D6B63"/>
+                </a:solidFill>
+                <a:latin typeface="Calibri" pitchFamily="34" charset="0"/>
+                <a:ea typeface="Calibri" pitchFamily="34" charset="-122"/>
+                <a:cs typeface="Calibri" pitchFamily="34" charset="-120"/>
+              </a:rPr>
+              <a:t>The banks, oil majors and state financiers shaping Kenya's energy future — each measured against their own public climate promises, and scored, with sources to follow.</a:t>
+            </a:r>
+            <a:endParaRPr lang="en-US" sz="1400" dirty="0"/>
+          </a:p>
+        </p:txBody>
+      </p:sp>
+      <p:sp>
+        <p:nvSpPr>
+          <p:cNvPr id="5" name="Shape 3"/>
+          <p:cNvSpPr/>
+          <p:nvPr/>
+        </p:nvSpPr>
+        <p:spPr>
+          <a:xfrm>
+            <a:off x="548640" y="2468880"/>
+            <a:ext cx="3611880" cy="2834640"/>
+          </a:xfrm>
+          <a:prstGeom prst="roundRect">
+            <a:avLst>
+              <a:gd name="adj" fmla="val 2581"/>
+            </a:avLst>
+          </a:prstGeom>
+          <a:solidFill>
+            <a:srgbClr val="F1F5F3"/>
+          </a:solidFill>
+          <a:ln w="9525">
+            <a:solidFill>
+              <a:srgbClr val="D9E2DC"/>
+            </a:solidFill>
+            <a:prstDash val="solid"/>
+          </a:ln>
+          <a:effectLst>
+            <a:outerShdw sx="100000" sy="100000" kx="0" ky="0" algn="bl" rotWithShape="0" blurRad="76200" dist="25400" dir="5400000">
+              <a:srgbClr val="9AA8A0">
+                <a:alpha val="35000"/>
+              </a:srgbClr>
+            </a:outerShdw>
+          </a:effectLst>
+        </p:spPr>
+      </p:sp>
+      <p:sp>
+        <p:nvSpPr>
+          <p:cNvPr id="6" name="Shape 4"/>
+          <p:cNvSpPr/>
+          <p:nvPr/>
+        </p:nvSpPr>
+        <p:spPr>
+          <a:xfrm>
+            <a:off x="2029968" y="2697480"/>
+            <a:ext cx="640080" cy="640080"/>
+          </a:xfrm>
+          <a:prstGeom prst="ellipse">
+            <a:avLst/>
+          </a:prstGeom>
+          <a:solidFill>
+            <a:srgbClr val="1B6B4A"/>
+          </a:solidFill>
+          <a:ln/>
+        </p:spPr>
+      </p:sp>
+      <p:sp>
+        <p:nvSpPr>
+          <p:cNvPr id="7" name="Text 5"/>
+          <p:cNvSpPr/>
+          <p:nvPr/>
+        </p:nvSpPr>
+        <p:spPr>
+          <a:xfrm>
+            <a:off x="731520" y="3429000"/>
+            <a:ext cx="3246120" cy="457200"/>
+          </a:xfrm>
+          <a:prstGeom prst="rect">
+            <a:avLst/>
+          </a:prstGeom>
+          <a:noFill/>
+          <a:ln/>
+        </p:spPr>
+        <p:txBody>
+          <a:bodyPr wrap="square" lIns="0" tIns="0" rIns="0" bIns="0" rtlCol="0" anchor="ctr"/>
+          <a:lstStyle/>
+          <a:p>
+            <a:pPr algn="ctr" indent="0" marL="0">
+              <a:buNone/>
+            </a:pPr>
+            <a:r>
+              <a:rPr lang="en-US" sz="1800" b="1" dirty="0">
+                <a:solidFill>
+                  <a:srgbClr val="1D2621"/>
+                </a:solidFill>
+                <a:latin typeface="Calibri" pitchFamily="34" charset="0"/>
+                <a:ea typeface="Calibri" pitchFamily="34" charset="-122"/>
+                <a:cs typeface="Calibri" pitchFamily="34" charset="-120"/>
+              </a:rPr>
+              <a:t>Kept</a:t>
+            </a:r>
+            <a:endParaRPr lang="en-US" sz="1800" dirty="0"/>
+          </a:p>
+        </p:txBody>
+      </p:sp>
+      <p:sp>
+        <p:nvSpPr>
+          <p:cNvPr id="8" name="Text 6"/>
+          <p:cNvSpPr/>
+          <p:nvPr/>
+        </p:nvSpPr>
+        <p:spPr>
+          <a:xfrm>
+            <a:off x="804672" y="3886200"/>
+            <a:ext cx="3108960" cy="1280160"/>
+          </a:xfrm>
+          <a:prstGeom prst="rect">
+            <a:avLst/>
+          </a:prstGeom>
+          <a:noFill/>
+          <a:ln/>
+        </p:spPr>
+        <p:txBody>
+          <a:bodyPr wrap="square" lIns="0" tIns="0" rIns="0" bIns="0" rtlCol="0" anchor="t"/>
+          <a:lstStyle/>
+          <a:p>
+            <a:pPr algn="ctr" indent="0" marL="0">
+              <a:buNone/>
+            </a:pPr>
+            <a:r>
+              <a:rPr lang="en-US" sz="1200" dirty="0">
+                <a:solidFill>
+                  <a:srgbClr val="5D6B63"/>
+                </a:solidFill>
+                <a:latin typeface="Calibri" pitchFamily="34" charset="0"/>
+                <a:ea typeface="Calibri" pitchFamily="34" charset="-122"/>
+                <a:cs typeface="Calibri" pitchFamily="34" charset="-120"/>
+              </a:rPr>
+              <a:t>Promise matched by action — e.g. a bank declining to finance EACOP</a:t>
+            </a:r>
+            <a:endParaRPr lang="en-US" sz="1200" dirty="0"/>
+          </a:p>
+        </p:txBody>
+      </p:sp>
+      <p:sp>
+        <p:nvSpPr>
+          <p:cNvPr id="9" name="Shape 7"/>
+          <p:cNvSpPr/>
+          <p:nvPr/>
+        </p:nvSpPr>
+        <p:spPr>
+          <a:xfrm>
+            <a:off x="4261104" y="2468880"/>
+            <a:ext cx="3611880" cy="2834640"/>
+          </a:xfrm>
+          <a:prstGeom prst="roundRect">
+            <a:avLst>
+              <a:gd name="adj" fmla="val 2581"/>
+            </a:avLst>
+          </a:prstGeom>
+          <a:solidFill>
+            <a:srgbClr val="F1F5F3"/>
+          </a:solidFill>
+          <a:ln w="9525">
+            <a:solidFill>
+              <a:srgbClr val="D9E2DC"/>
+            </a:solidFill>
+            <a:prstDash val="solid"/>
+          </a:ln>
+          <a:effectLst>
+            <a:outerShdw sx="100000" sy="100000" kx="0" ky="0" algn="bl" rotWithShape="0" blurRad="76200" dist="25400" dir="5400000">
+              <a:srgbClr val="9AA8A0">
+                <a:alpha val="35000"/>
+              </a:srgbClr>
+            </a:outerShdw>
+          </a:effectLst>
+        </p:spPr>
+      </p:sp>
+      <p:sp>
+        <p:nvSpPr>
+          <p:cNvPr id="10" name="Shape 8"/>
+          <p:cNvSpPr/>
+          <p:nvPr/>
+        </p:nvSpPr>
+        <p:spPr>
+          <a:xfrm>
+            <a:off x="5742432" y="2697480"/>
+            <a:ext cx="640080" cy="640080"/>
+          </a:xfrm>
+          <a:prstGeom prst="ellipse">
+            <a:avLst/>
+          </a:prstGeom>
+          <a:solidFill>
+            <a:srgbClr val="EE9455"/>
+          </a:solidFill>
+          <a:ln/>
+        </p:spPr>
+      </p:sp>
+      <p:sp>
+        <p:nvSpPr>
+          <p:cNvPr id="11" name="Text 9"/>
+          <p:cNvSpPr/>
+          <p:nvPr/>
+        </p:nvSpPr>
+        <p:spPr>
+          <a:xfrm>
+            <a:off x="4443984" y="3429000"/>
+            <a:ext cx="3246120" cy="457200"/>
+          </a:xfrm>
+          <a:prstGeom prst="rect">
+            <a:avLst/>
+          </a:prstGeom>
+          <a:noFill/>
+          <a:ln/>
+        </p:spPr>
+        <p:txBody>
+          <a:bodyPr wrap="square" lIns="0" tIns="0" rIns="0" bIns="0" rtlCol="0" anchor="ctr"/>
+          <a:lstStyle/>
+          <a:p>
+            <a:pPr algn="ctr" indent="0" marL="0">
+              <a:buNone/>
+            </a:pPr>
+            <a:r>
+              <a:rPr lang="en-US" sz="1800" b="1" dirty="0">
+                <a:solidFill>
+                  <a:srgbClr val="1D2621"/>
+                </a:solidFill>
+                <a:latin typeface="Calibri" pitchFamily="34" charset="0"/>
+                <a:ea typeface="Calibri" pitchFamily="34" charset="-122"/>
+                <a:cs typeface="Calibri" pitchFamily="34" charset="-120"/>
+              </a:rPr>
+              <a:t>Partial</a:t>
+            </a:r>
+            <a:endParaRPr lang="en-US" sz="1800" dirty="0"/>
+          </a:p>
+        </p:txBody>
+      </p:sp>
+      <p:sp>
+        <p:nvSpPr>
+          <p:cNvPr id="12" name="Text 10"/>
+          <p:cNvSpPr/>
+          <p:nvPr/>
+        </p:nvSpPr>
+        <p:spPr>
+          <a:xfrm>
+            <a:off x="4517136" y="3886200"/>
+            <a:ext cx="3108960" cy="1280160"/>
+          </a:xfrm>
+          <a:prstGeom prst="rect">
+            <a:avLst/>
+          </a:prstGeom>
+          <a:noFill/>
+          <a:ln/>
+        </p:spPr>
+        <p:txBody>
+          <a:bodyPr wrap="square" lIns="0" tIns="0" rIns="0" bIns="0" rtlCol="0" anchor="t"/>
+          <a:lstStyle/>
+          <a:p>
+            <a:pPr algn="ctr" indent="0" marL="0">
+              <a:buNone/>
+            </a:pPr>
+            <a:r>
+              <a:rPr lang="en-US" sz="1200" dirty="0">
+                <a:solidFill>
+                  <a:srgbClr val="5D6B63"/>
+                </a:solidFill>
+                <a:latin typeface="Calibri" pitchFamily="34" charset="0"/>
+                <a:ea typeface="Calibri" pitchFamily="34" charset="-122"/>
+                <a:cs typeface="Calibri" pitchFamily="34" charset="-120"/>
+              </a:rPr>
+              <a:t>Real movement, real gaps — e.g. a coal pledge with a legacy pipeline</a:t>
+            </a:r>
+            <a:endParaRPr lang="en-US" sz="1200" dirty="0"/>
+          </a:p>
+        </p:txBody>
+      </p:sp>
+      <p:sp>
+        <p:nvSpPr>
+          <p:cNvPr id="13" name="Shape 11"/>
+          <p:cNvSpPr/>
+          <p:nvPr/>
+        </p:nvSpPr>
+        <p:spPr>
+          <a:xfrm>
+            <a:off x="7973568" y="2468880"/>
+            <a:ext cx="3611880" cy="2834640"/>
+          </a:xfrm>
+          <a:prstGeom prst="roundRect">
+            <a:avLst>
+              <a:gd name="adj" fmla="val 2581"/>
+            </a:avLst>
+          </a:prstGeom>
+          <a:solidFill>
+            <a:srgbClr val="F1F5F3"/>
+          </a:solidFill>
+          <a:ln w="9525">
+            <a:solidFill>
+              <a:srgbClr val="D9E2DC"/>
+            </a:solidFill>
+            <a:prstDash val="solid"/>
+          </a:ln>
+          <a:effectLst>
+            <a:outerShdw sx="100000" sy="100000" kx="0" ky="0" algn="bl" rotWithShape="0" blurRad="76200" dist="25400" dir="5400000">
+              <a:srgbClr val="9AA8A0">
+                <a:alpha val="35000"/>
+              </a:srgbClr>
+            </a:outerShdw>
+          </a:effectLst>
+        </p:spPr>
+      </p:sp>
+      <p:sp>
+        <p:nvSpPr>
+          <p:cNvPr id="14" name="Shape 12"/>
+          <p:cNvSpPr/>
+          <p:nvPr/>
+        </p:nvSpPr>
+        <p:spPr>
+          <a:xfrm>
+            <a:off x="9454896" y="2697480"/>
+            <a:ext cx="640080" cy="640080"/>
+          </a:xfrm>
+          <a:prstGeom prst="ellipse">
+            <a:avLst/>
+          </a:prstGeom>
+          <a:solidFill>
+            <a:srgbClr val="EE9455"/>
+          </a:solidFill>
+          <a:ln/>
+        </p:spPr>
+      </p:sp>
+      <p:sp>
+        <p:nvSpPr>
+          <p:cNvPr id="15" name="Text 13"/>
+          <p:cNvSpPr/>
+          <p:nvPr/>
+        </p:nvSpPr>
+        <p:spPr>
+          <a:xfrm>
+            <a:off x="8156448" y="3429000"/>
+            <a:ext cx="3246120" cy="457200"/>
+          </a:xfrm>
+          <a:prstGeom prst="rect">
+            <a:avLst/>
+          </a:prstGeom>
+          <a:noFill/>
+          <a:ln/>
+        </p:spPr>
+        <p:txBody>
+          <a:bodyPr wrap="square" lIns="0" tIns="0" rIns="0" bIns="0" rtlCol="0" anchor="ctr"/>
+          <a:lstStyle/>
+          <a:p>
+            <a:pPr algn="ctr" indent="0" marL="0">
+              <a:buNone/>
+            </a:pPr>
+            <a:r>
+              <a:rPr lang="en-US" sz="1800" b="1" dirty="0">
+                <a:solidFill>
+                  <a:srgbClr val="1D2621"/>
+                </a:solidFill>
+                <a:latin typeface="Calibri" pitchFamily="34" charset="0"/>
+                <a:ea typeface="Calibri" pitchFamily="34" charset="-122"/>
+                <a:cs typeface="Calibri" pitchFamily="34" charset="-120"/>
+              </a:rPr>
+              <a:t>Lip-service</a:t>
+            </a:r>
+            <a:endParaRPr lang="en-US" sz="1800" dirty="0"/>
+          </a:p>
+        </p:txBody>
+      </p:sp>
+      <p:sp>
+        <p:nvSpPr>
+          <p:cNvPr id="16" name="Text 14"/>
+          <p:cNvSpPr/>
+          <p:nvPr/>
+        </p:nvSpPr>
+        <p:spPr>
+          <a:xfrm>
+            <a:off x="8229600" y="3886200"/>
+            <a:ext cx="3108960" cy="1280160"/>
+          </a:xfrm>
+          <a:prstGeom prst="rect">
+            <a:avLst/>
+          </a:prstGeom>
+          <a:noFill/>
+          <a:ln/>
+        </p:spPr>
+        <p:txBody>
+          <a:bodyPr wrap="square" lIns="0" tIns="0" rIns="0" bIns="0" rtlCol="0" anchor="t"/>
+          <a:lstStyle/>
+          <a:p>
+            <a:pPr algn="ctr" indent="0" marL="0">
+              <a:buNone/>
+            </a:pPr>
+            <a:r>
+              <a:rPr lang="en-US" sz="1200" dirty="0">
+                <a:solidFill>
+                  <a:srgbClr val="5D6B63"/>
+                </a:solidFill>
+                <a:latin typeface="Calibri" pitchFamily="34" charset="0"/>
+                <a:ea typeface="Calibri" pitchFamily="34" charset="-122"/>
+                <a:cs typeface="Calibri" pitchFamily="34" charset="-120"/>
+              </a:rPr>
+              <a:t>A claim, not conduct — e.g. “net zero” that ignores 85% of emissions</a:t>
+            </a:r>
+            <a:endParaRPr lang="en-US" sz="1200" dirty="0"/>
+          </a:p>
+        </p:txBody>
+      </p:sp>
+      <p:sp>
+        <p:nvSpPr>
+          <p:cNvPr id="17" name="Text 15"/>
+          <p:cNvSpPr/>
+          <p:nvPr/>
+        </p:nvSpPr>
+        <p:spPr>
+          <a:xfrm>
+            <a:off x="548640" y="6446520"/>
+            <a:ext cx="11064240" cy="274320"/>
+          </a:xfrm>
+          <a:prstGeom prst="rect">
+            <a:avLst/>
+          </a:prstGeom>
+          <a:noFill/>
+          <a:ln/>
+        </p:spPr>
+        <p:txBody>
+          <a:bodyPr wrap="square" lIns="0" tIns="0" rIns="0" bIns="0" rtlCol="0" anchor="ctr"/>
+          <a:lstStyle/>
+          <a:p>
+            <a:pPr indent="0" marL="0">
+              <a:buNone/>
+            </a:pPr>
+            <a:r>
+              <a:rPr lang="en-US" sz="900" i="1" dirty="0">
+                <a:solidFill>
+                  <a:srgbClr val="5D6B63"/>
+                </a:solidFill>
+                <a:latin typeface="Calibri" pitchFamily="34" charset="0"/>
+                <a:ea typeface="Calibri" pitchFamily="34" charset="-122"/>
+                <a:cs typeface="Calibri" pitchFamily="34" charset="-120"/>
+              </a:rPr>
+              <a:t>MazingiraKenya · Partner prospectus</a:t>
+            </a:r>
+            <a:endParaRPr lang="en-US" sz="900" dirty="0"/>
+          </a:p>
+        </p:txBody>
+      </p:sp>
+    </p:spTree>
+  </p:cSld>
+  <p:clrMapOvr>
+    <a:masterClrMapping/>
+  </p:clrMapOvr>
+</p:sld>
+</file>
+
+<file path=ppt/slides/slide11.xml><?xml version="1.0" encoding="utf-8"?>
+<p:sld xmlns:a="http://schemas.openxmlformats.org/drawingml/2006/main" xmlns:r="http://schemas.openxmlformats.org/officeDocument/2006/relationships" xmlns:p="http://schemas.openxmlformats.org/presentationml/2006/main">
+  <p:cSld name="Slide 11">
+    <p:bg>
+      <p:bgPr>
+        <a:solidFill>
+          <a:srgbClr val="FFFFFF"/>
+        </a:solidFill>
+      </p:bgPr>
+    </p:bg>
+    <p:spTree>
+      <p:nvGrpSpPr>
+        <p:cNvPr id="1" name=""/>
+        <p:cNvGrpSpPr/>
+        <p:nvPr/>
+      </p:nvGrpSpPr>
+      <p:grpSpPr>
+        <a:xfrm>
+          <a:off x="0" y="0"/>
+          <a:ext cx="0" cy="0"/>
+          <a:chOff x="0" y="0"/>
+          <a:chExt cx="0" cy="0"/>
+        </a:xfrm>
+      </p:grpSpPr>
+      <p:sp>
+        <p:nvSpPr>
+          <p:cNvPr id="2" name="Text 0"/>
+          <p:cNvSpPr/>
+          <p:nvPr/>
+        </p:nvSpPr>
+        <p:spPr>
+          <a:xfrm>
+            <a:off x="548640" y="384048"/>
+            <a:ext cx="10972800" cy="274320"/>
+          </a:xfrm>
+          <a:prstGeom prst="rect">
+            <a:avLst/>
+          </a:prstGeom>
+          <a:noFill/>
+          <a:ln/>
+        </p:spPr>
+        <p:txBody>
+          <a:bodyPr wrap="square" lIns="0" tIns="0" rIns="0" bIns="0" rtlCol="0" anchor="ctr"/>
+          <a:lstStyle/>
+          <a:p>
+            <a:pPr indent="0" marL="0">
+              <a:buNone/>
+            </a:pPr>
+            <a:r>
+              <a:rPr lang="en-US" sz="1200" b="1" spc="200" kern="0" dirty="0">
+                <a:solidFill>
+                  <a:srgbClr val="EE9455"/>
+                </a:solidFill>
+                <a:latin typeface="Calibri" pitchFamily="34" charset="0"/>
+                <a:ea typeface="Calibri" pitchFamily="34" charset="-122"/>
+                <a:cs typeface="Calibri" pitchFamily="34" charset="-120"/>
+              </a:rPr>
               <a:t>WHY PARTNER NOW</a:t>
             </a:r>
             <a:endParaRPr lang="en-US" sz="1200" dirty="0"/>
@@ -2496,9 +3169,9 @@
 </p:sld>
 </file>
 
-<file path=ppt/slides/slide11.xml><?xml version="1.0" encoding="utf-8"?>
+<file path=ppt/slides/slide12.xml><?xml version="1.0" encoding="utf-8"?>
 <p:sld xmlns:a="http://schemas.openxmlformats.org/drawingml/2006/main" xmlns:r="http://schemas.openxmlformats.org/officeDocument/2006/relationships" xmlns:p="http://schemas.openxmlformats.org/presentationml/2006/main">
-  <p:cSld name="Slide 11">
+  <p:cSld name="Slide 12">
     <p:bg>
       <p:bgPr>
         <a:solidFill>
@@ -6335,7 +7008,7 @@
                 <a:ea typeface="Calibri" pitchFamily="34" charset="-122"/>
                 <a:cs typeface="Calibri" pitchFamily="34" charset="-120"/>
               </a:rPr>
-              <a:t>WHY IT'S USEFUL</a:t>
+              <a:t>CONVENE · DECIDE · ACT</a:t>
             </a:r>
             <a:endParaRPr lang="en-US" sz="1200" dirty="0"/>
           </a:p>
@@ -6374,7 +7047,7 @@
                 <a:ea typeface="Cambria" pitchFamily="34" charset="-122"/>
                 <a:cs typeface="Cambria" pitchFamily="34" charset="-120"/>
               </a:rPr>
-              <a:t>From information to leverage</a:t>
+              <a:t>The Coalition Room — where meetings produce action</a:t>
             </a:r>
             <a:endParaRPr lang="en-US" sz="3000" dirty="0"/>
           </a:p>
@@ -6389,11 +7062,11 @@
         <p:spPr>
           <a:xfrm>
             <a:off x="548640" y="1554480"/>
-            <a:ext cx="11064240" cy="1051560"/>
+            <a:ext cx="5440680" cy="3063240"/>
           </a:xfrm>
           <a:prstGeom prst="roundRect">
             <a:avLst>
-              <a:gd name="adj" fmla="val 6957"/>
+              <a:gd name="adj" fmla="val 2388"/>
             </a:avLst>
           </a:prstGeom>
           <a:solidFill>
@@ -6416,23 +7089,42 @@
       </p:sp>
       <p:sp>
         <p:nvSpPr>
-          <p:cNvPr id="5" name="Shape 3"/>
-          <p:cNvSpPr/>
-          <p:nvPr/>
-        </p:nvSpPr>
-        <p:spPr>
-          <a:xfrm>
-            <a:off x="749808" y="1773936"/>
-            <a:ext cx="457200" cy="457200"/>
-          </a:xfrm>
-          <a:prstGeom prst="ellipse">
-            <a:avLst/>
-          </a:prstGeom>
-          <a:solidFill>
-            <a:srgbClr val="1B6B4A"/>
-          </a:solidFill>
-          <a:ln/>
-        </p:spPr>
+          <p:cNvPr id="5" name="Text 3"/>
+          <p:cNvSpPr/>
+          <p:nvPr/>
+        </p:nvSpPr>
+        <p:spPr>
+          <a:xfrm>
+            <a:off x="822960" y="1783080"/>
+            <a:ext cx="4846320" cy="411480"/>
+          </a:xfrm>
+          <a:prstGeom prst="rect">
+            <a:avLst/>
+          </a:prstGeom>
+          <a:noFill/>
+          <a:ln/>
+        </p:spPr>
+        <p:txBody>
+          <a:bodyPr wrap="square" lIns="0" tIns="0" rIns="0" bIns="0" rtlCol="0" anchor="ctr"/>
+          <a:lstStyle/>
+          <a:p>
+            <a:pPr indent="0" marL="0">
+              <a:buNone/>
+            </a:pPr>
+            <a:r>
+              <a:rPr lang="en-US" sz="1700" b="1" dirty="0">
+                <a:solidFill>
+                  <a:srgbClr val="1B6B4A"/>
+                </a:solidFill>
+                <a:latin typeface="Calibri" pitchFamily="34" charset="0"/>
+                <a:ea typeface="Calibri" pitchFamily="34" charset="-122"/>
+                <a:cs typeface="Calibri" pitchFamily="34" charset="-120"/>
+              </a:rPr>
+              <a:t>One tap to meet</a:t>
+            </a:r>
+            <a:endParaRPr lang="en-US" sz="1700" dirty="0"/>
+          </a:p>
+        </p:txBody>
       </p:sp>
       <p:sp>
         <p:nvSpPr>
@@ -6442,63 +7134,28 @@
         </p:nvSpPr>
         <p:spPr>
           <a:xfrm>
-            <a:off x="749808" y="1773936"/>
-            <a:ext cx="457200" cy="457200"/>
-          </a:xfrm>
-          <a:prstGeom prst="rect">
-            <a:avLst/>
-          </a:prstGeom>
-          <a:noFill/>
-          <a:ln/>
-        </p:spPr>
-        <p:txBody>
-          <a:bodyPr wrap="square" lIns="0" tIns="0" rIns="0" bIns="0" rtlCol="0" anchor="ctr"/>
-          <a:lstStyle/>
-          <a:p>
-            <a:pPr algn="ctr" indent="0" marL="0">
-              <a:buNone/>
-            </a:pPr>
-            <a:r>
-              <a:rPr lang="en-US" sz="1500" b="1" dirty="0">
-                <a:solidFill>
-                  <a:srgbClr val="FFFFFF"/>
-                </a:solidFill>
-                <a:latin typeface="Calibri" pitchFamily="34" charset="0"/>
-                <a:ea typeface="Calibri" pitchFamily="34" charset="-122"/>
-                <a:cs typeface="Calibri" pitchFamily="34" charset="-120"/>
-              </a:rPr>
-              <a:t>✓</a:t>
-            </a:r>
-            <a:endParaRPr lang="en-US" sz="1500" dirty="0"/>
-          </a:p>
-        </p:txBody>
-      </p:sp>
-      <p:sp>
-        <p:nvSpPr>
-          <p:cNvPr id="7" name="Text 5"/>
-          <p:cNvSpPr/>
-          <p:nvPr/>
-        </p:nvSpPr>
-        <p:spPr>
-          <a:xfrm>
-            <a:off x="1371600" y="1700784"/>
-            <a:ext cx="10104120" cy="310896"/>
-          </a:xfrm>
-          <a:prstGeom prst="rect">
-            <a:avLst/>
-          </a:prstGeom>
-          <a:noFill/>
-          <a:ln/>
-        </p:spPr>
-        <p:txBody>
-          <a:bodyPr wrap="square" lIns="0" tIns="0" rIns="0" bIns="0" rtlCol="0" anchor="ctr"/>
-          <a:lstStyle/>
-          <a:p>
-            <a:pPr indent="0" marL="0">
-              <a:buNone/>
-            </a:pPr>
-            <a:r>
-              <a:rPr lang="en-US" sz="1400" b="1" dirty="0">
+            <a:off x="914400" y="2240280"/>
+            <a:ext cx="4846320" cy="2286000"/>
+          </a:xfrm>
+          <a:prstGeom prst="rect">
+            <a:avLst/>
+          </a:prstGeom>
+          <a:noFill/>
+          <a:ln/>
+        </p:spPr>
+        <p:txBody>
+          <a:bodyPr wrap="square" lIns="0" tIns="0" rIns="0" bIns="0" rtlCol="0" anchor="ctr"/>
+          <a:lstStyle/>
+          <a:p>
+            <a:pPr marL="203200" indent="-203200">
+              <a:spcAft>
+                <a:spcPts val="1100"/>
+              </a:spcAft>
+              <a:buSzPct val="100000"/>
+              <a:buChar char="•"/>
+            </a:pPr>
+            <a:r>
+              <a:rPr lang="en-US" sz="1350" dirty="0">
                 <a:solidFill>
                   <a:srgbClr val="1D2621"/>
                 </a:solidFill>
@@ -6506,69 +7163,72 @@
                 <a:ea typeface="Calibri" pitchFamily="34" charset="-122"/>
                 <a:cs typeface="Calibri" pitchFamily="34" charset="-120"/>
               </a:rPr>
-              <a:t>See the whole board</a:t>
-            </a:r>
-            <a:endParaRPr lang="en-US" sz="1400" dirty="0"/>
-          </a:p>
-        </p:txBody>
-      </p:sp>
-      <p:sp>
-        <p:nvSpPr>
-          <p:cNvPr id="8" name="Text 6"/>
-          <p:cNvSpPr/>
-          <p:nvPr/>
-        </p:nvSpPr>
-        <p:spPr>
-          <a:xfrm>
-            <a:off x="1371600" y="2011680"/>
-            <a:ext cx="10104120" cy="502920"/>
-          </a:xfrm>
-          <a:prstGeom prst="rect">
-            <a:avLst/>
-          </a:prstGeom>
-          <a:noFill/>
-          <a:ln/>
-        </p:spPr>
-        <p:txBody>
-          <a:bodyPr wrap="square" lIns="0" tIns="0" rIns="0" bIns="0" rtlCol="0" anchor="t"/>
-          <a:lstStyle/>
-          <a:p>
-            <a:pPr indent="0" marL="0">
-              <a:buNone/>
-            </a:pPr>
-            <a:r>
-              <a:rPr lang="en-US" sz="1150" dirty="0">
-                <a:solidFill>
-                  <a:srgbClr val="5D6B63"/>
-                </a:solidFill>
-                <a:latin typeface="Calibri" pitchFamily="34" charset="0"/>
-                <a:ea typeface="Calibri" pitchFamily="34" charset="-122"/>
-                <a:cs typeface="Calibri" pitchFamily="34" charset="-120"/>
-              </a:rPr>
-              <a:t>Every pressure and every responder in one view — the picture no single org holds.</a:t>
-            </a:r>
-            <a:endParaRPr lang="en-US" sz="1150" dirty="0"/>
-          </a:p>
-        </p:txBody>
-      </p:sp>
-      <p:sp>
-        <p:nvSpPr>
-          <p:cNvPr id="9" name="Shape 7"/>
-          <p:cNvSpPr/>
-          <p:nvPr/>
-        </p:nvSpPr>
-        <p:spPr>
-          <a:xfrm>
-            <a:off x="548640" y="2724912"/>
-            <a:ext cx="11064240" cy="1051560"/>
+              <a:t>Embedded video room — no account, no install, no app store</a:t>
+            </a:r>
+            <a:endParaRPr lang="en-US" sz="1350" dirty="0"/>
+          </a:p>
+          <a:p>
+            <a:pPr marL="203200" indent="-203200">
+              <a:spcAft>
+                <a:spcPts val="1100"/>
+              </a:spcAft>
+              <a:buSzPct val="100000"/>
+              <a:buChar char="•"/>
+            </a:pPr>
+            <a:r>
+              <a:rPr lang="en-US" sz="1350" dirty="0">
+                <a:solidFill>
+                  <a:srgbClr val="1D2621"/>
+                </a:solidFill>
+                <a:latin typeface="Calibri" pitchFamily="34" charset="0"/>
+                <a:ea typeface="Calibri" pitchFamily="34" charset="-122"/>
+                <a:cs typeface="Calibri" pitchFamily="34" charset="-120"/>
+              </a:rPr>
+              <a:t>Schedule a call and members get an auto calendar invite</a:t>
+            </a:r>
+            <a:endParaRPr lang="en-US" sz="1350" dirty="0"/>
+          </a:p>
+          <a:p>
+            <a:pPr marL="203200" indent="-203200">
+              <a:spcAft>
+                <a:spcPts val="1100"/>
+              </a:spcAft>
+              <a:buSzPct val="100000"/>
+              <a:buChar char="•"/>
+            </a:pPr>
+            <a:r>
+              <a:rPr lang="en-US" sz="1350" dirty="0">
+                <a:solidFill>
+                  <a:srgbClr val="1D2621"/>
+                </a:solidFill>
+                <a:latin typeface="Calibri" pitchFamily="34" charset="0"/>
+                <a:ea typeface="Calibri" pitchFamily="34" charset="-122"/>
+                <a:cs typeface="Calibri" pitchFamily="34" charset="-120"/>
+              </a:rPr>
+              <a:t>Join from any phone; runs on Jitsi in the browser</a:t>
+            </a:r>
+            <a:endParaRPr lang="en-US" sz="1350" dirty="0"/>
+          </a:p>
+        </p:txBody>
+      </p:sp>
+      <p:sp>
+        <p:nvSpPr>
+          <p:cNvPr id="7" name="Shape 5"/>
+          <p:cNvSpPr/>
+          <p:nvPr/>
+        </p:nvSpPr>
+        <p:spPr>
+          <a:xfrm>
+            <a:off x="6172200" y="1554480"/>
+            <a:ext cx="5440680" cy="3063240"/>
           </a:xfrm>
           <a:prstGeom prst="roundRect">
             <a:avLst>
-              <a:gd name="adj" fmla="val 6957"/>
+              <a:gd name="adj" fmla="val 2388"/>
             </a:avLst>
           </a:prstGeom>
           <a:solidFill>
-            <a:srgbClr val="F1F5F3"/>
+            <a:srgbClr val="0F2A20"/>
           </a:solidFill>
           <a:ln w="9525">
             <a:solidFill>
@@ -6587,159 +7247,146 @@
       </p:sp>
       <p:sp>
         <p:nvSpPr>
+          <p:cNvPr id="8" name="Text 6"/>
+          <p:cNvSpPr/>
+          <p:nvPr/>
+        </p:nvSpPr>
+        <p:spPr>
+          <a:xfrm>
+            <a:off x="6446520" y="1783080"/>
+            <a:ext cx="4937760" cy="411480"/>
+          </a:xfrm>
+          <a:prstGeom prst="rect">
+            <a:avLst/>
+          </a:prstGeom>
+          <a:noFill/>
+          <a:ln/>
+        </p:spPr>
+        <p:txBody>
+          <a:bodyPr wrap="square" lIns="0" tIns="0" rIns="0" bIns="0" rtlCol="0" anchor="ctr"/>
+          <a:lstStyle/>
+          <a:p>
+            <a:pPr indent="0" marL="0">
+              <a:buNone/>
+            </a:pPr>
+            <a:r>
+              <a:rPr lang="en-US" sz="1700" b="1" dirty="0">
+                <a:solidFill>
+                  <a:srgbClr val="62C79B"/>
+                </a:solidFill>
+                <a:latin typeface="Calibri" pitchFamily="34" charset="0"/>
+                <a:ea typeface="Calibri" pitchFamily="34" charset="-122"/>
+                <a:cs typeface="Calibri" pitchFamily="34" charset="-120"/>
+              </a:rPr>
+              <a:t>Minutes in minutes, not weeks</a:t>
+            </a:r>
+            <a:endParaRPr lang="en-US" sz="1700" dirty="0"/>
+          </a:p>
+        </p:txBody>
+      </p:sp>
+      <p:sp>
+        <p:nvSpPr>
+          <p:cNvPr id="9" name="Text 7"/>
+          <p:cNvSpPr/>
+          <p:nvPr/>
+        </p:nvSpPr>
+        <p:spPr>
+          <a:xfrm>
+            <a:off x="6537960" y="2240280"/>
+            <a:ext cx="4937760" cy="2286000"/>
+          </a:xfrm>
+          <a:prstGeom prst="rect">
+            <a:avLst/>
+          </a:prstGeom>
+          <a:noFill/>
+          <a:ln/>
+        </p:spPr>
+        <p:txBody>
+          <a:bodyPr wrap="square" lIns="0" tIns="0" rIns="0" bIns="0" rtlCol="0" anchor="ctr"/>
+          <a:lstStyle/>
+          <a:p>
+            <a:pPr marL="203200" indent="-203200">
+              <a:spcAft>
+                <a:spcPts val="1100"/>
+              </a:spcAft>
+              <a:buSzPct val="100000"/>
+              <a:buChar char="•"/>
+            </a:pPr>
+            <a:r>
+              <a:rPr lang="en-US" sz="1350" dirty="0">
+                <a:solidFill>
+                  <a:srgbClr val="E7F0EA"/>
+                </a:solidFill>
+                <a:latin typeface="Calibri" pitchFamily="34" charset="0"/>
+                <a:ea typeface="Calibri" pitchFamily="34" charset="-122"/>
+                <a:cs typeface="Calibri" pitchFamily="34" charset="-120"/>
+              </a:rPr>
+              <a:t>Capture decisions &amp; action items live — even by voice dictation</a:t>
+            </a:r>
+            <a:endParaRPr lang="en-US" sz="1350" dirty="0"/>
+          </a:p>
+          <a:p>
+            <a:pPr marL="203200" indent="-203200">
+              <a:spcAft>
+                <a:spcPts val="1100"/>
+              </a:spcAft>
+              <a:buSzPct val="100000"/>
+              <a:buChar char="•"/>
+            </a:pPr>
+            <a:r>
+              <a:rPr lang="en-US" sz="1350" dirty="0">
+                <a:solidFill>
+                  <a:srgbClr val="E7F0EA"/>
+                </a:solidFill>
+                <a:latin typeface="Calibri" pitchFamily="34" charset="0"/>
+                <a:ea typeface="Calibri" pitchFamily="34" charset="-122"/>
+                <a:cs typeface="Calibri" pitchFamily="34" charset="-120"/>
+              </a:rPr>
+              <a:t>Generate a formatted PDF and share it before anyone leaves the call</a:t>
+            </a:r>
+            <a:endParaRPr lang="en-US" sz="1350" dirty="0"/>
+          </a:p>
+          <a:p>
+            <a:pPr marL="203200" indent="-203200">
+              <a:spcAft>
+                <a:spcPts val="1100"/>
+              </a:spcAft>
+              <a:buSzPct val="100000"/>
+              <a:buChar char="•"/>
+            </a:pPr>
+            <a:r>
+              <a:rPr lang="en-US" sz="1350" dirty="0">
+                <a:solidFill>
+                  <a:srgbClr val="E7F0EA"/>
+                </a:solidFill>
+                <a:latin typeface="Calibri" pitchFamily="34" charset="0"/>
+                <a:ea typeface="Calibri" pitchFamily="34" charset="-122"/>
+                <a:cs typeface="Calibri" pitchFamily="34" charset="-120"/>
+              </a:rPr>
+              <a:t>Optionally record the session where your server allows</a:t>
+            </a:r>
+            <a:endParaRPr lang="en-US" sz="1350" dirty="0"/>
+          </a:p>
+        </p:txBody>
+      </p:sp>
+      <p:sp>
+        <p:nvSpPr>
           <p:cNvPr id="10" name="Shape 8"/>
           <p:cNvSpPr/>
           <p:nvPr/>
         </p:nvSpPr>
         <p:spPr>
           <a:xfrm>
-            <a:off x="749808" y="2944368"/>
-            <a:ext cx="457200" cy="457200"/>
-          </a:xfrm>
-          <a:prstGeom prst="ellipse">
-            <a:avLst/>
-          </a:prstGeom>
-          <a:solidFill>
-            <a:srgbClr val="1B6B4A"/>
-          </a:solidFill>
-          <a:ln/>
-        </p:spPr>
-      </p:sp>
-      <p:sp>
-        <p:nvSpPr>
-          <p:cNvPr id="11" name="Text 9"/>
-          <p:cNvSpPr/>
-          <p:nvPr/>
-        </p:nvSpPr>
-        <p:spPr>
-          <a:xfrm>
-            <a:off x="749808" y="2944368"/>
-            <a:ext cx="457200" cy="457200"/>
-          </a:xfrm>
-          <a:prstGeom prst="rect">
-            <a:avLst/>
-          </a:prstGeom>
-          <a:noFill/>
-          <a:ln/>
-        </p:spPr>
-        <p:txBody>
-          <a:bodyPr wrap="square" lIns="0" tIns="0" rIns="0" bIns="0" rtlCol="0" anchor="ctr"/>
-          <a:lstStyle/>
-          <a:p>
-            <a:pPr algn="ctr" indent="0" marL="0">
-              <a:buNone/>
-            </a:pPr>
-            <a:r>
-              <a:rPr lang="en-US" sz="1500" b="1" dirty="0">
-                <a:solidFill>
-                  <a:srgbClr val="FFFFFF"/>
-                </a:solidFill>
-                <a:latin typeface="Calibri" pitchFamily="34" charset="0"/>
-                <a:ea typeface="Calibri" pitchFamily="34" charset="-122"/>
-                <a:cs typeface="Calibri" pitchFamily="34" charset="-120"/>
-              </a:rPr>
-              <a:t>✓</a:t>
-            </a:r>
-            <a:endParaRPr lang="en-US" sz="1500" dirty="0"/>
-          </a:p>
-        </p:txBody>
-      </p:sp>
-      <p:sp>
-        <p:nvSpPr>
-          <p:cNvPr id="12" name="Text 10"/>
-          <p:cNvSpPr/>
-          <p:nvPr/>
-        </p:nvSpPr>
-        <p:spPr>
-          <a:xfrm>
-            <a:off x="1371600" y="2871216"/>
-            <a:ext cx="10104120" cy="310896"/>
-          </a:xfrm>
-          <a:prstGeom prst="rect">
-            <a:avLst/>
-          </a:prstGeom>
-          <a:noFill/>
-          <a:ln/>
-        </p:spPr>
-        <p:txBody>
-          <a:bodyPr wrap="square" lIns="0" tIns="0" rIns="0" bIns="0" rtlCol="0" anchor="ctr"/>
-          <a:lstStyle/>
-          <a:p>
-            <a:pPr indent="0" marL="0">
-              <a:buNone/>
-            </a:pPr>
-            <a:r>
-              <a:rPr lang="en-US" sz="1400" b="1" dirty="0">
-                <a:solidFill>
-                  <a:srgbClr val="1D2621"/>
-                </a:solidFill>
-                <a:latin typeface="Calibri" pitchFamily="34" charset="0"/>
-                <a:ea typeface="Calibri" pitchFamily="34" charset="-122"/>
-                <a:cs typeface="Calibri" pitchFamily="34" charset="-120"/>
-              </a:rPr>
-              <a:t>Find the gaps</a:t>
-            </a:r>
-            <a:endParaRPr lang="en-US" sz="1400" dirty="0"/>
-          </a:p>
-        </p:txBody>
-      </p:sp>
-      <p:sp>
-        <p:nvSpPr>
-          <p:cNvPr id="13" name="Text 11"/>
-          <p:cNvSpPr/>
-          <p:nvPr/>
-        </p:nvSpPr>
-        <p:spPr>
-          <a:xfrm>
-            <a:off x="1371600" y="3182112"/>
-            <a:ext cx="10104120" cy="502920"/>
-          </a:xfrm>
-          <a:prstGeom prst="rect">
-            <a:avLst/>
-          </a:prstGeom>
-          <a:noFill/>
-          <a:ln/>
-        </p:spPr>
-        <p:txBody>
-          <a:bodyPr wrap="square" lIns="0" tIns="0" rIns="0" bIns="0" rtlCol="0" anchor="t"/>
-          <a:lstStyle/>
-          <a:p>
-            <a:pPr indent="0" marL="0">
-              <a:buNone/>
-            </a:pPr>
-            <a:r>
-              <a:rPr lang="en-US" sz="1150" dirty="0">
-                <a:solidFill>
-                  <a:srgbClr val="5D6B63"/>
-                </a:solidFill>
-                <a:latin typeface="Calibri" pitchFamily="34" charset="0"/>
-                <a:ea typeface="Calibri" pitchFamily="34" charset="-122"/>
-                <a:cs typeface="Calibri" pitchFamily="34" charset="-120"/>
-              </a:rPr>
-              <a:t>A ranking that shows exactly where a marginal effort or grant counts most.</a:t>
-            </a:r>
-            <a:endParaRPr lang="en-US" sz="1150" dirty="0"/>
-          </a:p>
-        </p:txBody>
-      </p:sp>
-      <p:sp>
-        <p:nvSpPr>
-          <p:cNvPr id="14" name="Shape 12"/>
-          <p:cNvSpPr/>
-          <p:nvPr/>
-        </p:nvSpPr>
-        <p:spPr>
-          <a:xfrm>
-            <a:off x="548640" y="3895344"/>
-            <a:ext cx="11064240" cy="1051560"/>
+            <a:off x="548640" y="4892040"/>
+            <a:ext cx="3200400" cy="1371600"/>
           </a:xfrm>
           <a:prstGeom prst="roundRect">
             <a:avLst>
-              <a:gd name="adj" fmla="val 6957"/>
+              <a:gd name="adj" fmla="val 5333"/>
             </a:avLst>
           </a:prstGeom>
           <a:solidFill>
-            <a:srgbClr val="F1F5F3"/>
+            <a:srgbClr val="FFFFFF"/>
           </a:solidFill>
           <a:ln w="9525">
             <a:solidFill>
@@ -6758,34 +7405,14 @@
       </p:sp>
       <p:sp>
         <p:nvSpPr>
-          <p:cNvPr id="15" name="Shape 13"/>
-          <p:cNvSpPr/>
-          <p:nvPr/>
-        </p:nvSpPr>
-        <p:spPr>
-          <a:xfrm>
-            <a:off x="749808" y="4114800"/>
-            <a:ext cx="457200" cy="457200"/>
-          </a:xfrm>
-          <a:prstGeom prst="ellipse">
-            <a:avLst/>
-          </a:prstGeom>
-          <a:solidFill>
-            <a:srgbClr val="1B6B4A"/>
-          </a:solidFill>
-          <a:ln/>
-        </p:spPr>
-      </p:sp>
-      <p:sp>
-        <p:nvSpPr>
-          <p:cNvPr id="16" name="Text 14"/>
-          <p:cNvSpPr/>
-          <p:nvPr/>
-        </p:nvSpPr>
-        <p:spPr>
-          <a:xfrm>
-            <a:off x="749808" y="4114800"/>
-            <a:ext cx="457200" cy="457200"/>
+          <p:cNvPr id="11" name="Text 9"/>
+          <p:cNvSpPr/>
+          <p:nvPr/>
+        </p:nvSpPr>
+        <p:spPr>
+          <a:xfrm>
+            <a:off x="548640" y="5029200"/>
+            <a:ext cx="3200400" cy="548640"/>
           </a:xfrm>
           <a:prstGeom prst="rect">
             <a:avLst/>
@@ -6801,30 +7428,69 @@
               <a:buNone/>
             </a:pPr>
             <a:r>
-              <a:rPr lang="en-US" sz="1500" b="1" dirty="0">
-                <a:solidFill>
-                  <a:srgbClr val="FFFFFF"/>
-                </a:solidFill>
-                <a:latin typeface="Calibri" pitchFamily="34" charset="0"/>
-                <a:ea typeface="Calibri" pitchFamily="34" charset="-122"/>
-                <a:cs typeface="Calibri" pitchFamily="34" charset="-120"/>
-              </a:rPr>
-              <a:t>✓</a:t>
-            </a:r>
-            <a:endParaRPr lang="en-US" sz="1500" dirty="0"/>
-          </a:p>
-        </p:txBody>
-      </p:sp>
-      <p:sp>
-        <p:nvSpPr>
-          <p:cNvPr id="17" name="Text 15"/>
-          <p:cNvSpPr/>
-          <p:nvPr/>
-        </p:nvSpPr>
-        <p:spPr>
-          <a:xfrm>
-            <a:off x="1371600" y="4041648"/>
-            <a:ext cx="10104120" cy="310896"/>
+              <a:rPr lang="en-US" sz="2300" b="1" dirty="0">
+                <a:solidFill>
+                  <a:srgbClr val="EE9455"/>
+                </a:solidFill>
+                <a:latin typeface="Cambria" pitchFamily="34" charset="0"/>
+                <a:ea typeface="Cambria" pitchFamily="34" charset="-122"/>
+                <a:cs typeface="Cambria" pitchFamily="34" charset="-120"/>
+              </a:rPr>
+              <a:t>3 weeks → 3 min</a:t>
+            </a:r>
+            <a:endParaRPr lang="en-US" sz="2300" dirty="0"/>
+          </a:p>
+        </p:txBody>
+      </p:sp>
+      <p:sp>
+        <p:nvSpPr>
+          <p:cNvPr id="12" name="Text 10"/>
+          <p:cNvSpPr/>
+          <p:nvPr/>
+        </p:nvSpPr>
+        <p:spPr>
+          <a:xfrm>
+            <a:off x="548640" y="5596128"/>
+            <a:ext cx="3200400" cy="457200"/>
+          </a:xfrm>
+          <a:prstGeom prst="rect">
+            <a:avLst/>
+          </a:prstGeom>
+          <a:noFill/>
+          <a:ln/>
+        </p:spPr>
+        <p:txBody>
+          <a:bodyPr wrap="square" lIns="0" tIns="0" rIns="0" bIns="0" rtlCol="0" anchor="ctr"/>
+          <a:lstStyle/>
+          <a:p>
+            <a:pPr algn="ctr" indent="0" marL="0">
+              <a:buNone/>
+            </a:pPr>
+            <a:r>
+              <a:rPr lang="en-US" sz="1100" dirty="0">
+                <a:solidFill>
+                  <a:srgbClr val="5D6B63"/>
+                </a:solidFill>
+                <a:latin typeface="Calibri" pitchFamily="34" charset="0"/>
+                <a:ea typeface="Calibri" pitchFamily="34" charset="-122"/>
+                <a:cs typeface="Calibri" pitchFamily="34" charset="-120"/>
+              </a:rPr>
+              <a:t>from meeting to shared minutes</a:t>
+            </a:r>
+            <a:endParaRPr lang="en-US" sz="1100" dirty="0"/>
+          </a:p>
+        </p:txBody>
+      </p:sp>
+      <p:sp>
+        <p:nvSpPr>
+          <p:cNvPr id="13" name="Text 11"/>
+          <p:cNvSpPr/>
+          <p:nvPr/>
+        </p:nvSpPr>
+        <p:spPr>
+          <a:xfrm>
+            <a:off x="3977640" y="4892040"/>
+            <a:ext cx="7635240" cy="1371600"/>
           </a:xfrm>
           <a:prstGeom prst="rect">
             <a:avLst/>
@@ -6840,7 +7506,7 @@
               <a:buNone/>
             </a:pPr>
             <a:r>
-              <a:rPr lang="en-US" sz="1400" b="1" dirty="0">
+              <a:rPr lang="en-US" sz="1350" dirty="0">
                 <a:solidFill>
                   <a:srgbClr val="1D2621"/>
                 </a:solidFill>
@@ -6848,225 +7514,15 @@
                 <a:ea typeface="Calibri" pitchFamily="34" charset="-122"/>
                 <a:cs typeface="Calibri" pitchFamily="34" charset="-120"/>
               </a:rPr>
-              <a:t>Coordinate &amp; convene</a:t>
-            </a:r>
-            <a:endParaRPr lang="en-US" sz="1400" dirty="0"/>
-          </a:p>
-        </p:txBody>
-      </p:sp>
-      <p:sp>
-        <p:nvSpPr>
-          <p:cNvPr id="18" name="Text 16"/>
-          <p:cNvSpPr/>
-          <p:nvPr/>
-        </p:nvSpPr>
-        <p:spPr>
-          <a:xfrm>
-            <a:off x="1371600" y="4352544"/>
-            <a:ext cx="10104120" cy="502920"/>
-          </a:xfrm>
-          <a:prstGeom prst="rect">
-            <a:avLst/>
-          </a:prstGeom>
-          <a:noFill/>
-          <a:ln/>
-        </p:spPr>
-        <p:txBody>
-          <a:bodyPr wrap="square" lIns="0" tIns="0" rIns="0" bIns="0" rtlCol="0" anchor="t"/>
-          <a:lstStyle/>
-          <a:p>
-            <a:pPr indent="0" marL="0">
-              <a:buNone/>
-            </a:pPr>
-            <a:r>
-              <a:rPr lang="en-US" sz="1150" dirty="0">
-                <a:solidFill>
-                  <a:srgbClr val="5D6B63"/>
-                </a:solidFill>
-                <a:latin typeface="Calibri" pitchFamily="34" charset="0"/>
-                <a:ea typeface="Calibri" pitchFamily="34" charset="-122"/>
-                <a:cs typeface="Calibri" pitchFamily="34" charset="-120"/>
-              </a:rPr>
-              <a:t>Directory, resource exchange and one-click video calls keep the coalition moving together.</a:t>
-            </a:r>
-            <a:endParaRPr lang="en-US" sz="1150" dirty="0"/>
-          </a:p>
-        </p:txBody>
-      </p:sp>
-      <p:sp>
-        <p:nvSpPr>
-          <p:cNvPr id="19" name="Shape 17"/>
-          <p:cNvSpPr/>
-          <p:nvPr/>
-        </p:nvSpPr>
-        <p:spPr>
-          <a:xfrm>
-            <a:off x="548640" y="5065776"/>
-            <a:ext cx="11064240" cy="1051560"/>
-          </a:xfrm>
-          <a:prstGeom prst="roundRect">
-            <a:avLst>
-              <a:gd name="adj" fmla="val 6957"/>
-            </a:avLst>
-          </a:prstGeom>
-          <a:solidFill>
-            <a:srgbClr val="F1F5F3"/>
-          </a:solidFill>
-          <a:ln w="9525">
-            <a:solidFill>
-              <a:srgbClr val="D9E2DC"/>
-            </a:solidFill>
-            <a:prstDash val="solid"/>
-          </a:ln>
-          <a:effectLst>
-            <a:outerShdw sx="100000" sy="100000" kx="0" ky="0" algn="bl" rotWithShape="0" blurRad="76200" dist="25400" dir="5400000">
-              <a:srgbClr val="9AA8A0">
-                <a:alpha val="35000"/>
-              </a:srgbClr>
-            </a:outerShdw>
-          </a:effectLst>
-        </p:spPr>
-      </p:sp>
-      <p:sp>
-        <p:nvSpPr>
-          <p:cNvPr id="20" name="Shape 18"/>
-          <p:cNvSpPr/>
-          <p:nvPr/>
-        </p:nvSpPr>
-        <p:spPr>
-          <a:xfrm>
-            <a:off x="749808" y="5285232"/>
-            <a:ext cx="457200" cy="457200"/>
-          </a:xfrm>
-          <a:prstGeom prst="ellipse">
-            <a:avLst/>
-          </a:prstGeom>
-          <a:solidFill>
-            <a:srgbClr val="1B6B4A"/>
-          </a:solidFill>
-          <a:ln/>
-        </p:spPr>
-      </p:sp>
-      <p:sp>
-        <p:nvSpPr>
-          <p:cNvPr id="21" name="Text 19"/>
-          <p:cNvSpPr/>
-          <p:nvPr/>
-        </p:nvSpPr>
-        <p:spPr>
-          <a:xfrm>
-            <a:off x="749808" y="5285232"/>
-            <a:ext cx="457200" cy="457200"/>
-          </a:xfrm>
-          <a:prstGeom prst="rect">
-            <a:avLst/>
-          </a:prstGeom>
-          <a:noFill/>
-          <a:ln/>
-        </p:spPr>
-        <p:txBody>
-          <a:bodyPr wrap="square" lIns="0" tIns="0" rIns="0" bIns="0" rtlCol="0" anchor="ctr"/>
-          <a:lstStyle/>
-          <a:p>
-            <a:pPr algn="ctr" indent="0" marL="0">
-              <a:buNone/>
-            </a:pPr>
-            <a:r>
-              <a:rPr lang="en-US" sz="1500" b="1" dirty="0">
-                <a:solidFill>
-                  <a:srgbClr val="FFFFFF"/>
-                </a:solidFill>
-                <a:latin typeface="Calibri" pitchFamily="34" charset="0"/>
-                <a:ea typeface="Calibri" pitchFamily="34" charset="-122"/>
-                <a:cs typeface="Calibri" pitchFamily="34" charset="-120"/>
-              </a:rPr>
-              <a:t>✓</a:t>
-            </a:r>
-            <a:endParaRPr lang="en-US" sz="1500" dirty="0"/>
-          </a:p>
-        </p:txBody>
-      </p:sp>
-      <p:sp>
-        <p:nvSpPr>
-          <p:cNvPr id="22" name="Text 20"/>
-          <p:cNvSpPr/>
-          <p:nvPr/>
-        </p:nvSpPr>
-        <p:spPr>
-          <a:xfrm>
-            <a:off x="1371600" y="5212080"/>
-            <a:ext cx="10104120" cy="310896"/>
-          </a:xfrm>
-          <a:prstGeom prst="rect">
-            <a:avLst/>
-          </a:prstGeom>
-          <a:noFill/>
-          <a:ln/>
-        </p:spPr>
-        <p:txBody>
-          <a:bodyPr wrap="square" lIns="0" tIns="0" rIns="0" bIns="0" rtlCol="0" anchor="ctr"/>
-          <a:lstStyle/>
-          <a:p>
-            <a:pPr indent="0" marL="0">
-              <a:buNone/>
-            </a:pPr>
-            <a:r>
-              <a:rPr lang="en-US" sz="1400" b="1" dirty="0">
-                <a:solidFill>
-                  <a:srgbClr val="1D2621"/>
-                </a:solidFill>
-                <a:latin typeface="Calibri" pitchFamily="34" charset="0"/>
-                <a:ea typeface="Calibri" pitchFamily="34" charset="-122"/>
-                <a:cs typeface="Calibri" pitchFamily="34" charset="-120"/>
-              </a:rPr>
-              <a:t>Amplify &amp; mobilise</a:t>
-            </a:r>
-            <a:endParaRPr lang="en-US" sz="1400" dirty="0"/>
-          </a:p>
-        </p:txBody>
-      </p:sp>
-      <p:sp>
-        <p:nvSpPr>
-          <p:cNvPr id="23" name="Text 21"/>
-          <p:cNvSpPr/>
-          <p:nvPr/>
-        </p:nvSpPr>
-        <p:spPr>
-          <a:xfrm>
-            <a:off x="1371600" y="5522976"/>
-            <a:ext cx="10104120" cy="502920"/>
-          </a:xfrm>
-          <a:prstGeom prst="rect">
-            <a:avLst/>
-          </a:prstGeom>
-          <a:noFill/>
-          <a:ln/>
-        </p:spPr>
-        <p:txBody>
-          <a:bodyPr wrap="square" lIns="0" tIns="0" rIns="0" bIns="0" rtlCol="0" anchor="t"/>
-          <a:lstStyle/>
-          <a:p>
-            <a:pPr indent="0" marL="0">
-              <a:buNone/>
-            </a:pPr>
-            <a:r>
-              <a:rPr lang="en-US" sz="1150" dirty="0">
-                <a:solidFill>
-                  <a:srgbClr val="5D6B63"/>
-                </a:solidFill>
-                <a:latin typeface="Calibri" pitchFamily="34" charset="0"/>
-                <a:ea typeface="Calibri" pitchFamily="34" charset="-122"/>
-                <a:cs typeface="Calibri" pitchFamily="34" charset="-120"/>
-              </a:rPr>
-              <a:t>Petitions, public debunks and social sharing turn evidence into pressure.</a:t>
-            </a:r>
-            <a:endParaRPr lang="en-US" sz="1150" dirty="0"/>
-          </a:p>
-        </p:txBody>
-      </p:sp>
-      <p:sp>
-        <p:nvSpPr>
-          <p:cNvPr id="24" name="Text 22"/>
+              <a:t>The sector's quiet failure is minutes that arrive weeks late, with no clear action. The Coalition Room turns every call into a decision record and a next step — instantly — which is exactly why partners will convene here.</a:t>
+            </a:r>
+            <a:endParaRPr lang="en-US" sz="1350" dirty="0"/>
+          </a:p>
+        </p:txBody>
+      </p:sp>
+      <p:sp>
+        <p:nvSpPr>
+          <p:cNvPr id="14" name="Text 12"/>
           <p:cNvSpPr/>
           <p:nvPr/>
         </p:nvSpPr>
@@ -7097,7 +7553,7 @@
                 <a:ea typeface="Calibri" pitchFamily="34" charset="-122"/>
                 <a:cs typeface="Calibri" pitchFamily="34" charset="-120"/>
               </a:rPr>
-              <a:t>MazingiraKenya · Partner prospectus</a:t>
+              <a:t>MazingiraKenya</a:t>
             </a:r>
             <a:endParaRPr lang="en-US" sz="900" dirty="0"/>
           </a:p>
@@ -7168,7 +7624,7 @@
                 <a:ea typeface="Calibri" pitchFamily="34" charset="-122"/>
                 <a:cs typeface="Calibri" pitchFamily="34" charset="-120"/>
               </a:rPr>
-              <a:t>BUILT FOR HOW YOU WORK</a:t>
+              <a:t>WHY IT'S USEFUL</a:t>
             </a:r>
             <a:endParaRPr lang="en-US" sz="1200" dirty="0"/>
           </a:p>
@@ -7207,7 +7663,7 @@
                 <a:ea typeface="Cambria" pitchFamily="34" charset="-122"/>
                 <a:cs typeface="Cambria" pitchFamily="34" charset="-120"/>
               </a:rPr>
-              <a:t>No friction, no training, no app store</a:t>
+              <a:t>From information to leverage</a:t>
             </a:r>
             <a:endParaRPr lang="en-US" sz="3000" dirty="0"/>
           </a:p>
@@ -7221,12 +7677,12 @@
         </p:nvSpPr>
         <p:spPr>
           <a:xfrm>
-            <a:off x="548640" y="1600200"/>
-            <a:ext cx="3566160" cy="1600200"/>
+            <a:off x="548640" y="1554480"/>
+            <a:ext cx="11064240" cy="1051560"/>
           </a:xfrm>
           <a:prstGeom prst="roundRect">
             <a:avLst>
-              <a:gd name="adj" fmla="val 4571"/>
+              <a:gd name="adj" fmla="val 6957"/>
             </a:avLst>
           </a:prstGeom>
           <a:solidFill>
@@ -7255,14 +7711,14 @@
         </p:nvSpPr>
         <p:spPr>
           <a:xfrm>
-            <a:off x="749808" y="1819656"/>
+            <a:off x="749808" y="1773936"/>
             <a:ext cx="457200" cy="457200"/>
           </a:xfrm>
           <a:prstGeom prst="ellipse">
             <a:avLst/>
           </a:prstGeom>
           <a:solidFill>
-            <a:srgbClr val="EE9455"/>
+            <a:srgbClr val="1B6B4A"/>
           </a:solidFill>
           <a:ln/>
         </p:spPr>
@@ -7275,7 +7731,7 @@
         </p:nvSpPr>
         <p:spPr>
           <a:xfrm>
-            <a:off x="749808" y="1819656"/>
+            <a:off x="749808" y="1773936"/>
             <a:ext cx="457200" cy="457200"/>
           </a:xfrm>
           <a:prstGeom prst="rect">
@@ -7300,7 +7756,7 @@
                 <a:ea typeface="Calibri" pitchFamily="34" charset="-122"/>
                 <a:cs typeface="Calibri" pitchFamily="34" charset="-120"/>
               </a:rPr>
-              <a:t>★</a:t>
+              <a:t>✓</a:t>
             </a:r>
             <a:endParaRPr lang="en-US" sz="1500" dirty="0"/>
           </a:p>
@@ -7314,8 +7770,8 @@
         </p:nvSpPr>
         <p:spPr>
           <a:xfrm>
-            <a:off x="1371600" y="1746504"/>
-            <a:ext cx="2606040" cy="310896"/>
+            <a:off x="1371600" y="1700784"/>
+            <a:ext cx="10104120" cy="310896"/>
           </a:xfrm>
           <a:prstGeom prst="rect">
             <a:avLst/>
@@ -7339,7 +7795,7 @@
                 <a:ea typeface="Calibri" pitchFamily="34" charset="-122"/>
                 <a:cs typeface="Calibri" pitchFamily="34" charset="-120"/>
               </a:rPr>
-              <a:t>Any phone</a:t>
+              <a:t>See the whole board</a:t>
             </a:r>
             <a:endParaRPr lang="en-US" sz="1400" dirty="0"/>
           </a:p>
@@ -7353,8 +7809,8 @@
         </p:nvSpPr>
         <p:spPr>
           <a:xfrm>
-            <a:off x="1371600" y="2057400"/>
-            <a:ext cx="2606040" cy="1051560"/>
+            <a:off x="1371600" y="2011680"/>
+            <a:ext cx="10104120" cy="502920"/>
           </a:xfrm>
           <a:prstGeom prst="rect">
             <a:avLst/>
@@ -7378,7 +7834,7 @@
                 <a:ea typeface="Calibri" pitchFamily="34" charset="-122"/>
                 <a:cs typeface="Calibri" pitchFamily="34" charset="-120"/>
               </a:rPr>
-              <a:t>Installs like an app from the browser — a Progressive Web App, works on modest devices</a:t>
+              <a:t>Every pressure and every responder in one view — the picture no single org holds.</a:t>
             </a:r>
             <a:endParaRPr lang="en-US" sz="1150" dirty="0"/>
           </a:p>
@@ -7392,12 +7848,12 @@
         </p:nvSpPr>
         <p:spPr>
           <a:xfrm>
-            <a:off x="4261104" y="1600200"/>
-            <a:ext cx="3566160" cy="1600200"/>
+            <a:off x="548640" y="2724912"/>
+            <a:ext cx="11064240" cy="1051560"/>
           </a:xfrm>
           <a:prstGeom prst="roundRect">
             <a:avLst>
-              <a:gd name="adj" fmla="val 4571"/>
+              <a:gd name="adj" fmla="val 6957"/>
             </a:avLst>
           </a:prstGeom>
           <a:solidFill>
@@ -7426,14 +7882,14 @@
         </p:nvSpPr>
         <p:spPr>
           <a:xfrm>
-            <a:off x="4462272" y="1819656"/>
+            <a:off x="749808" y="2944368"/>
             <a:ext cx="457200" cy="457200"/>
           </a:xfrm>
           <a:prstGeom prst="ellipse">
             <a:avLst/>
           </a:prstGeom>
           <a:solidFill>
-            <a:srgbClr val="EE9455"/>
+            <a:srgbClr val="1B6B4A"/>
           </a:solidFill>
           <a:ln/>
         </p:spPr>
@@ -7446,7 +7902,7 @@
         </p:nvSpPr>
         <p:spPr>
           <a:xfrm>
-            <a:off x="4462272" y="1819656"/>
+            <a:off x="749808" y="2944368"/>
             <a:ext cx="457200" cy="457200"/>
           </a:xfrm>
           <a:prstGeom prst="rect">
@@ -7471,7 +7927,7 @@
                 <a:ea typeface="Calibri" pitchFamily="34" charset="-122"/>
                 <a:cs typeface="Calibri" pitchFamily="34" charset="-120"/>
               </a:rPr>
-              <a:t>★</a:t>
+              <a:t>✓</a:t>
             </a:r>
             <a:endParaRPr lang="en-US" sz="1500" dirty="0"/>
           </a:p>
@@ -7485,8 +7941,8 @@
         </p:nvSpPr>
         <p:spPr>
           <a:xfrm>
-            <a:off x="5084064" y="1746504"/>
-            <a:ext cx="2606040" cy="310896"/>
+            <a:off x="1371600" y="2871216"/>
+            <a:ext cx="10104120" cy="310896"/>
           </a:xfrm>
           <a:prstGeom prst="rect">
             <a:avLst/>
@@ -7510,7 +7966,7 @@
                 <a:ea typeface="Calibri" pitchFamily="34" charset="-122"/>
                 <a:cs typeface="Calibri" pitchFamily="34" charset="-120"/>
               </a:rPr>
-              <a:t>Works offline</a:t>
+              <a:t>Find the gaps</a:t>
             </a:r>
             <a:endParaRPr lang="en-US" sz="1400" dirty="0"/>
           </a:p>
@@ -7524,8 +7980,8 @@
         </p:nvSpPr>
         <p:spPr>
           <a:xfrm>
-            <a:off x="5084064" y="2057400"/>
-            <a:ext cx="2606040" cy="1051560"/>
+            <a:off x="1371600" y="3182112"/>
+            <a:ext cx="10104120" cy="502920"/>
           </a:xfrm>
           <a:prstGeom prst="rect">
             <a:avLst/>
@@ -7549,7 +8005,7 @@
                 <a:ea typeface="Calibri" pitchFamily="34" charset="-122"/>
                 <a:cs typeface="Calibri" pitchFamily="34" charset="-120"/>
               </a:rPr>
-              <a:t>Caches so it opens fast and keeps working on a weak connection</a:t>
+              <a:t>A ranking that shows exactly where a marginal effort or grant counts most.</a:t>
             </a:r>
             <a:endParaRPr lang="en-US" sz="1150" dirty="0"/>
           </a:p>
@@ -7563,12 +8019,12 @@
         </p:nvSpPr>
         <p:spPr>
           <a:xfrm>
-            <a:off x="7973568" y="1600200"/>
-            <a:ext cx="3566160" cy="1600200"/>
+            <a:off x="548640" y="3895344"/>
+            <a:ext cx="11064240" cy="1051560"/>
           </a:xfrm>
           <a:prstGeom prst="roundRect">
             <a:avLst>
-              <a:gd name="adj" fmla="val 4571"/>
+              <a:gd name="adj" fmla="val 6957"/>
             </a:avLst>
           </a:prstGeom>
           <a:solidFill>
@@ -7597,14 +8053,14 @@
         </p:nvSpPr>
         <p:spPr>
           <a:xfrm>
-            <a:off x="8174736" y="1819656"/>
+            <a:off x="749808" y="4114800"/>
             <a:ext cx="457200" cy="457200"/>
           </a:xfrm>
           <a:prstGeom prst="ellipse">
             <a:avLst/>
           </a:prstGeom>
           <a:solidFill>
-            <a:srgbClr val="EE9455"/>
+            <a:srgbClr val="1B6B4A"/>
           </a:solidFill>
           <a:ln/>
         </p:spPr>
@@ -7617,7 +8073,7 @@
         </p:nvSpPr>
         <p:spPr>
           <a:xfrm>
-            <a:off x="8174736" y="1819656"/>
+            <a:off x="749808" y="4114800"/>
             <a:ext cx="457200" cy="457200"/>
           </a:xfrm>
           <a:prstGeom prst="rect">
@@ -7642,7 +8098,7 @@
                 <a:ea typeface="Calibri" pitchFamily="34" charset="-122"/>
                 <a:cs typeface="Calibri" pitchFamily="34" charset="-120"/>
               </a:rPr>
-              <a:t>★</a:t>
+              <a:t>✓</a:t>
             </a:r>
             <a:endParaRPr lang="en-US" sz="1500" dirty="0"/>
           </a:p>
@@ -7656,8 +8112,8 @@
         </p:nvSpPr>
         <p:spPr>
           <a:xfrm>
-            <a:off x="8796528" y="1746504"/>
-            <a:ext cx="2606040" cy="310896"/>
+            <a:off x="1371600" y="4041648"/>
+            <a:ext cx="10104120" cy="310896"/>
           </a:xfrm>
           <a:prstGeom prst="rect">
             <a:avLst/>
@@ -7681,7 +8137,7 @@
                 <a:ea typeface="Calibri" pitchFamily="34" charset="-122"/>
                 <a:cs typeface="Calibri" pitchFamily="34" charset="-120"/>
               </a:rPr>
-              <a:t>Three languages</a:t>
+              <a:t>Coordinate &amp; convene</a:t>
             </a:r>
             <a:endParaRPr lang="en-US" sz="1400" dirty="0"/>
           </a:p>
@@ -7695,8 +8151,8 @@
         </p:nvSpPr>
         <p:spPr>
           <a:xfrm>
-            <a:off x="8796528" y="2057400"/>
-            <a:ext cx="2606040" cy="1051560"/>
+            <a:off x="1371600" y="4352544"/>
+            <a:ext cx="10104120" cy="502920"/>
           </a:xfrm>
           <a:prstGeom prst="rect">
             <a:avLst/>
@@ -7720,7 +8176,7 @@
                 <a:ea typeface="Calibri" pitchFamily="34" charset="-122"/>
                 <a:cs typeface="Calibri" pitchFamily="34" charset="-120"/>
               </a:rPr>
-              <a:t>English, Kiswahili and Sheng — meet people where they are</a:t>
+              <a:t>Directory, resource exchange and one-click video calls keep the coalition moving together.</a:t>
             </a:r>
             <a:endParaRPr lang="en-US" sz="1150" dirty="0"/>
           </a:p>
@@ -7734,12 +8190,12 @@
         </p:nvSpPr>
         <p:spPr>
           <a:xfrm>
-            <a:off x="548640" y="3383280"/>
-            <a:ext cx="3566160" cy="1600200"/>
+            <a:off x="548640" y="5065776"/>
+            <a:ext cx="11064240" cy="1051560"/>
           </a:xfrm>
           <a:prstGeom prst="roundRect">
             <a:avLst>
-              <a:gd name="adj" fmla="val 4571"/>
+              <a:gd name="adj" fmla="val 6957"/>
             </a:avLst>
           </a:prstGeom>
           <a:solidFill>
@@ -7768,14 +8224,14 @@
         </p:nvSpPr>
         <p:spPr>
           <a:xfrm>
-            <a:off x="749808" y="3602736"/>
+            <a:off x="749808" y="5285232"/>
             <a:ext cx="457200" cy="457200"/>
           </a:xfrm>
           <a:prstGeom prst="ellipse">
             <a:avLst/>
           </a:prstGeom>
           <a:solidFill>
-            <a:srgbClr val="EE9455"/>
+            <a:srgbClr val="1B6B4A"/>
           </a:solidFill>
           <a:ln/>
         </p:spPr>
@@ -7788,7 +8244,7 @@
         </p:nvSpPr>
         <p:spPr>
           <a:xfrm>
-            <a:off x="749808" y="3602736"/>
+            <a:off x="749808" y="5285232"/>
             <a:ext cx="457200" cy="457200"/>
           </a:xfrm>
           <a:prstGeom prst="rect">
@@ -7813,7 +8269,7 @@
                 <a:ea typeface="Calibri" pitchFamily="34" charset="-122"/>
                 <a:cs typeface="Calibri" pitchFamily="34" charset="-120"/>
               </a:rPr>
-              <a:t>★</a:t>
+              <a:t>✓</a:t>
             </a:r>
             <a:endParaRPr lang="en-US" sz="1500" dirty="0"/>
           </a:p>
@@ -7827,8 +8283,8 @@
         </p:nvSpPr>
         <p:spPr>
           <a:xfrm>
-            <a:off x="1371600" y="3529584"/>
-            <a:ext cx="2606040" cy="310896"/>
+            <a:off x="1371600" y="5212080"/>
+            <a:ext cx="10104120" cy="310896"/>
           </a:xfrm>
           <a:prstGeom prst="rect">
             <a:avLst/>
@@ -7852,7 +8308,7 @@
                 <a:ea typeface="Calibri" pitchFamily="34" charset="-122"/>
                 <a:cs typeface="Calibri" pitchFamily="34" charset="-120"/>
               </a:rPr>
-              <a:t>Members-only &amp; secure</a:t>
+              <a:t>Amplify &amp; mobilise</a:t>
             </a:r>
             <a:endParaRPr lang="en-US" sz="1400" dirty="0"/>
           </a:p>
@@ -7866,8 +8322,8 @@
         </p:nvSpPr>
         <p:spPr>
           <a:xfrm>
-            <a:off x="1371600" y="3840480"/>
-            <a:ext cx="2606040" cy="1051560"/>
+            <a:off x="1371600" y="5522976"/>
+            <a:ext cx="10104120" cy="502920"/>
           </a:xfrm>
           <a:prstGeom prst="rect">
             <a:avLst/>
@@ -7891,7 +8347,7 @@
                 <a:ea typeface="Calibri" pitchFamily="34" charset="-122"/>
                 <a:cs typeface="Calibri" pitchFamily="34" charset="-120"/>
               </a:rPr>
-              <a:t>Invite-only sign-in; your coordination stays inside the coalition</a:t>
+              <a:t>Petitions, public debunks and social sharing turn evidence into pressure.</a:t>
             </a:r>
             <a:endParaRPr lang="en-US" sz="1150" dirty="0"/>
           </a:p>
@@ -7899,349 +8355,7 @@
       </p:sp>
       <p:sp>
         <p:nvSpPr>
-          <p:cNvPr id="24" name="Shape 22"/>
-          <p:cNvSpPr/>
-          <p:nvPr/>
-        </p:nvSpPr>
-        <p:spPr>
-          <a:xfrm>
-            <a:off x="4261104" y="3383280"/>
-            <a:ext cx="3566160" cy="1600200"/>
-          </a:xfrm>
-          <a:prstGeom prst="roundRect">
-            <a:avLst>
-              <a:gd name="adj" fmla="val 4571"/>
-            </a:avLst>
-          </a:prstGeom>
-          <a:solidFill>
-            <a:srgbClr val="F1F5F3"/>
-          </a:solidFill>
-          <a:ln w="9525">
-            <a:solidFill>
-              <a:srgbClr val="D9E2DC"/>
-            </a:solidFill>
-            <a:prstDash val="solid"/>
-          </a:ln>
-          <a:effectLst>
-            <a:outerShdw sx="100000" sy="100000" kx="0" ky="0" algn="bl" rotWithShape="0" blurRad="76200" dist="25400" dir="5400000">
-              <a:srgbClr val="9AA8A0">
-                <a:alpha val="35000"/>
-              </a:srgbClr>
-            </a:outerShdw>
-          </a:effectLst>
-        </p:spPr>
-      </p:sp>
-      <p:sp>
-        <p:nvSpPr>
-          <p:cNvPr id="25" name="Shape 23"/>
-          <p:cNvSpPr/>
-          <p:nvPr/>
-        </p:nvSpPr>
-        <p:spPr>
-          <a:xfrm>
-            <a:off x="4462272" y="3602736"/>
-            <a:ext cx="457200" cy="457200"/>
-          </a:xfrm>
-          <a:prstGeom prst="ellipse">
-            <a:avLst/>
-          </a:prstGeom>
-          <a:solidFill>
-            <a:srgbClr val="EE9455"/>
-          </a:solidFill>
-          <a:ln/>
-        </p:spPr>
-      </p:sp>
-      <p:sp>
-        <p:nvSpPr>
-          <p:cNvPr id="26" name="Text 24"/>
-          <p:cNvSpPr/>
-          <p:nvPr/>
-        </p:nvSpPr>
-        <p:spPr>
-          <a:xfrm>
-            <a:off x="4462272" y="3602736"/>
-            <a:ext cx="457200" cy="457200"/>
-          </a:xfrm>
-          <a:prstGeom prst="rect">
-            <a:avLst/>
-          </a:prstGeom>
-          <a:noFill/>
-          <a:ln/>
-        </p:spPr>
-        <p:txBody>
-          <a:bodyPr wrap="square" lIns="0" tIns="0" rIns="0" bIns="0" rtlCol="0" anchor="ctr"/>
-          <a:lstStyle/>
-          <a:p>
-            <a:pPr algn="ctr" indent="0" marL="0">
-              <a:buNone/>
-            </a:pPr>
-            <a:r>
-              <a:rPr lang="en-US" sz="1500" b="1" dirty="0">
-                <a:solidFill>
-                  <a:srgbClr val="FFFFFF"/>
-                </a:solidFill>
-                <a:latin typeface="Calibri" pitchFamily="34" charset="0"/>
-                <a:ea typeface="Calibri" pitchFamily="34" charset="-122"/>
-                <a:cs typeface="Calibri" pitchFamily="34" charset="-120"/>
-              </a:rPr>
-              <a:t>★</a:t>
-            </a:r>
-            <a:endParaRPr lang="en-US" sz="1500" dirty="0"/>
-          </a:p>
-        </p:txBody>
-      </p:sp>
-      <p:sp>
-        <p:nvSpPr>
-          <p:cNvPr id="27" name="Text 25"/>
-          <p:cNvSpPr/>
-          <p:nvPr/>
-        </p:nvSpPr>
-        <p:spPr>
-          <a:xfrm>
-            <a:off x="5084064" y="3529584"/>
-            <a:ext cx="2606040" cy="310896"/>
-          </a:xfrm>
-          <a:prstGeom prst="rect">
-            <a:avLst/>
-          </a:prstGeom>
-          <a:noFill/>
-          <a:ln/>
-        </p:spPr>
-        <p:txBody>
-          <a:bodyPr wrap="square" lIns="0" tIns="0" rIns="0" bIns="0" rtlCol="0" anchor="ctr"/>
-          <a:lstStyle/>
-          <a:p>
-            <a:pPr indent="0" marL="0">
-              <a:buNone/>
-            </a:pPr>
-            <a:r>
-              <a:rPr lang="en-US" sz="1400" b="1" dirty="0">
-                <a:solidFill>
-                  <a:srgbClr val="1D2621"/>
-                </a:solidFill>
-                <a:latin typeface="Calibri" pitchFamily="34" charset="0"/>
-                <a:ea typeface="Calibri" pitchFamily="34" charset="-122"/>
-                <a:cs typeface="Calibri" pitchFamily="34" charset="-120"/>
-              </a:rPr>
-              <a:t>One tap in</a:t>
-            </a:r>
-            <a:endParaRPr lang="en-US" sz="1400" dirty="0"/>
-          </a:p>
-        </p:txBody>
-      </p:sp>
-      <p:sp>
-        <p:nvSpPr>
-          <p:cNvPr id="28" name="Text 26"/>
-          <p:cNvSpPr/>
-          <p:nvPr/>
-        </p:nvSpPr>
-        <p:spPr>
-          <a:xfrm>
-            <a:off x="5084064" y="3840480"/>
-            <a:ext cx="2606040" cy="1051560"/>
-          </a:xfrm>
-          <a:prstGeom prst="rect">
-            <a:avLst/>
-          </a:prstGeom>
-          <a:noFill/>
-          <a:ln/>
-        </p:spPr>
-        <p:txBody>
-          <a:bodyPr wrap="square" lIns="0" tIns="0" rIns="0" bIns="0" rtlCol="0" anchor="t"/>
-          <a:lstStyle/>
-          <a:p>
-            <a:pPr indent="0" marL="0">
-              <a:buNone/>
-            </a:pPr>
-            <a:r>
-              <a:rPr lang="en-US" sz="1150" dirty="0">
-                <a:solidFill>
-                  <a:srgbClr val="5D6B63"/>
-                </a:solidFill>
-                <a:latin typeface="Calibri" pitchFamily="34" charset="0"/>
-                <a:ea typeface="Calibri" pitchFamily="34" charset="-122"/>
-                <a:cs typeface="Calibri" pitchFamily="34" charset="-120"/>
-              </a:rPr>
-              <a:t>Magic-link or password sign-in — nothing to configure</a:t>
-            </a:r>
-            <a:endParaRPr lang="en-US" sz="1150" dirty="0"/>
-          </a:p>
-        </p:txBody>
-      </p:sp>
-      <p:sp>
-        <p:nvSpPr>
-          <p:cNvPr id="29" name="Shape 27"/>
-          <p:cNvSpPr/>
-          <p:nvPr/>
-        </p:nvSpPr>
-        <p:spPr>
-          <a:xfrm>
-            <a:off x="7973568" y="3383280"/>
-            <a:ext cx="3566160" cy="1600200"/>
-          </a:xfrm>
-          <a:prstGeom prst="roundRect">
-            <a:avLst>
-              <a:gd name="adj" fmla="val 4571"/>
-            </a:avLst>
-          </a:prstGeom>
-          <a:solidFill>
-            <a:srgbClr val="F1F5F3"/>
-          </a:solidFill>
-          <a:ln w="9525">
-            <a:solidFill>
-              <a:srgbClr val="D9E2DC"/>
-            </a:solidFill>
-            <a:prstDash val="solid"/>
-          </a:ln>
-          <a:effectLst>
-            <a:outerShdw sx="100000" sy="100000" kx="0" ky="0" algn="bl" rotWithShape="0" blurRad="76200" dist="25400" dir="5400000">
-              <a:srgbClr val="9AA8A0">
-                <a:alpha val="35000"/>
-              </a:srgbClr>
-            </a:outerShdw>
-          </a:effectLst>
-        </p:spPr>
-      </p:sp>
-      <p:sp>
-        <p:nvSpPr>
-          <p:cNvPr id="30" name="Shape 28"/>
-          <p:cNvSpPr/>
-          <p:nvPr/>
-        </p:nvSpPr>
-        <p:spPr>
-          <a:xfrm>
-            <a:off x="8174736" y="3602736"/>
-            <a:ext cx="457200" cy="457200"/>
-          </a:xfrm>
-          <a:prstGeom prst="ellipse">
-            <a:avLst/>
-          </a:prstGeom>
-          <a:solidFill>
-            <a:srgbClr val="EE9455"/>
-          </a:solidFill>
-          <a:ln/>
-        </p:spPr>
-      </p:sp>
-      <p:sp>
-        <p:nvSpPr>
-          <p:cNvPr id="31" name="Text 29"/>
-          <p:cNvSpPr/>
-          <p:nvPr/>
-        </p:nvSpPr>
-        <p:spPr>
-          <a:xfrm>
-            <a:off x="8174736" y="3602736"/>
-            <a:ext cx="457200" cy="457200"/>
-          </a:xfrm>
-          <a:prstGeom prst="rect">
-            <a:avLst/>
-          </a:prstGeom>
-          <a:noFill/>
-          <a:ln/>
-        </p:spPr>
-        <p:txBody>
-          <a:bodyPr wrap="square" lIns="0" tIns="0" rIns="0" bIns="0" rtlCol="0" anchor="ctr"/>
-          <a:lstStyle/>
-          <a:p>
-            <a:pPr algn="ctr" indent="0" marL="0">
-              <a:buNone/>
-            </a:pPr>
-            <a:r>
-              <a:rPr lang="en-US" sz="1500" b="1" dirty="0">
-                <a:solidFill>
-                  <a:srgbClr val="FFFFFF"/>
-                </a:solidFill>
-                <a:latin typeface="Calibri" pitchFamily="34" charset="0"/>
-                <a:ea typeface="Calibri" pitchFamily="34" charset="-122"/>
-                <a:cs typeface="Calibri" pitchFamily="34" charset="-120"/>
-              </a:rPr>
-              <a:t>★</a:t>
-            </a:r>
-            <a:endParaRPr lang="en-US" sz="1500" dirty="0"/>
-          </a:p>
-        </p:txBody>
-      </p:sp>
-      <p:sp>
-        <p:nvSpPr>
-          <p:cNvPr id="32" name="Text 30"/>
-          <p:cNvSpPr/>
-          <p:nvPr/>
-        </p:nvSpPr>
-        <p:spPr>
-          <a:xfrm>
-            <a:off x="8796528" y="3529584"/>
-            <a:ext cx="2606040" cy="310896"/>
-          </a:xfrm>
-          <a:prstGeom prst="rect">
-            <a:avLst/>
-          </a:prstGeom>
-          <a:noFill/>
-          <a:ln/>
-        </p:spPr>
-        <p:txBody>
-          <a:bodyPr wrap="square" lIns="0" tIns="0" rIns="0" bIns="0" rtlCol="0" anchor="ctr"/>
-          <a:lstStyle/>
-          <a:p>
-            <a:pPr indent="0" marL="0">
-              <a:buNone/>
-            </a:pPr>
-            <a:r>
-              <a:rPr lang="en-US" sz="1400" b="1" dirty="0">
-                <a:solidFill>
-                  <a:srgbClr val="1D2621"/>
-                </a:solidFill>
-                <a:latin typeface="Calibri" pitchFamily="34" charset="0"/>
-                <a:ea typeface="Calibri" pitchFamily="34" charset="-122"/>
-                <a:cs typeface="Calibri" pitchFamily="34" charset="-120"/>
-              </a:rPr>
-              <a:t>Sourced &amp; honest</a:t>
-            </a:r>
-            <a:endParaRPr lang="en-US" sz="1400" dirty="0"/>
-          </a:p>
-        </p:txBody>
-      </p:sp>
-      <p:sp>
-        <p:nvSpPr>
-          <p:cNvPr id="33" name="Text 31"/>
-          <p:cNvSpPr/>
-          <p:nvPr/>
-        </p:nvSpPr>
-        <p:spPr>
-          <a:xfrm>
-            <a:off x="8796528" y="3840480"/>
-            <a:ext cx="2606040" cy="1051560"/>
-          </a:xfrm>
-          <a:prstGeom prst="rect">
-            <a:avLst/>
-          </a:prstGeom>
-          <a:noFill/>
-          <a:ln/>
-        </p:spPr>
-        <p:txBody>
-          <a:bodyPr wrap="square" lIns="0" tIns="0" rIns="0" bIns="0" rtlCol="0" anchor="t"/>
-          <a:lstStyle/>
-          <a:p>
-            <a:pPr indent="0" marL="0">
-              <a:buNone/>
-            </a:pPr>
-            <a:r>
-              <a:rPr lang="en-US" sz="1150" dirty="0">
-                <a:solidFill>
-                  <a:srgbClr val="5D6B63"/>
-                </a:solidFill>
-                <a:latin typeface="Calibri" pitchFamily="34" charset="0"/>
-                <a:ea typeface="Calibri" pitchFamily="34" charset="-122"/>
-                <a:cs typeface="Calibri" pitchFamily="34" charset="-120"/>
-              </a:rPr>
-              <a:t>Every claim links to its source; no fabricated data</a:t>
-            </a:r>
-            <a:endParaRPr lang="en-US" sz="1150" dirty="0"/>
-          </a:p>
-        </p:txBody>
-      </p:sp>
-      <p:sp>
-        <p:nvSpPr>
-          <p:cNvPr id="34" name="Text 32"/>
+          <p:cNvPr id="24" name="Text 22"/>
           <p:cNvSpPr/>
           <p:nvPr/>
         </p:nvSpPr>
@@ -8343,7 +8457,7 @@
                 <a:ea typeface="Calibri" pitchFamily="34" charset="-122"/>
                 <a:cs typeface="Calibri" pitchFamily="34" charset="-120"/>
               </a:rPr>
-              <a:t>FOR FUNDERS</a:t>
+              <a:t>BUILT FOR HOW YOU WORK</a:t>
             </a:r>
             <a:endParaRPr lang="en-US" sz="1200" dirty="0"/>
           </a:p>
@@ -8382,7 +8496,7 @@
                 <a:ea typeface="Cambria" pitchFamily="34" charset="-122"/>
                 <a:cs typeface="Cambria" pitchFamily="34" charset="-120"/>
               </a:rPr>
-              <a:t>Where a marginal shilling moves the needle</a:t>
+              <a:t>No friction, no training, no app store</a:t>
             </a:r>
             <a:endParaRPr lang="en-US" sz="3000" dirty="0"/>
           </a:p>
@@ -8390,143 +8504,22 @@
       </p:sp>
       <p:sp>
         <p:nvSpPr>
-          <p:cNvPr id="4" name="Text 2"/>
-          <p:cNvSpPr/>
-          <p:nvPr/>
-        </p:nvSpPr>
-        <p:spPr>
-          <a:xfrm>
-            <a:off x="548640" y="1463040"/>
-            <a:ext cx="5486400" cy="2194560"/>
-          </a:xfrm>
-          <a:prstGeom prst="rect">
-            <a:avLst/>
-          </a:prstGeom>
-          <a:noFill/>
-          <a:ln/>
-        </p:spPr>
-        <p:txBody>
-          <a:bodyPr wrap="square" lIns="0" tIns="0" rIns="0" bIns="0" rtlCol="0" anchor="t"/>
-          <a:lstStyle/>
-          <a:p>
-            <a:pPr indent="0" marL="0">
-              <a:buNone/>
-            </a:pPr>
-            <a:r>
-              <a:rPr lang="en-US" sz="1500" dirty="0">
-                <a:solidFill>
-                  <a:srgbClr val="5D6B63"/>
-                </a:solidFill>
-                <a:latin typeface="Calibri" pitchFamily="34" charset="0"/>
-                <a:ea typeface="Calibri" pitchFamily="34" charset="-122"/>
-                <a:cs typeface="Calibri" pitchFamily="34" charset="-120"/>
-              </a:rPr>
-              <a:t>The map ranks counties by response gap and the platform exports reach, coverage and engagement data — so you fund live programme activity, not a retrospective annual report.</a:t>
-            </a:r>
-            <a:endParaRPr lang="en-US" sz="1500" dirty="0"/>
-          </a:p>
-        </p:txBody>
-      </p:sp>
-      <p:sp>
-        <p:nvSpPr>
-          <p:cNvPr id="5" name="Text 3"/>
-          <p:cNvSpPr/>
-          <p:nvPr/>
-        </p:nvSpPr>
-        <p:spPr>
-          <a:xfrm>
-            <a:off x="640080" y="3657600"/>
-            <a:ext cx="5394960" cy="2194560"/>
-          </a:xfrm>
-          <a:prstGeom prst="rect">
-            <a:avLst/>
-          </a:prstGeom>
-          <a:noFill/>
-          <a:ln/>
-        </p:spPr>
-        <p:txBody>
-          <a:bodyPr wrap="square" lIns="0" tIns="0" rIns="0" bIns="0" rtlCol="0" anchor="ctr"/>
-          <a:lstStyle/>
-          <a:p>
-            <a:pPr marL="203200" indent="-203200">
-              <a:spcAft>
-                <a:spcPts val="1000"/>
-              </a:spcAft>
-              <a:buSzPct val="100000"/>
-              <a:buChar char="•"/>
-            </a:pPr>
-            <a:r>
-              <a:rPr lang="en-US" sz="1400" dirty="0">
-                <a:solidFill>
-                  <a:srgbClr val="1D2621"/>
-                </a:solidFill>
-                <a:latin typeface="Calibri" pitchFamily="34" charset="0"/>
-                <a:ea typeface="Calibri" pitchFamily="34" charset="-122"/>
-                <a:cs typeface="Calibri" pitchFamily="34" charset="-120"/>
-              </a:rPr>
-              <a:t>Fund a documentation partner in a top-gap county</a:t>
-            </a:r>
-            <a:endParaRPr lang="en-US" sz="1400" dirty="0"/>
-          </a:p>
-          <a:p>
-            <a:pPr marL="203200" indent="-203200">
-              <a:spcAft>
-                <a:spcPts val="1000"/>
-              </a:spcAft>
-              <a:buSzPct val="100000"/>
-              <a:buChar char="•"/>
-            </a:pPr>
-            <a:r>
-              <a:rPr lang="en-US" sz="1400" dirty="0">
-                <a:solidFill>
-                  <a:srgbClr val="1D2621"/>
-                </a:solidFill>
-                <a:latin typeface="Calibri" pitchFamily="34" charset="0"/>
-                <a:ea typeface="Calibri" pitchFamily="34" charset="-122"/>
-                <a:cs typeface="Calibri" pitchFamily="34" charset="-120"/>
-              </a:rPr>
-              <a:t>Back a live legal matter through to judgment</a:t>
-            </a:r>
-            <a:endParaRPr lang="en-US" sz="1400" dirty="0"/>
-          </a:p>
-          <a:p>
-            <a:pPr marL="203200" indent="-203200">
-              <a:buSzPct val="100000"/>
-              <a:buChar char="•"/>
-            </a:pPr>
-            <a:r>
-              <a:rPr lang="en-US" sz="1400" dirty="0">
-                <a:solidFill>
-                  <a:srgbClr val="1D2621"/>
-                </a:solidFill>
-                <a:latin typeface="Calibri" pitchFamily="34" charset="0"/>
-                <a:ea typeface="Calibri" pitchFamily="34" charset="-122"/>
-                <a:cs typeface="Calibri" pitchFamily="34" charset="-120"/>
-              </a:rPr>
-              <a:t>Support the coalition secretariat that keeps it current</a:t>
-            </a:r>
-            <a:endParaRPr lang="en-US" sz="1400" dirty="0"/>
-          </a:p>
-        </p:txBody>
-      </p:sp>
-      <p:sp>
-        <p:nvSpPr>
-          <p:cNvPr id="6" name="Shape 4"/>
-          <p:cNvSpPr/>
-          <p:nvPr/>
-        </p:nvSpPr>
-        <p:spPr>
-          <a:xfrm>
-            <a:off x="6400800" y="1554480"/>
-            <a:ext cx="2487168" cy="2103120"/>
+          <p:cNvPr id="4" name="Shape 2"/>
+          <p:cNvSpPr/>
+          <p:nvPr/>
+        </p:nvSpPr>
+        <p:spPr>
+          <a:xfrm>
+            <a:off x="548640" y="1600200"/>
+            <a:ext cx="3566160" cy="1600200"/>
           </a:xfrm>
           <a:prstGeom prst="roundRect">
             <a:avLst>
-              <a:gd name="adj" fmla="val 3478"/>
+              <a:gd name="adj" fmla="val 4571"/>
             </a:avLst>
           </a:prstGeom>
           <a:solidFill>
-            <a:srgbClr val="FFFFFF"/>
+            <a:srgbClr val="F1F5F3"/>
           </a:solidFill>
           <a:ln w="9525">
             <a:solidFill>
@@ -8545,40 +8538,99 @@
       </p:sp>
       <p:sp>
         <p:nvSpPr>
+          <p:cNvPr id="5" name="Shape 3"/>
+          <p:cNvSpPr/>
+          <p:nvPr/>
+        </p:nvSpPr>
+        <p:spPr>
+          <a:xfrm>
+            <a:off x="749808" y="1819656"/>
+            <a:ext cx="457200" cy="457200"/>
+          </a:xfrm>
+          <a:prstGeom prst="ellipse">
+            <a:avLst/>
+          </a:prstGeom>
+          <a:solidFill>
+            <a:srgbClr val="EE9455"/>
+          </a:solidFill>
+          <a:ln/>
+        </p:spPr>
+      </p:sp>
+      <p:sp>
+        <p:nvSpPr>
+          <p:cNvPr id="6" name="Text 4"/>
+          <p:cNvSpPr/>
+          <p:nvPr/>
+        </p:nvSpPr>
+        <p:spPr>
+          <a:xfrm>
+            <a:off x="749808" y="1819656"/>
+            <a:ext cx="457200" cy="457200"/>
+          </a:xfrm>
+          <a:prstGeom prst="rect">
+            <a:avLst/>
+          </a:prstGeom>
+          <a:noFill/>
+          <a:ln/>
+        </p:spPr>
+        <p:txBody>
+          <a:bodyPr wrap="square" lIns="0" tIns="0" rIns="0" bIns="0" rtlCol="0" anchor="ctr"/>
+          <a:lstStyle/>
+          <a:p>
+            <a:pPr algn="ctr" indent="0" marL="0">
+              <a:buNone/>
+            </a:pPr>
+            <a:r>
+              <a:rPr lang="en-US" sz="1500" b="1" dirty="0">
+                <a:solidFill>
+                  <a:srgbClr val="FFFFFF"/>
+                </a:solidFill>
+                <a:latin typeface="Calibri" pitchFamily="34" charset="0"/>
+                <a:ea typeface="Calibri" pitchFamily="34" charset="-122"/>
+                <a:cs typeface="Calibri" pitchFamily="34" charset="-120"/>
+              </a:rPr>
+              <a:t>★</a:t>
+            </a:r>
+            <a:endParaRPr lang="en-US" sz="1500" dirty="0"/>
+          </a:p>
+        </p:txBody>
+      </p:sp>
+      <p:sp>
+        <p:nvSpPr>
           <p:cNvPr id="7" name="Text 5"/>
           <p:cNvSpPr/>
           <p:nvPr/>
         </p:nvSpPr>
         <p:spPr>
           <a:xfrm>
-            <a:off x="6492240" y="1719072"/>
-            <a:ext cx="2304288" cy="822960"/>
-          </a:xfrm>
-          <a:prstGeom prst="rect">
-            <a:avLst/>
-          </a:prstGeom>
-          <a:noFill/>
-          <a:ln/>
-        </p:spPr>
-        <p:txBody>
-          <a:bodyPr wrap="square" lIns="0" tIns="0" rIns="0" bIns="0" rtlCol="0" anchor="ctr"/>
-          <a:lstStyle/>
-          <a:p>
-            <a:pPr algn="ctr" indent="0" marL="0">
-              <a:buNone/>
-            </a:pPr>
-            <a:r>
-              <a:rPr lang="en-US" sz="3400" b="1" dirty="0">
-                <a:solidFill>
-                  <a:srgbClr val="1B6B4A"/>
-                </a:solidFill>
-                <a:latin typeface="Cambria" pitchFamily="34" charset="0"/>
-                <a:ea typeface="Cambria" pitchFamily="34" charset="-122"/>
-                <a:cs typeface="Cambria" pitchFamily="34" charset="-120"/>
-              </a:rPr>
-              <a:t>47</a:t>
-            </a:r>
-            <a:endParaRPr lang="en-US" sz="3400" dirty="0"/>
+            <a:off x="1371600" y="1746504"/>
+            <a:ext cx="2606040" cy="310896"/>
+          </a:xfrm>
+          <a:prstGeom prst="rect">
+            <a:avLst/>
+          </a:prstGeom>
+          <a:noFill/>
+          <a:ln/>
+        </p:spPr>
+        <p:txBody>
+          <a:bodyPr wrap="square" lIns="0" tIns="0" rIns="0" bIns="0" rtlCol="0" anchor="ctr"/>
+          <a:lstStyle/>
+          <a:p>
+            <a:pPr indent="0" marL="0">
+              <a:buNone/>
+            </a:pPr>
+            <a:r>
+              <a:rPr lang="en-US" sz="1400" b="1" dirty="0">
+                <a:solidFill>
+                  <a:srgbClr val="1D2621"/>
+                </a:solidFill>
+                <a:latin typeface="Calibri" pitchFamily="34" charset="0"/>
+                <a:ea typeface="Calibri" pitchFamily="34" charset="-122"/>
+                <a:cs typeface="Calibri" pitchFamily="34" charset="-120"/>
+              </a:rPr>
+              <a:t>Any phone</a:t>
+            </a:r>
+            <a:endParaRPr lang="en-US" sz="1400" dirty="0"/>
           </a:p>
         </p:txBody>
       </p:sp>
@@ -8590,8 +8642,8 @@
         </p:nvSpPr>
         <p:spPr>
           <a:xfrm>
-            <a:off x="6510528" y="2514600"/>
-            <a:ext cx="2267712" cy="1097280"/>
+            <a:off x="1371600" y="2057400"/>
+            <a:ext cx="2606040" cy="1051560"/>
           </a:xfrm>
           <a:prstGeom prst="rect">
             <a:avLst/>
@@ -8603,11 +8655,11 @@
           <a:bodyPr wrap="square" lIns="0" tIns="0" rIns="0" bIns="0" rtlCol="0" anchor="t"/>
           <a:lstStyle/>
           <a:p>
-            <a:pPr algn="ctr" indent="0" marL="0">
-              <a:buNone/>
-            </a:pPr>
-            <a:r>
-              <a:rPr lang="en-US" sz="1100" dirty="0">
+            <a:pPr indent="0" marL="0">
+              <a:buNone/>
+            </a:pPr>
+            <a:r>
+              <a:rPr lang="en-US" sz="1150" dirty="0">
                 <a:solidFill>
                   <a:srgbClr val="5D6B63"/>
                 </a:solidFill>
@@ -8615,9 +8667,9 @@
                 <a:ea typeface="Calibri" pitchFamily="34" charset="-122"/>
                 <a:cs typeface="Calibri" pitchFamily="34" charset="-120"/>
               </a:rPr>
-              <a:t>counties, one gap-ranked view</a:t>
-            </a:r>
-            <a:endParaRPr lang="en-US" sz="1100" dirty="0"/>
+              <a:t>Installs like an app from the browser — a Progressive Web App, works on modest devices</a:t>
+            </a:r>
+            <a:endParaRPr lang="en-US" sz="1150" dirty="0"/>
           </a:p>
         </p:txBody>
       </p:sp>
@@ -8629,16 +8681,16 @@
         </p:nvSpPr>
         <p:spPr>
           <a:xfrm>
-            <a:off x="9052560" y="1554480"/>
-            <a:ext cx="2487168" cy="2103120"/>
+            <a:off x="4261104" y="1600200"/>
+            <a:ext cx="3566160" cy="1600200"/>
           </a:xfrm>
           <a:prstGeom prst="roundRect">
             <a:avLst>
-              <a:gd name="adj" fmla="val 3478"/>
+              <a:gd name="adj" fmla="val 4571"/>
             </a:avLst>
           </a:prstGeom>
           <a:solidFill>
-            <a:srgbClr val="FFFFFF"/>
+            <a:srgbClr val="F1F5F3"/>
           </a:solidFill>
           <a:ln w="9525">
             <a:solidFill>
@@ -8657,14 +8709,34 @@
       </p:sp>
       <p:sp>
         <p:nvSpPr>
-          <p:cNvPr id="10" name="Text 8"/>
-          <p:cNvSpPr/>
-          <p:nvPr/>
-        </p:nvSpPr>
-        <p:spPr>
-          <a:xfrm>
-            <a:off x="9144000" y="1719072"/>
-            <a:ext cx="2304288" cy="822960"/>
+          <p:cNvPr id="10" name="Shape 8"/>
+          <p:cNvSpPr/>
+          <p:nvPr/>
+        </p:nvSpPr>
+        <p:spPr>
+          <a:xfrm>
+            <a:off x="4462272" y="1819656"/>
+            <a:ext cx="457200" cy="457200"/>
+          </a:xfrm>
+          <a:prstGeom prst="ellipse">
+            <a:avLst/>
+          </a:prstGeom>
+          <a:solidFill>
+            <a:srgbClr val="EE9455"/>
+          </a:solidFill>
+          <a:ln/>
+        </p:spPr>
+      </p:sp>
+      <p:sp>
+        <p:nvSpPr>
+          <p:cNvPr id="11" name="Text 9"/>
+          <p:cNvSpPr/>
+          <p:nvPr/>
+        </p:nvSpPr>
+        <p:spPr>
+          <a:xfrm>
+            <a:off x="4462272" y="1819656"/>
+            <a:ext cx="457200" cy="457200"/>
           </a:xfrm>
           <a:prstGeom prst="rect">
             <a:avLst/>
@@ -8680,30 +8752,69 @@
               <a:buNone/>
             </a:pPr>
             <a:r>
-              <a:rPr lang="en-US" sz="3400" b="1" dirty="0">
-                <a:solidFill>
-                  <a:srgbClr val="EE9455"/>
-                </a:solidFill>
-                <a:latin typeface="Cambria" pitchFamily="34" charset="0"/>
-                <a:ea typeface="Cambria" pitchFamily="34" charset="-122"/>
-                <a:cs typeface="Cambria" pitchFamily="34" charset="-120"/>
-              </a:rPr>
-              <a:t>3</a:t>
-            </a:r>
-            <a:endParaRPr lang="en-US" sz="3400" dirty="0"/>
-          </a:p>
-        </p:txBody>
-      </p:sp>
-      <p:sp>
-        <p:nvSpPr>
-          <p:cNvPr id="11" name="Text 9"/>
-          <p:cNvSpPr/>
-          <p:nvPr/>
-        </p:nvSpPr>
-        <p:spPr>
-          <a:xfrm>
-            <a:off x="9162288" y="2514600"/>
-            <a:ext cx="2267712" cy="1097280"/>
+              <a:rPr lang="en-US" sz="1500" b="1" dirty="0">
+                <a:solidFill>
+                  <a:srgbClr val="FFFFFF"/>
+                </a:solidFill>
+                <a:latin typeface="Calibri" pitchFamily="34" charset="0"/>
+                <a:ea typeface="Calibri" pitchFamily="34" charset="-122"/>
+                <a:cs typeface="Calibri" pitchFamily="34" charset="-120"/>
+              </a:rPr>
+              <a:t>★</a:t>
+            </a:r>
+            <a:endParaRPr lang="en-US" sz="1500" dirty="0"/>
+          </a:p>
+        </p:txBody>
+      </p:sp>
+      <p:sp>
+        <p:nvSpPr>
+          <p:cNvPr id="12" name="Text 10"/>
+          <p:cNvSpPr/>
+          <p:nvPr/>
+        </p:nvSpPr>
+        <p:spPr>
+          <a:xfrm>
+            <a:off x="5084064" y="1746504"/>
+            <a:ext cx="2606040" cy="310896"/>
+          </a:xfrm>
+          <a:prstGeom prst="rect">
+            <a:avLst/>
+          </a:prstGeom>
+          <a:noFill/>
+          <a:ln/>
+        </p:spPr>
+        <p:txBody>
+          <a:bodyPr wrap="square" lIns="0" tIns="0" rIns="0" bIns="0" rtlCol="0" anchor="ctr"/>
+          <a:lstStyle/>
+          <a:p>
+            <a:pPr indent="0" marL="0">
+              <a:buNone/>
+            </a:pPr>
+            <a:r>
+              <a:rPr lang="en-US" sz="1400" b="1" dirty="0">
+                <a:solidFill>
+                  <a:srgbClr val="1D2621"/>
+                </a:solidFill>
+                <a:latin typeface="Calibri" pitchFamily="34" charset="0"/>
+                <a:ea typeface="Calibri" pitchFamily="34" charset="-122"/>
+                <a:cs typeface="Calibri" pitchFamily="34" charset="-120"/>
+              </a:rPr>
+              <a:t>Works offline</a:t>
+            </a:r>
+            <a:endParaRPr lang="en-US" sz="1400" dirty="0"/>
+          </a:p>
+        </p:txBody>
+      </p:sp>
+      <p:sp>
+        <p:nvSpPr>
+          <p:cNvPr id="13" name="Text 11"/>
+          <p:cNvSpPr/>
+          <p:nvPr/>
+        </p:nvSpPr>
+        <p:spPr>
+          <a:xfrm>
+            <a:off x="5084064" y="2057400"/>
+            <a:ext cx="2606040" cy="1051560"/>
           </a:xfrm>
           <a:prstGeom prst="rect">
             <a:avLst/>
@@ -8715,11 +8826,11 @@
           <a:bodyPr wrap="square" lIns="0" tIns="0" rIns="0" bIns="0" rtlCol="0" anchor="t"/>
           <a:lstStyle/>
           <a:p>
-            <a:pPr algn="ctr" indent="0" marL="0">
-              <a:buNone/>
-            </a:pPr>
-            <a:r>
-              <a:rPr lang="en-US" sz="1100" dirty="0">
+            <a:pPr indent="0" marL="0">
+              <a:buNone/>
+            </a:pPr>
+            <a:r>
+              <a:rPr lang="en-US" sz="1150" dirty="0">
                 <a:solidFill>
                   <a:srgbClr val="5D6B63"/>
                 </a:solidFill>
@@ -8727,30 +8838,30 @@
                 <a:ea typeface="Calibri" pitchFamily="34" charset="-122"/>
                 <a:cs typeface="Calibri" pitchFamily="34" charset="-120"/>
               </a:rPr>
-              <a:t>languages, public + members</a:t>
-            </a:r>
-            <a:endParaRPr lang="en-US" sz="1100" dirty="0"/>
-          </a:p>
-        </p:txBody>
-      </p:sp>
-      <p:sp>
-        <p:nvSpPr>
-          <p:cNvPr id="12" name="Shape 10"/>
-          <p:cNvSpPr/>
-          <p:nvPr/>
-        </p:nvSpPr>
-        <p:spPr>
-          <a:xfrm>
-            <a:off x="6400800" y="3794760"/>
-            <a:ext cx="5138928" cy="1920240"/>
+              <a:t>Caches so it opens fast and keeps working on a weak connection</a:t>
+            </a:r>
+            <a:endParaRPr lang="en-US" sz="1150" dirty="0"/>
+          </a:p>
+        </p:txBody>
+      </p:sp>
+      <p:sp>
+        <p:nvSpPr>
+          <p:cNvPr id="14" name="Shape 12"/>
+          <p:cNvSpPr/>
+          <p:nvPr/>
+        </p:nvSpPr>
+        <p:spPr>
+          <a:xfrm>
+            <a:off x="7973568" y="1600200"/>
+            <a:ext cx="3566160" cy="1600200"/>
           </a:xfrm>
           <a:prstGeom prst="roundRect">
             <a:avLst>
-              <a:gd name="adj" fmla="val 3810"/>
+              <a:gd name="adj" fmla="val 4571"/>
             </a:avLst>
           </a:prstGeom>
           <a:solidFill>
-            <a:srgbClr val="FFFFFF"/>
+            <a:srgbClr val="F1F5F3"/>
           </a:solidFill>
           <a:ln w="9525">
             <a:solidFill>
@@ -8769,14 +8880,34 @@
       </p:sp>
       <p:sp>
         <p:nvSpPr>
-          <p:cNvPr id="13" name="Text 11"/>
-          <p:cNvSpPr/>
-          <p:nvPr/>
-        </p:nvSpPr>
-        <p:spPr>
-          <a:xfrm>
-            <a:off x="6492240" y="3959352"/>
-            <a:ext cx="4956048" cy="822960"/>
+          <p:cNvPr id="15" name="Shape 13"/>
+          <p:cNvSpPr/>
+          <p:nvPr/>
+        </p:nvSpPr>
+        <p:spPr>
+          <a:xfrm>
+            <a:off x="8174736" y="1819656"/>
+            <a:ext cx="457200" cy="457200"/>
+          </a:xfrm>
+          <a:prstGeom prst="ellipse">
+            <a:avLst/>
+          </a:prstGeom>
+          <a:solidFill>
+            <a:srgbClr val="EE9455"/>
+          </a:solidFill>
+          <a:ln/>
+        </p:spPr>
+      </p:sp>
+      <p:sp>
+        <p:nvSpPr>
+          <p:cNvPr id="16" name="Text 14"/>
+          <p:cNvSpPr/>
+          <p:nvPr/>
+        </p:nvSpPr>
+        <p:spPr>
+          <a:xfrm>
+            <a:off x="8174736" y="1819656"/>
+            <a:ext cx="457200" cy="457200"/>
           </a:xfrm>
           <a:prstGeom prst="rect">
             <a:avLst/>
@@ -8792,30 +8923,69 @@
               <a:buNone/>
             </a:pPr>
             <a:r>
-              <a:rPr lang="en-US" sz="3400" b="1" dirty="0">
-                <a:solidFill>
-                  <a:srgbClr val="2C7A55"/>
-                </a:solidFill>
-                <a:latin typeface="Cambria" pitchFamily="34" charset="0"/>
-                <a:ea typeface="Cambria" pitchFamily="34" charset="-122"/>
-                <a:cs typeface="Cambria" pitchFamily="34" charset="-120"/>
-              </a:rPr>
-              <a:t>Export</a:t>
-            </a:r>
-            <a:endParaRPr lang="en-US" sz="3400" dirty="0"/>
-          </a:p>
-        </p:txBody>
-      </p:sp>
-      <p:sp>
-        <p:nvSpPr>
-          <p:cNvPr id="14" name="Text 12"/>
-          <p:cNvSpPr/>
-          <p:nvPr/>
-        </p:nvSpPr>
-        <p:spPr>
-          <a:xfrm>
-            <a:off x="6510528" y="4754880"/>
-            <a:ext cx="4919472" cy="914400"/>
+              <a:rPr lang="en-US" sz="1500" b="1" dirty="0">
+                <a:solidFill>
+                  <a:srgbClr val="FFFFFF"/>
+                </a:solidFill>
+                <a:latin typeface="Calibri" pitchFamily="34" charset="0"/>
+                <a:ea typeface="Calibri" pitchFamily="34" charset="-122"/>
+                <a:cs typeface="Calibri" pitchFamily="34" charset="-120"/>
+              </a:rPr>
+              <a:t>★</a:t>
+            </a:r>
+            <a:endParaRPr lang="en-US" sz="1500" dirty="0"/>
+          </a:p>
+        </p:txBody>
+      </p:sp>
+      <p:sp>
+        <p:nvSpPr>
+          <p:cNvPr id="17" name="Text 15"/>
+          <p:cNvSpPr/>
+          <p:nvPr/>
+        </p:nvSpPr>
+        <p:spPr>
+          <a:xfrm>
+            <a:off x="8796528" y="1746504"/>
+            <a:ext cx="2606040" cy="310896"/>
+          </a:xfrm>
+          <a:prstGeom prst="rect">
+            <a:avLst/>
+          </a:prstGeom>
+          <a:noFill/>
+          <a:ln/>
+        </p:spPr>
+        <p:txBody>
+          <a:bodyPr wrap="square" lIns="0" tIns="0" rIns="0" bIns="0" rtlCol="0" anchor="ctr"/>
+          <a:lstStyle/>
+          <a:p>
+            <a:pPr indent="0" marL="0">
+              <a:buNone/>
+            </a:pPr>
+            <a:r>
+              <a:rPr lang="en-US" sz="1400" b="1" dirty="0">
+                <a:solidFill>
+                  <a:srgbClr val="1D2621"/>
+                </a:solidFill>
+                <a:latin typeface="Calibri" pitchFamily="34" charset="0"/>
+                <a:ea typeface="Calibri" pitchFamily="34" charset="-122"/>
+                <a:cs typeface="Calibri" pitchFamily="34" charset="-120"/>
+              </a:rPr>
+              <a:t>Three languages</a:t>
+            </a:r>
+            <a:endParaRPr lang="en-US" sz="1400" dirty="0"/>
+          </a:p>
+        </p:txBody>
+      </p:sp>
+      <p:sp>
+        <p:nvSpPr>
+          <p:cNvPr id="18" name="Text 16"/>
+          <p:cNvSpPr/>
+          <p:nvPr/>
+        </p:nvSpPr>
+        <p:spPr>
+          <a:xfrm>
+            <a:off x="8796528" y="2057400"/>
+            <a:ext cx="2606040" cy="1051560"/>
           </a:xfrm>
           <a:prstGeom prst="rect">
             <a:avLst/>
@@ -8827,11 +8997,182 @@
           <a:bodyPr wrap="square" lIns="0" tIns="0" rIns="0" bIns="0" rtlCol="0" anchor="t"/>
           <a:lstStyle/>
           <a:p>
+            <a:pPr indent="0" marL="0">
+              <a:buNone/>
+            </a:pPr>
+            <a:r>
+              <a:rPr lang="en-US" sz="1150" dirty="0">
+                <a:solidFill>
+                  <a:srgbClr val="5D6B63"/>
+                </a:solidFill>
+                <a:latin typeface="Calibri" pitchFamily="34" charset="0"/>
+                <a:ea typeface="Calibri" pitchFamily="34" charset="-122"/>
+                <a:cs typeface="Calibri" pitchFamily="34" charset="-120"/>
+              </a:rPr>
+              <a:t>English, Kiswahili and Sheng — meet people where they are</a:t>
+            </a:r>
+            <a:endParaRPr lang="en-US" sz="1150" dirty="0"/>
+          </a:p>
+        </p:txBody>
+      </p:sp>
+      <p:sp>
+        <p:nvSpPr>
+          <p:cNvPr id="19" name="Shape 17"/>
+          <p:cNvSpPr/>
+          <p:nvPr/>
+        </p:nvSpPr>
+        <p:spPr>
+          <a:xfrm>
+            <a:off x="548640" y="3383280"/>
+            <a:ext cx="3566160" cy="1600200"/>
+          </a:xfrm>
+          <a:prstGeom prst="roundRect">
+            <a:avLst>
+              <a:gd name="adj" fmla="val 4571"/>
+            </a:avLst>
+          </a:prstGeom>
+          <a:solidFill>
+            <a:srgbClr val="F1F5F3"/>
+          </a:solidFill>
+          <a:ln w="9525">
+            <a:solidFill>
+              <a:srgbClr val="D9E2DC"/>
+            </a:solidFill>
+            <a:prstDash val="solid"/>
+          </a:ln>
+          <a:effectLst>
+            <a:outerShdw sx="100000" sy="100000" kx="0" ky="0" algn="bl" rotWithShape="0" blurRad="76200" dist="25400" dir="5400000">
+              <a:srgbClr val="9AA8A0">
+                <a:alpha val="35000"/>
+              </a:srgbClr>
+            </a:outerShdw>
+          </a:effectLst>
+        </p:spPr>
+      </p:sp>
+      <p:sp>
+        <p:nvSpPr>
+          <p:cNvPr id="20" name="Shape 18"/>
+          <p:cNvSpPr/>
+          <p:nvPr/>
+        </p:nvSpPr>
+        <p:spPr>
+          <a:xfrm>
+            <a:off x="749808" y="3602736"/>
+            <a:ext cx="457200" cy="457200"/>
+          </a:xfrm>
+          <a:prstGeom prst="ellipse">
+            <a:avLst/>
+          </a:prstGeom>
+          <a:solidFill>
+            <a:srgbClr val="EE9455"/>
+          </a:solidFill>
+          <a:ln/>
+        </p:spPr>
+      </p:sp>
+      <p:sp>
+        <p:nvSpPr>
+          <p:cNvPr id="21" name="Text 19"/>
+          <p:cNvSpPr/>
+          <p:nvPr/>
+        </p:nvSpPr>
+        <p:spPr>
+          <a:xfrm>
+            <a:off x="749808" y="3602736"/>
+            <a:ext cx="457200" cy="457200"/>
+          </a:xfrm>
+          <a:prstGeom prst="rect">
+            <a:avLst/>
+          </a:prstGeom>
+          <a:noFill/>
+          <a:ln/>
+        </p:spPr>
+        <p:txBody>
+          <a:bodyPr wrap="square" lIns="0" tIns="0" rIns="0" bIns="0" rtlCol="0" anchor="ctr"/>
+          <a:lstStyle/>
+          <a:p>
             <a:pPr algn="ctr" indent="0" marL="0">
               <a:buNone/>
             </a:pPr>
             <a:r>
-              <a:rPr lang="en-US" sz="1100" dirty="0">
+              <a:rPr lang="en-US" sz="1500" b="1" dirty="0">
+                <a:solidFill>
+                  <a:srgbClr val="FFFFFF"/>
+                </a:solidFill>
+                <a:latin typeface="Calibri" pitchFamily="34" charset="0"/>
+                <a:ea typeface="Calibri" pitchFamily="34" charset="-122"/>
+                <a:cs typeface="Calibri" pitchFamily="34" charset="-120"/>
+              </a:rPr>
+              <a:t>★</a:t>
+            </a:r>
+            <a:endParaRPr lang="en-US" sz="1500" dirty="0"/>
+          </a:p>
+        </p:txBody>
+      </p:sp>
+      <p:sp>
+        <p:nvSpPr>
+          <p:cNvPr id="22" name="Text 20"/>
+          <p:cNvSpPr/>
+          <p:nvPr/>
+        </p:nvSpPr>
+        <p:spPr>
+          <a:xfrm>
+            <a:off x="1371600" y="3529584"/>
+            <a:ext cx="2606040" cy="310896"/>
+          </a:xfrm>
+          <a:prstGeom prst="rect">
+            <a:avLst/>
+          </a:prstGeom>
+          <a:noFill/>
+          <a:ln/>
+        </p:spPr>
+        <p:txBody>
+          <a:bodyPr wrap="square" lIns="0" tIns="0" rIns="0" bIns="0" rtlCol="0" anchor="ctr"/>
+          <a:lstStyle/>
+          <a:p>
+            <a:pPr indent="0" marL="0">
+              <a:buNone/>
+            </a:pPr>
+            <a:r>
+              <a:rPr lang="en-US" sz="1400" b="1" dirty="0">
+                <a:solidFill>
+                  <a:srgbClr val="1D2621"/>
+                </a:solidFill>
+                <a:latin typeface="Calibri" pitchFamily="34" charset="0"/>
+                <a:ea typeface="Calibri" pitchFamily="34" charset="-122"/>
+                <a:cs typeface="Calibri" pitchFamily="34" charset="-120"/>
+              </a:rPr>
+              <a:t>Members-only &amp; secure</a:t>
+            </a:r>
+            <a:endParaRPr lang="en-US" sz="1400" dirty="0"/>
+          </a:p>
+        </p:txBody>
+      </p:sp>
+      <p:sp>
+        <p:nvSpPr>
+          <p:cNvPr id="23" name="Text 21"/>
+          <p:cNvSpPr/>
+          <p:nvPr/>
+        </p:nvSpPr>
+        <p:spPr>
+          <a:xfrm>
+            <a:off x="1371600" y="3840480"/>
+            <a:ext cx="2606040" cy="1051560"/>
+          </a:xfrm>
+          <a:prstGeom prst="rect">
+            <a:avLst/>
+          </a:prstGeom>
+          <a:noFill/>
+          <a:ln/>
+        </p:spPr>
+        <p:txBody>
+          <a:bodyPr wrap="square" lIns="0" tIns="0" rIns="0" bIns="0" rtlCol="0" anchor="t"/>
+          <a:lstStyle/>
+          <a:p>
+            <a:pPr indent="0" marL="0">
+              <a:buNone/>
+            </a:pPr>
+            <a:r>
+              <a:rPr lang="en-US" sz="1150" dirty="0">
                 <a:solidFill>
                   <a:srgbClr val="5D6B63"/>
                 </a:solidFill>
@@ -8839,15 +9180,357 @@
                 <a:ea typeface="Calibri" pitchFamily="34" charset="-122"/>
                 <a:cs typeface="Calibri" pitchFamily="34" charset="-120"/>
               </a:rPr>
-              <a:t>reach · coverage · engagement, on demand</a:t>
-            </a:r>
-            <a:endParaRPr lang="en-US" sz="1100" dirty="0"/>
-          </a:p>
-        </p:txBody>
-      </p:sp>
-      <p:sp>
-        <p:nvSpPr>
-          <p:cNvPr id="15" name="Text 13"/>
+              <a:t>Invite-only sign-in; your coordination stays inside the coalition</a:t>
+            </a:r>
+            <a:endParaRPr lang="en-US" sz="1150" dirty="0"/>
+          </a:p>
+        </p:txBody>
+      </p:sp>
+      <p:sp>
+        <p:nvSpPr>
+          <p:cNvPr id="24" name="Shape 22"/>
+          <p:cNvSpPr/>
+          <p:nvPr/>
+        </p:nvSpPr>
+        <p:spPr>
+          <a:xfrm>
+            <a:off x="4261104" y="3383280"/>
+            <a:ext cx="3566160" cy="1600200"/>
+          </a:xfrm>
+          <a:prstGeom prst="roundRect">
+            <a:avLst>
+              <a:gd name="adj" fmla="val 4571"/>
+            </a:avLst>
+          </a:prstGeom>
+          <a:solidFill>
+            <a:srgbClr val="F1F5F3"/>
+          </a:solidFill>
+          <a:ln w="9525">
+            <a:solidFill>
+              <a:srgbClr val="D9E2DC"/>
+            </a:solidFill>
+            <a:prstDash val="solid"/>
+          </a:ln>
+          <a:effectLst>
+            <a:outerShdw sx="100000" sy="100000" kx="0" ky="0" algn="bl" rotWithShape="0" blurRad="76200" dist="25400" dir="5400000">
+              <a:srgbClr val="9AA8A0">
+                <a:alpha val="35000"/>
+              </a:srgbClr>
+            </a:outerShdw>
+          </a:effectLst>
+        </p:spPr>
+      </p:sp>
+      <p:sp>
+        <p:nvSpPr>
+          <p:cNvPr id="25" name="Shape 23"/>
+          <p:cNvSpPr/>
+          <p:nvPr/>
+        </p:nvSpPr>
+        <p:spPr>
+          <a:xfrm>
+            <a:off x="4462272" y="3602736"/>
+            <a:ext cx="457200" cy="457200"/>
+          </a:xfrm>
+          <a:prstGeom prst="ellipse">
+            <a:avLst/>
+          </a:prstGeom>
+          <a:solidFill>
+            <a:srgbClr val="EE9455"/>
+          </a:solidFill>
+          <a:ln/>
+        </p:spPr>
+      </p:sp>
+      <p:sp>
+        <p:nvSpPr>
+          <p:cNvPr id="26" name="Text 24"/>
+          <p:cNvSpPr/>
+          <p:nvPr/>
+        </p:nvSpPr>
+        <p:spPr>
+          <a:xfrm>
+            <a:off x="4462272" y="3602736"/>
+            <a:ext cx="457200" cy="457200"/>
+          </a:xfrm>
+          <a:prstGeom prst="rect">
+            <a:avLst/>
+          </a:prstGeom>
+          <a:noFill/>
+          <a:ln/>
+        </p:spPr>
+        <p:txBody>
+          <a:bodyPr wrap="square" lIns="0" tIns="0" rIns="0" bIns="0" rtlCol="0" anchor="ctr"/>
+          <a:lstStyle/>
+          <a:p>
+            <a:pPr algn="ctr" indent="0" marL="0">
+              <a:buNone/>
+            </a:pPr>
+            <a:r>
+              <a:rPr lang="en-US" sz="1500" b="1" dirty="0">
+                <a:solidFill>
+                  <a:srgbClr val="FFFFFF"/>
+                </a:solidFill>
+                <a:latin typeface="Calibri" pitchFamily="34" charset="0"/>
+                <a:ea typeface="Calibri" pitchFamily="34" charset="-122"/>
+                <a:cs typeface="Calibri" pitchFamily="34" charset="-120"/>
+              </a:rPr>
+              <a:t>★</a:t>
+            </a:r>
+            <a:endParaRPr lang="en-US" sz="1500" dirty="0"/>
+          </a:p>
+        </p:txBody>
+      </p:sp>
+      <p:sp>
+        <p:nvSpPr>
+          <p:cNvPr id="27" name="Text 25"/>
+          <p:cNvSpPr/>
+          <p:nvPr/>
+        </p:nvSpPr>
+        <p:spPr>
+          <a:xfrm>
+            <a:off x="5084064" y="3529584"/>
+            <a:ext cx="2606040" cy="310896"/>
+          </a:xfrm>
+          <a:prstGeom prst="rect">
+            <a:avLst/>
+          </a:prstGeom>
+          <a:noFill/>
+          <a:ln/>
+        </p:spPr>
+        <p:txBody>
+          <a:bodyPr wrap="square" lIns="0" tIns="0" rIns="0" bIns="0" rtlCol="0" anchor="ctr"/>
+          <a:lstStyle/>
+          <a:p>
+            <a:pPr indent="0" marL="0">
+              <a:buNone/>
+            </a:pPr>
+            <a:r>
+              <a:rPr lang="en-US" sz="1400" b="1" dirty="0">
+                <a:solidFill>
+                  <a:srgbClr val="1D2621"/>
+                </a:solidFill>
+                <a:latin typeface="Calibri" pitchFamily="34" charset="0"/>
+                <a:ea typeface="Calibri" pitchFamily="34" charset="-122"/>
+                <a:cs typeface="Calibri" pitchFamily="34" charset="-120"/>
+              </a:rPr>
+              <a:t>One tap in</a:t>
+            </a:r>
+            <a:endParaRPr lang="en-US" sz="1400" dirty="0"/>
+          </a:p>
+        </p:txBody>
+      </p:sp>
+      <p:sp>
+        <p:nvSpPr>
+          <p:cNvPr id="28" name="Text 26"/>
+          <p:cNvSpPr/>
+          <p:nvPr/>
+        </p:nvSpPr>
+        <p:spPr>
+          <a:xfrm>
+            <a:off x="5084064" y="3840480"/>
+            <a:ext cx="2606040" cy="1051560"/>
+          </a:xfrm>
+          <a:prstGeom prst="rect">
+            <a:avLst/>
+          </a:prstGeom>
+          <a:noFill/>
+          <a:ln/>
+        </p:spPr>
+        <p:txBody>
+          <a:bodyPr wrap="square" lIns="0" tIns="0" rIns="0" bIns="0" rtlCol="0" anchor="t"/>
+          <a:lstStyle/>
+          <a:p>
+            <a:pPr indent="0" marL="0">
+              <a:buNone/>
+            </a:pPr>
+            <a:r>
+              <a:rPr lang="en-US" sz="1150" dirty="0">
+                <a:solidFill>
+                  <a:srgbClr val="5D6B63"/>
+                </a:solidFill>
+                <a:latin typeface="Calibri" pitchFamily="34" charset="0"/>
+                <a:ea typeface="Calibri" pitchFamily="34" charset="-122"/>
+                <a:cs typeface="Calibri" pitchFamily="34" charset="-120"/>
+              </a:rPr>
+              <a:t>Magic-link or password sign-in — nothing to configure</a:t>
+            </a:r>
+            <a:endParaRPr lang="en-US" sz="1150" dirty="0"/>
+          </a:p>
+        </p:txBody>
+      </p:sp>
+      <p:sp>
+        <p:nvSpPr>
+          <p:cNvPr id="29" name="Shape 27"/>
+          <p:cNvSpPr/>
+          <p:nvPr/>
+        </p:nvSpPr>
+        <p:spPr>
+          <a:xfrm>
+            <a:off x="7973568" y="3383280"/>
+            <a:ext cx="3566160" cy="1600200"/>
+          </a:xfrm>
+          <a:prstGeom prst="roundRect">
+            <a:avLst>
+              <a:gd name="adj" fmla="val 4571"/>
+            </a:avLst>
+          </a:prstGeom>
+          <a:solidFill>
+            <a:srgbClr val="F1F5F3"/>
+          </a:solidFill>
+          <a:ln w="9525">
+            <a:solidFill>
+              <a:srgbClr val="D9E2DC"/>
+            </a:solidFill>
+            <a:prstDash val="solid"/>
+          </a:ln>
+          <a:effectLst>
+            <a:outerShdw sx="100000" sy="100000" kx="0" ky="0" algn="bl" rotWithShape="0" blurRad="76200" dist="25400" dir="5400000">
+              <a:srgbClr val="9AA8A0">
+                <a:alpha val="35000"/>
+              </a:srgbClr>
+            </a:outerShdw>
+          </a:effectLst>
+        </p:spPr>
+      </p:sp>
+      <p:sp>
+        <p:nvSpPr>
+          <p:cNvPr id="30" name="Shape 28"/>
+          <p:cNvSpPr/>
+          <p:nvPr/>
+        </p:nvSpPr>
+        <p:spPr>
+          <a:xfrm>
+            <a:off x="8174736" y="3602736"/>
+            <a:ext cx="457200" cy="457200"/>
+          </a:xfrm>
+          <a:prstGeom prst="ellipse">
+            <a:avLst/>
+          </a:prstGeom>
+          <a:solidFill>
+            <a:srgbClr val="EE9455"/>
+          </a:solidFill>
+          <a:ln/>
+        </p:spPr>
+      </p:sp>
+      <p:sp>
+        <p:nvSpPr>
+          <p:cNvPr id="31" name="Text 29"/>
+          <p:cNvSpPr/>
+          <p:nvPr/>
+        </p:nvSpPr>
+        <p:spPr>
+          <a:xfrm>
+            <a:off x="8174736" y="3602736"/>
+            <a:ext cx="457200" cy="457200"/>
+          </a:xfrm>
+          <a:prstGeom prst="rect">
+            <a:avLst/>
+          </a:prstGeom>
+          <a:noFill/>
+          <a:ln/>
+        </p:spPr>
+        <p:txBody>
+          <a:bodyPr wrap="square" lIns="0" tIns="0" rIns="0" bIns="0" rtlCol="0" anchor="ctr"/>
+          <a:lstStyle/>
+          <a:p>
+            <a:pPr algn="ctr" indent="0" marL="0">
+              <a:buNone/>
+            </a:pPr>
+            <a:r>
+              <a:rPr lang="en-US" sz="1500" b="1" dirty="0">
+                <a:solidFill>
+                  <a:srgbClr val="FFFFFF"/>
+                </a:solidFill>
+                <a:latin typeface="Calibri" pitchFamily="34" charset="0"/>
+                <a:ea typeface="Calibri" pitchFamily="34" charset="-122"/>
+                <a:cs typeface="Calibri" pitchFamily="34" charset="-120"/>
+              </a:rPr>
+              <a:t>★</a:t>
+            </a:r>
+            <a:endParaRPr lang="en-US" sz="1500" dirty="0"/>
+          </a:p>
+        </p:txBody>
+      </p:sp>
+      <p:sp>
+        <p:nvSpPr>
+          <p:cNvPr id="32" name="Text 30"/>
+          <p:cNvSpPr/>
+          <p:nvPr/>
+        </p:nvSpPr>
+        <p:spPr>
+          <a:xfrm>
+            <a:off x="8796528" y="3529584"/>
+            <a:ext cx="2606040" cy="310896"/>
+          </a:xfrm>
+          <a:prstGeom prst="rect">
+            <a:avLst/>
+          </a:prstGeom>
+          <a:noFill/>
+          <a:ln/>
+        </p:spPr>
+        <p:txBody>
+          <a:bodyPr wrap="square" lIns="0" tIns="0" rIns="0" bIns="0" rtlCol="0" anchor="ctr"/>
+          <a:lstStyle/>
+          <a:p>
+            <a:pPr indent="0" marL="0">
+              <a:buNone/>
+            </a:pPr>
+            <a:r>
+              <a:rPr lang="en-US" sz="1400" b="1" dirty="0">
+                <a:solidFill>
+                  <a:srgbClr val="1D2621"/>
+                </a:solidFill>
+                <a:latin typeface="Calibri" pitchFamily="34" charset="0"/>
+                <a:ea typeface="Calibri" pitchFamily="34" charset="-122"/>
+                <a:cs typeface="Calibri" pitchFamily="34" charset="-120"/>
+              </a:rPr>
+              <a:t>Sourced &amp; honest</a:t>
+            </a:r>
+            <a:endParaRPr lang="en-US" sz="1400" dirty="0"/>
+          </a:p>
+        </p:txBody>
+      </p:sp>
+      <p:sp>
+        <p:nvSpPr>
+          <p:cNvPr id="33" name="Text 31"/>
+          <p:cNvSpPr/>
+          <p:nvPr/>
+        </p:nvSpPr>
+        <p:spPr>
+          <a:xfrm>
+            <a:off x="8796528" y="3840480"/>
+            <a:ext cx="2606040" cy="1051560"/>
+          </a:xfrm>
+          <a:prstGeom prst="rect">
+            <a:avLst/>
+          </a:prstGeom>
+          <a:noFill/>
+          <a:ln/>
+        </p:spPr>
+        <p:txBody>
+          <a:bodyPr wrap="square" lIns="0" tIns="0" rIns="0" bIns="0" rtlCol="0" anchor="t"/>
+          <a:lstStyle/>
+          <a:p>
+            <a:pPr indent="0" marL="0">
+              <a:buNone/>
+            </a:pPr>
+            <a:r>
+              <a:rPr lang="en-US" sz="1150" dirty="0">
+                <a:solidFill>
+                  <a:srgbClr val="5D6B63"/>
+                </a:solidFill>
+                <a:latin typeface="Calibri" pitchFamily="34" charset="0"/>
+                <a:ea typeface="Calibri" pitchFamily="34" charset="-122"/>
+                <a:cs typeface="Calibri" pitchFamily="34" charset="-120"/>
+              </a:rPr>
+              <a:t>Every claim links to its source; no fabricated data</a:t>
+            </a:r>
+            <a:endParaRPr lang="en-US" sz="1150" dirty="0"/>
+          </a:p>
+        </p:txBody>
+      </p:sp>
+      <p:sp>
+        <p:nvSpPr>
+          <p:cNvPr id="34" name="Text 32"/>
           <p:cNvSpPr/>
           <p:nvPr/>
         </p:nvSpPr>
@@ -8949,7 +9632,7 @@
                 <a:ea typeface="Calibri" pitchFamily="34" charset="-122"/>
                 <a:cs typeface="Calibri" pitchFamily="34" charset="-120"/>
               </a:rPr>
-              <a:t>THE RECEIPTS</a:t>
+              <a:t>FOR FUNDERS</a:t>
             </a:r>
             <a:endParaRPr lang="en-US" sz="1200" dirty="0"/>
           </a:p>
@@ -8988,7 +9671,7 @@
                 <a:ea typeface="Cambria" pitchFamily="34" charset="-122"/>
                 <a:cs typeface="Cambria" pitchFamily="34" charset="-120"/>
               </a:rPr>
-              <a:t>An accountability index with sources</a:t>
+              <a:t>Where a marginal shilling moves the needle</a:t>
             </a:r>
             <a:endParaRPr lang="en-US" sz="3000" dirty="0"/>
           </a:p>
@@ -9002,8 +9685,8 @@
         </p:nvSpPr>
         <p:spPr>
           <a:xfrm>
-            <a:off x="548640" y="1417320"/>
-            <a:ext cx="10972800" cy="822960"/>
+            <a:off x="548640" y="1463040"/>
+            <a:ext cx="5486400" cy="2194560"/>
           </a:xfrm>
           <a:prstGeom prst="rect">
             <a:avLst/>
@@ -9019,38 +9702,120 @@
               <a:buNone/>
             </a:pPr>
             <a:r>
+              <a:rPr lang="en-US" sz="1500" dirty="0">
+                <a:solidFill>
+                  <a:srgbClr val="5D6B63"/>
+                </a:solidFill>
+                <a:latin typeface="Calibri" pitchFamily="34" charset="0"/>
+                <a:ea typeface="Calibri" pitchFamily="34" charset="-122"/>
+                <a:cs typeface="Calibri" pitchFamily="34" charset="-120"/>
+              </a:rPr>
+              <a:t>The map ranks counties by response gap and the platform exports reach, coverage and engagement data — so you fund live programme activity, not a retrospective annual report.</a:t>
+            </a:r>
+            <a:endParaRPr lang="en-US" sz="1500" dirty="0"/>
+          </a:p>
+        </p:txBody>
+      </p:sp>
+      <p:sp>
+        <p:nvSpPr>
+          <p:cNvPr id="5" name="Text 3"/>
+          <p:cNvSpPr/>
+          <p:nvPr/>
+        </p:nvSpPr>
+        <p:spPr>
+          <a:xfrm>
+            <a:off x="640080" y="3657600"/>
+            <a:ext cx="5394960" cy="2194560"/>
+          </a:xfrm>
+          <a:prstGeom prst="rect">
+            <a:avLst/>
+          </a:prstGeom>
+          <a:noFill/>
+          <a:ln/>
+        </p:spPr>
+        <p:txBody>
+          <a:bodyPr wrap="square" lIns="0" tIns="0" rIns="0" bIns="0" rtlCol="0" anchor="ctr"/>
+          <a:lstStyle/>
+          <a:p>
+            <a:pPr marL="203200" indent="-203200">
+              <a:spcAft>
+                <a:spcPts val="1000"/>
+              </a:spcAft>
+              <a:buSzPct val="100000"/>
+              <a:buChar char="•"/>
+            </a:pPr>
+            <a:r>
               <a:rPr lang="en-US" sz="1400" dirty="0">
                 <a:solidFill>
-                  <a:srgbClr val="5D6B63"/>
-                </a:solidFill>
-                <a:latin typeface="Calibri" pitchFamily="34" charset="0"/>
-                <a:ea typeface="Calibri" pitchFamily="34" charset="-122"/>
-                <a:cs typeface="Calibri" pitchFamily="34" charset="-120"/>
-              </a:rPr>
-              <a:t>The banks, oil majors and state financiers shaping Kenya's energy future — each measured against their own public climate promises, and scored, with sources to follow.</a:t>
+                  <a:srgbClr val="1D2621"/>
+                </a:solidFill>
+                <a:latin typeface="Calibri" pitchFamily="34" charset="0"/>
+                <a:ea typeface="Calibri" pitchFamily="34" charset="-122"/>
+                <a:cs typeface="Calibri" pitchFamily="34" charset="-120"/>
+              </a:rPr>
+              <a:t>Fund a documentation partner in a top-gap county</a:t>
             </a:r>
             <a:endParaRPr lang="en-US" sz="1400" dirty="0"/>
           </a:p>
-        </p:txBody>
-      </p:sp>
-      <p:sp>
-        <p:nvSpPr>
-          <p:cNvPr id="5" name="Shape 3"/>
-          <p:cNvSpPr/>
-          <p:nvPr/>
-        </p:nvSpPr>
-        <p:spPr>
-          <a:xfrm>
-            <a:off x="548640" y="2468880"/>
-            <a:ext cx="3611880" cy="2834640"/>
+          <a:p>
+            <a:pPr marL="203200" indent="-203200">
+              <a:spcAft>
+                <a:spcPts val="1000"/>
+              </a:spcAft>
+              <a:buSzPct val="100000"/>
+              <a:buChar char="•"/>
+            </a:pPr>
+            <a:r>
+              <a:rPr lang="en-US" sz="1400" dirty="0">
+                <a:solidFill>
+                  <a:srgbClr val="1D2621"/>
+                </a:solidFill>
+                <a:latin typeface="Calibri" pitchFamily="34" charset="0"/>
+                <a:ea typeface="Calibri" pitchFamily="34" charset="-122"/>
+                <a:cs typeface="Calibri" pitchFamily="34" charset="-120"/>
+              </a:rPr>
+              <a:t>Back a live legal matter through to judgment</a:t>
+            </a:r>
+            <a:endParaRPr lang="en-US" sz="1400" dirty="0"/>
+          </a:p>
+          <a:p>
+            <a:pPr marL="203200" indent="-203200">
+              <a:buSzPct val="100000"/>
+              <a:buChar char="•"/>
+            </a:pPr>
+            <a:r>
+              <a:rPr lang="en-US" sz="1400" dirty="0">
+                <a:solidFill>
+                  <a:srgbClr val="1D2621"/>
+                </a:solidFill>
+                <a:latin typeface="Calibri" pitchFamily="34" charset="0"/>
+                <a:ea typeface="Calibri" pitchFamily="34" charset="-122"/>
+                <a:cs typeface="Calibri" pitchFamily="34" charset="-120"/>
+              </a:rPr>
+              <a:t>Support the coalition secretariat that keeps it current</a:t>
+            </a:r>
+            <a:endParaRPr lang="en-US" sz="1400" dirty="0"/>
+          </a:p>
+        </p:txBody>
+      </p:sp>
+      <p:sp>
+        <p:nvSpPr>
+          <p:cNvPr id="6" name="Shape 4"/>
+          <p:cNvSpPr/>
+          <p:nvPr/>
+        </p:nvSpPr>
+        <p:spPr>
+          <a:xfrm>
+            <a:off x="6400800" y="1554480"/>
+            <a:ext cx="2487168" cy="2103120"/>
           </a:xfrm>
           <a:prstGeom prst="roundRect">
             <a:avLst>
-              <a:gd name="adj" fmla="val 2581"/>
+              <a:gd name="adj" fmla="val 3478"/>
             </a:avLst>
           </a:prstGeom>
           <a:solidFill>
-            <a:srgbClr val="F1F5F3"/>
+            <a:srgbClr val="FFFFFF"/>
           </a:solidFill>
           <a:ln w="9525">
             <a:solidFill>
@@ -9069,34 +9834,14 @@
       </p:sp>
       <p:sp>
         <p:nvSpPr>
-          <p:cNvPr id="6" name="Shape 4"/>
-          <p:cNvSpPr/>
-          <p:nvPr/>
-        </p:nvSpPr>
-        <p:spPr>
-          <a:xfrm>
-            <a:off x="2029968" y="2697480"/>
-            <a:ext cx="640080" cy="640080"/>
-          </a:xfrm>
-          <a:prstGeom prst="ellipse">
-            <a:avLst/>
-          </a:prstGeom>
-          <a:solidFill>
-            <a:srgbClr val="1B6B4A"/>
-          </a:solidFill>
-          <a:ln/>
-        </p:spPr>
-      </p:sp>
-      <p:sp>
-        <p:nvSpPr>
           <p:cNvPr id="7" name="Text 5"/>
           <p:cNvSpPr/>
           <p:nvPr/>
         </p:nvSpPr>
         <p:spPr>
           <a:xfrm>
-            <a:off x="731520" y="3429000"/>
-            <a:ext cx="3246120" cy="457200"/>
+            <a:off x="6492240" y="1719072"/>
+            <a:ext cx="2304288" cy="822960"/>
           </a:xfrm>
           <a:prstGeom prst="rect">
             <a:avLst/>
@@ -9112,17 +9857,17 @@
               <a:buNone/>
             </a:pPr>
             <a:r>
-              <a:rPr lang="en-US" sz="1800" b="1" dirty="0">
-                <a:solidFill>
-                  <a:srgbClr val="1D2621"/>
-                </a:solidFill>
-                <a:latin typeface="Calibri" pitchFamily="34" charset="0"/>
-                <a:ea typeface="Calibri" pitchFamily="34" charset="-122"/>
-                <a:cs typeface="Calibri" pitchFamily="34" charset="-120"/>
-              </a:rPr>
-              <a:t>Kept</a:t>
-            </a:r>
-            <a:endParaRPr lang="en-US" sz="1800" dirty="0"/>
+              <a:rPr lang="en-US" sz="3400" b="1" dirty="0">
+                <a:solidFill>
+                  <a:srgbClr val="1B6B4A"/>
+                </a:solidFill>
+                <a:latin typeface="Cambria" pitchFamily="34" charset="0"/>
+                <a:ea typeface="Cambria" pitchFamily="34" charset="-122"/>
+                <a:cs typeface="Cambria" pitchFamily="34" charset="-120"/>
+              </a:rPr>
+              <a:t>47</a:t>
+            </a:r>
+            <a:endParaRPr lang="en-US" sz="3400" dirty="0"/>
           </a:p>
         </p:txBody>
       </p:sp>
@@ -9134,8 +9879,8 @@
         </p:nvSpPr>
         <p:spPr>
           <a:xfrm>
-            <a:off x="804672" y="3886200"/>
-            <a:ext cx="3108960" cy="1280160"/>
+            <a:off x="6510528" y="2514600"/>
+            <a:ext cx="2267712" cy="1097280"/>
           </a:xfrm>
           <a:prstGeom prst="rect">
             <a:avLst/>
@@ -9151,7 +9896,7 @@
               <a:buNone/>
             </a:pPr>
             <a:r>
-              <a:rPr lang="en-US" sz="1200" dirty="0">
+              <a:rPr lang="en-US" sz="1100" dirty="0">
                 <a:solidFill>
                   <a:srgbClr val="5D6B63"/>
                 </a:solidFill>
@@ -9159,9 +9904,9 @@
                 <a:ea typeface="Calibri" pitchFamily="34" charset="-122"/>
                 <a:cs typeface="Calibri" pitchFamily="34" charset="-120"/>
               </a:rPr>
-              <a:t>Promise matched by action — e.g. a bank declining to finance EACOP</a:t>
-            </a:r>
-            <a:endParaRPr lang="en-US" sz="1200" dirty="0"/>
+              <a:t>counties, one gap-ranked view</a:t>
+            </a:r>
+            <a:endParaRPr lang="en-US" sz="1100" dirty="0"/>
           </a:p>
         </p:txBody>
       </p:sp>
@@ -9173,16 +9918,16 @@
         </p:nvSpPr>
         <p:spPr>
           <a:xfrm>
-            <a:off x="4261104" y="2468880"/>
-            <a:ext cx="3611880" cy="2834640"/>
+            <a:off x="9052560" y="1554480"/>
+            <a:ext cx="2487168" cy="2103120"/>
           </a:xfrm>
           <a:prstGeom prst="roundRect">
             <a:avLst>
-              <a:gd name="adj" fmla="val 2581"/>
+              <a:gd name="adj" fmla="val 3478"/>
             </a:avLst>
           </a:prstGeom>
           <a:solidFill>
-            <a:srgbClr val="F1F5F3"/>
+            <a:srgbClr val="FFFFFF"/>
           </a:solidFill>
           <a:ln w="9525">
             <a:solidFill>
@@ -9201,23 +9946,42 @@
       </p:sp>
       <p:sp>
         <p:nvSpPr>
-          <p:cNvPr id="10" name="Shape 8"/>
-          <p:cNvSpPr/>
-          <p:nvPr/>
-        </p:nvSpPr>
-        <p:spPr>
-          <a:xfrm>
-            <a:off x="5742432" y="2697480"/>
-            <a:ext cx="640080" cy="640080"/>
-          </a:xfrm>
-          <a:prstGeom prst="ellipse">
-            <a:avLst/>
-          </a:prstGeom>
-          <a:solidFill>
-            <a:srgbClr val="EE9455"/>
-          </a:solidFill>
-          <a:ln/>
-        </p:spPr>
+          <p:cNvPr id="10" name="Text 8"/>
+          <p:cNvSpPr/>
+          <p:nvPr/>
+        </p:nvSpPr>
+        <p:spPr>
+          <a:xfrm>
+            <a:off x="9144000" y="1719072"/>
+            <a:ext cx="2304288" cy="822960"/>
+          </a:xfrm>
+          <a:prstGeom prst="rect">
+            <a:avLst/>
+          </a:prstGeom>
+          <a:noFill/>
+          <a:ln/>
+        </p:spPr>
+        <p:txBody>
+          <a:bodyPr wrap="square" lIns="0" tIns="0" rIns="0" bIns="0" rtlCol="0" anchor="ctr"/>
+          <a:lstStyle/>
+          <a:p>
+            <a:pPr algn="ctr" indent="0" marL="0">
+              <a:buNone/>
+            </a:pPr>
+            <a:r>
+              <a:rPr lang="en-US" sz="3400" b="1" dirty="0">
+                <a:solidFill>
+                  <a:srgbClr val="EE9455"/>
+                </a:solidFill>
+                <a:latin typeface="Cambria" pitchFamily="34" charset="0"/>
+                <a:ea typeface="Cambria" pitchFamily="34" charset="-122"/>
+                <a:cs typeface="Cambria" pitchFamily="34" charset="-120"/>
+              </a:rPr>
+              <a:t>3</a:t>
+            </a:r>
+            <a:endParaRPr lang="en-US" sz="3400" dirty="0"/>
+          </a:p>
+        </p:txBody>
       </p:sp>
       <p:sp>
         <p:nvSpPr>
@@ -9227,63 +9991,24 @@
         </p:nvSpPr>
         <p:spPr>
           <a:xfrm>
-            <a:off x="4443984" y="3429000"/>
-            <a:ext cx="3246120" cy="457200"/>
-          </a:xfrm>
-          <a:prstGeom prst="rect">
-            <a:avLst/>
-          </a:prstGeom>
-          <a:noFill/>
-          <a:ln/>
-        </p:spPr>
-        <p:txBody>
-          <a:bodyPr wrap="square" lIns="0" tIns="0" rIns="0" bIns="0" rtlCol="0" anchor="ctr"/>
+            <a:off x="9162288" y="2514600"/>
+            <a:ext cx="2267712" cy="1097280"/>
+          </a:xfrm>
+          <a:prstGeom prst="rect">
+            <a:avLst/>
+          </a:prstGeom>
+          <a:noFill/>
+          <a:ln/>
+        </p:spPr>
+        <p:txBody>
+          <a:bodyPr wrap="square" lIns="0" tIns="0" rIns="0" bIns="0" rtlCol="0" anchor="t"/>
           <a:lstStyle/>
           <a:p>
             <a:pPr algn="ctr" indent="0" marL="0">
               <a:buNone/>
             </a:pPr>
             <a:r>
-              <a:rPr lang="en-US" sz="1800" b="1" dirty="0">
-                <a:solidFill>
-                  <a:srgbClr val="1D2621"/>
-                </a:solidFill>
-                <a:latin typeface="Calibri" pitchFamily="34" charset="0"/>
-                <a:ea typeface="Calibri" pitchFamily="34" charset="-122"/>
-                <a:cs typeface="Calibri" pitchFamily="34" charset="-120"/>
-              </a:rPr>
-              <a:t>Partial</a:t>
-            </a:r>
-            <a:endParaRPr lang="en-US" sz="1800" dirty="0"/>
-          </a:p>
-        </p:txBody>
-      </p:sp>
-      <p:sp>
-        <p:nvSpPr>
-          <p:cNvPr id="12" name="Text 10"/>
-          <p:cNvSpPr/>
-          <p:nvPr/>
-        </p:nvSpPr>
-        <p:spPr>
-          <a:xfrm>
-            <a:off x="4517136" y="3886200"/>
-            <a:ext cx="3108960" cy="1280160"/>
-          </a:xfrm>
-          <a:prstGeom prst="rect">
-            <a:avLst/>
-          </a:prstGeom>
-          <a:noFill/>
-          <a:ln/>
-        </p:spPr>
-        <p:txBody>
-          <a:bodyPr wrap="square" lIns="0" tIns="0" rIns="0" bIns="0" rtlCol="0" anchor="t"/>
-          <a:lstStyle/>
-          <a:p>
-            <a:pPr algn="ctr" indent="0" marL="0">
-              <a:buNone/>
-            </a:pPr>
-            <a:r>
-              <a:rPr lang="en-US" sz="1200" dirty="0">
+              <a:rPr lang="en-US" sz="1100" dirty="0">
                 <a:solidFill>
                   <a:srgbClr val="5D6B63"/>
                 </a:solidFill>
@@ -9291,30 +10016,30 @@
                 <a:ea typeface="Calibri" pitchFamily="34" charset="-122"/>
                 <a:cs typeface="Calibri" pitchFamily="34" charset="-120"/>
               </a:rPr>
-              <a:t>Real movement, real gaps — e.g. a coal pledge with a legacy pipeline</a:t>
-            </a:r>
-            <a:endParaRPr lang="en-US" sz="1200" dirty="0"/>
-          </a:p>
-        </p:txBody>
-      </p:sp>
-      <p:sp>
-        <p:nvSpPr>
-          <p:cNvPr id="13" name="Shape 11"/>
-          <p:cNvSpPr/>
-          <p:nvPr/>
-        </p:nvSpPr>
-        <p:spPr>
-          <a:xfrm>
-            <a:off x="7973568" y="2468880"/>
-            <a:ext cx="3611880" cy="2834640"/>
+              <a:t>languages, public + members</a:t>
+            </a:r>
+            <a:endParaRPr lang="en-US" sz="1100" dirty="0"/>
+          </a:p>
+        </p:txBody>
+      </p:sp>
+      <p:sp>
+        <p:nvSpPr>
+          <p:cNvPr id="12" name="Shape 10"/>
+          <p:cNvSpPr/>
+          <p:nvPr/>
+        </p:nvSpPr>
+        <p:spPr>
+          <a:xfrm>
+            <a:off x="6400800" y="3794760"/>
+            <a:ext cx="5138928" cy="1920240"/>
           </a:xfrm>
           <a:prstGeom prst="roundRect">
             <a:avLst>
-              <a:gd name="adj" fmla="val 2581"/>
+              <a:gd name="adj" fmla="val 3810"/>
             </a:avLst>
           </a:prstGeom>
           <a:solidFill>
-            <a:srgbClr val="F1F5F3"/>
+            <a:srgbClr val="FFFFFF"/>
           </a:solidFill>
           <a:ln w="9525">
             <a:solidFill>
@@ -9333,105 +10058,85 @@
       </p:sp>
       <p:sp>
         <p:nvSpPr>
-          <p:cNvPr id="14" name="Shape 12"/>
-          <p:cNvSpPr/>
-          <p:nvPr/>
-        </p:nvSpPr>
-        <p:spPr>
-          <a:xfrm>
-            <a:off x="9454896" y="2697480"/>
-            <a:ext cx="640080" cy="640080"/>
-          </a:xfrm>
-          <a:prstGeom prst="ellipse">
-            <a:avLst/>
-          </a:prstGeom>
-          <a:solidFill>
-            <a:srgbClr val="EE9455"/>
-          </a:solidFill>
-          <a:ln/>
-        </p:spPr>
+          <p:cNvPr id="13" name="Text 11"/>
+          <p:cNvSpPr/>
+          <p:nvPr/>
+        </p:nvSpPr>
+        <p:spPr>
+          <a:xfrm>
+            <a:off x="6492240" y="3959352"/>
+            <a:ext cx="4956048" cy="822960"/>
+          </a:xfrm>
+          <a:prstGeom prst="rect">
+            <a:avLst/>
+          </a:prstGeom>
+          <a:noFill/>
+          <a:ln/>
+        </p:spPr>
+        <p:txBody>
+          <a:bodyPr wrap="square" lIns="0" tIns="0" rIns="0" bIns="0" rtlCol="0" anchor="ctr"/>
+          <a:lstStyle/>
+          <a:p>
+            <a:pPr algn="ctr" indent="0" marL="0">
+              <a:buNone/>
+            </a:pPr>
+            <a:r>
+              <a:rPr lang="en-US" sz="3400" b="1" dirty="0">
+                <a:solidFill>
+                  <a:srgbClr val="2C7A55"/>
+                </a:solidFill>
+                <a:latin typeface="Cambria" pitchFamily="34" charset="0"/>
+                <a:ea typeface="Cambria" pitchFamily="34" charset="-122"/>
+                <a:cs typeface="Cambria" pitchFamily="34" charset="-120"/>
+              </a:rPr>
+              <a:t>Export</a:t>
+            </a:r>
+            <a:endParaRPr lang="en-US" sz="3400" dirty="0"/>
+          </a:p>
+        </p:txBody>
+      </p:sp>
+      <p:sp>
+        <p:nvSpPr>
+          <p:cNvPr id="14" name="Text 12"/>
+          <p:cNvSpPr/>
+          <p:nvPr/>
+        </p:nvSpPr>
+        <p:spPr>
+          <a:xfrm>
+            <a:off x="6510528" y="4754880"/>
+            <a:ext cx="4919472" cy="914400"/>
+          </a:xfrm>
+          <a:prstGeom prst="rect">
+            <a:avLst/>
+          </a:prstGeom>
+          <a:noFill/>
+          <a:ln/>
+        </p:spPr>
+        <p:txBody>
+          <a:bodyPr wrap="square" lIns="0" tIns="0" rIns="0" bIns="0" rtlCol="0" anchor="t"/>
+          <a:lstStyle/>
+          <a:p>
+            <a:pPr algn="ctr" indent="0" marL="0">
+              <a:buNone/>
+            </a:pPr>
+            <a:r>
+              <a:rPr lang="en-US" sz="1100" dirty="0">
+                <a:solidFill>
+                  <a:srgbClr val="5D6B63"/>
+                </a:solidFill>
+                <a:latin typeface="Calibri" pitchFamily="34" charset="0"/>
+                <a:ea typeface="Calibri" pitchFamily="34" charset="-122"/>
+                <a:cs typeface="Calibri" pitchFamily="34" charset="-120"/>
+              </a:rPr>
+              <a:t>reach · coverage · engagement, on demand</a:t>
+            </a:r>
+            <a:endParaRPr lang="en-US" sz="1100" dirty="0"/>
+          </a:p>
+        </p:txBody>
       </p:sp>
       <p:sp>
         <p:nvSpPr>
           <p:cNvPr id="15" name="Text 13"/>
-          <p:cNvSpPr/>
-          <p:nvPr/>
-        </p:nvSpPr>
-        <p:spPr>
-          <a:xfrm>
-            <a:off x="8156448" y="3429000"/>
-            <a:ext cx="3246120" cy="457200"/>
-          </a:xfrm>
-          <a:prstGeom prst="rect">
-            <a:avLst/>
-          </a:prstGeom>
-          <a:noFill/>
-          <a:ln/>
-        </p:spPr>
-        <p:txBody>
-          <a:bodyPr wrap="square" lIns="0" tIns="0" rIns="0" bIns="0" rtlCol="0" anchor="ctr"/>
-          <a:lstStyle/>
-          <a:p>
-            <a:pPr algn="ctr" indent="0" marL="0">
-              <a:buNone/>
-            </a:pPr>
-            <a:r>
-              <a:rPr lang="en-US" sz="1800" b="1" dirty="0">
-                <a:solidFill>
-                  <a:srgbClr val="1D2621"/>
-                </a:solidFill>
-                <a:latin typeface="Calibri" pitchFamily="34" charset="0"/>
-                <a:ea typeface="Calibri" pitchFamily="34" charset="-122"/>
-                <a:cs typeface="Calibri" pitchFamily="34" charset="-120"/>
-              </a:rPr>
-              <a:t>Lip-service</a:t>
-            </a:r>
-            <a:endParaRPr lang="en-US" sz="1800" dirty="0"/>
-          </a:p>
-        </p:txBody>
-      </p:sp>
-      <p:sp>
-        <p:nvSpPr>
-          <p:cNvPr id="16" name="Text 14"/>
-          <p:cNvSpPr/>
-          <p:nvPr/>
-        </p:nvSpPr>
-        <p:spPr>
-          <a:xfrm>
-            <a:off x="8229600" y="3886200"/>
-            <a:ext cx="3108960" cy="1280160"/>
-          </a:xfrm>
-          <a:prstGeom prst="rect">
-            <a:avLst/>
-          </a:prstGeom>
-          <a:noFill/>
-          <a:ln/>
-        </p:spPr>
-        <p:txBody>
-          <a:bodyPr wrap="square" lIns="0" tIns="0" rIns="0" bIns="0" rtlCol="0" anchor="t"/>
-          <a:lstStyle/>
-          <a:p>
-            <a:pPr algn="ctr" indent="0" marL="0">
-              <a:buNone/>
-            </a:pPr>
-            <a:r>
-              <a:rPr lang="en-US" sz="1200" dirty="0">
-                <a:solidFill>
-                  <a:srgbClr val="5D6B63"/>
-                </a:solidFill>
-                <a:latin typeface="Calibri" pitchFamily="34" charset="0"/>
-                <a:ea typeface="Calibri" pitchFamily="34" charset="-122"/>
-                <a:cs typeface="Calibri" pitchFamily="34" charset="-120"/>
-              </a:rPr>
-              <a:t>A claim, not conduct — e.g. “net zero” that ignores 85% of emissions</a:t>
-            </a:r>
-            <a:endParaRPr lang="en-US" sz="1200" dirty="0"/>
-          </a:p>
-        </p:txBody>
-      </p:sp>
-      <p:sp>
-        <p:nvSpPr>
-          <p:cNvPr id="17" name="Text 15"/>
           <p:cNvSpPr/>
           <p:nvPr/>
         </p:nvSpPr>

</xml_diff>

<commit_message>
Match & notify on live opportunities + auto-notify on accept; deck brokering slide
</commit_message>
<xml_diff>
--- a/MazingiraKenya-Partner-Pitch.pptx
+++ b/MazingiraKenya-Partner-Pitch.pptx
@@ -17,9 +17,10 @@
     <p:sldId id="265" r:id="rId11"/>
     <p:sldId id="266" r:id="rId12"/>
     <p:sldId id="267" r:id="rId13"/>
+    <p:sldId id="268" r:id="rId14"/>
   </p:sldIdLst>
   <p:notesMasterIdLst>
-    <p:notesMasterId r:id="rId14"/>
+    <p:notesMasterId r:id="rId15"/>
   </p:notesMasterIdLst>
   <p:sldSz cx="12192000" cy="6858000"/>
   <p:notesSz cx="6858000" cy="12192000"/>
@@ -801,6 +802,94 @@
             <a:fld id="{F7021451-1387-4CA6-816F-3879F97B5CBC}" type="slidenum">
               <a:rPr lang="en-US"/>
               <a:t>12</a:t>
+            </a:fld>
+            <a:endParaRPr lang="en-US"/>
+          </a:p>
+        </p:txBody>
+      </p:sp>
+    </p:spTree>
+    <p:extLst>
+      <p:ext uri="{BB962C8B-B14F-4D97-AF65-F5344CB8AC3E}">
+        <p14:creationId xmlns:p14="http://schemas.microsoft.com/office/powerpoint/2010/main" val="1024086991"/>
+      </p:ext>
+    </p:extLst>
+  </p:cSld>
+  <p:clrMapOvr>
+    <a:masterClrMapping/>
+  </p:clrMapOvr>
+</p:notes>
+</file>
+
+<file path=ppt/notesSlides/notesSlide13.xml><?xml version="1.0" encoding="utf-8"?>
+<p:notes xmlns:a="http://schemas.openxmlformats.org/drawingml/2006/main" xmlns:r="http://schemas.openxmlformats.org/officeDocument/2006/relationships" xmlns:p="http://schemas.openxmlformats.org/presentationml/2006/main">
+  <p:cSld>
+    <p:spTree>
+      <p:nvGrpSpPr>
+        <p:cNvPr id="1" name=""/>
+        <p:cNvGrpSpPr/>
+        <p:nvPr/>
+      </p:nvGrpSpPr>
+      <p:grpSpPr>
+        <a:xfrm>
+          <a:off x="0" y="0"/>
+          <a:ext cx="0" cy="0"/>
+          <a:chOff x="0" y="0"/>
+          <a:chExt cx="0" cy="0"/>
+        </a:xfrm>
+      </p:grpSpPr>
+      <p:sp>
+        <p:nvSpPr>
+          <p:cNvPr id="2" name="Slide Image Placeholder 1"/>
+          <p:cNvSpPr>
+            <a:spLocks noGrp="1" noRot="1" noChangeAspect="1"/>
+          </p:cNvSpPr>
+          <p:nvPr>
+            <p:ph type="sldImg"/>
+          </p:nvPr>
+        </p:nvSpPr>
+        <p:spPr/>
+      </p:sp>
+      <p:sp>
+        <p:nvSpPr>
+          <p:cNvPr id="3" name="Notes Placeholder 2"/>
+          <p:cNvSpPr>
+            <a:spLocks noGrp="1"/>
+          </p:cNvSpPr>
+          <p:nvPr>
+            <p:ph type="body" idx="1"/>
+          </p:nvPr>
+        </p:nvSpPr>
+        <p:spPr/>
+        <p:txBody>
+          <a:bodyPr/>
+          <a:lstStyle/>
+          <a:p>
+            <a:r>
+              <a:rPr lang="en-US" dirty="0"/>
+              <a:t/>
+            </a:r>
+            <a:endParaRPr lang="en-US" dirty="0"/>
+          </a:p>
+        </p:txBody>
+      </p:sp>
+      <p:sp>
+        <p:nvSpPr>
+          <p:cNvPr id="4" name="Slide Number Placeholder 3"/>
+          <p:cNvSpPr>
+            <a:spLocks noGrp="1"/>
+          </p:cNvSpPr>
+          <p:nvPr>
+            <p:ph type="sldNum" sz="quarter" idx="10"/>
+          </p:nvPr>
+        </p:nvSpPr>
+        <p:spPr/>
+        <p:txBody>
+          <a:bodyPr/>
+          <a:lstStyle/>
+          <a:p>
+            <a:fld id="{F7021451-1387-4CA6-816F-3879F97B5CBC}" type="slidenum">
+              <a:rPr lang="en-US"/>
+              <a:t>13</a:t>
             </a:fld>
             <a:endParaRPr lang="en-US"/>
           </a:p>
@@ -2118,7 +2207,7 @@
                 <a:ea typeface="Calibri" pitchFamily="34" charset="-122"/>
                 <a:cs typeface="Calibri" pitchFamily="34" charset="-120"/>
               </a:rPr>
-              <a:t>THE RECEIPTS</a:t>
+              <a:t>FOR FUNDERS</a:t>
             </a:r>
             <a:endParaRPr lang="en-US" sz="1200" dirty="0"/>
           </a:p>
@@ -2157,7 +2246,7 @@
                 <a:ea typeface="Cambria" pitchFamily="34" charset="-122"/>
                 <a:cs typeface="Cambria" pitchFamily="34" charset="-120"/>
               </a:rPr>
-              <a:t>An accountability index with sources</a:t>
+              <a:t>Where a marginal shilling moves the needle</a:t>
             </a:r>
             <a:endParaRPr lang="en-US" sz="3000" dirty="0"/>
           </a:p>
@@ -2171,8 +2260,8 @@
         </p:nvSpPr>
         <p:spPr>
           <a:xfrm>
-            <a:off x="548640" y="1417320"/>
-            <a:ext cx="10972800" cy="822960"/>
+            <a:off x="548640" y="1463040"/>
+            <a:ext cx="5486400" cy="2194560"/>
           </a:xfrm>
           <a:prstGeom prst="rect">
             <a:avLst/>
@@ -2188,38 +2277,120 @@
               <a:buNone/>
             </a:pPr>
             <a:r>
+              <a:rPr lang="en-US" sz="1500" dirty="0">
+                <a:solidFill>
+                  <a:srgbClr val="5D6B63"/>
+                </a:solidFill>
+                <a:latin typeface="Calibri" pitchFamily="34" charset="0"/>
+                <a:ea typeface="Calibri" pitchFamily="34" charset="-122"/>
+                <a:cs typeface="Calibri" pitchFamily="34" charset="-120"/>
+              </a:rPr>
+              <a:t>The map ranks counties by response gap and the platform exports reach, coverage and engagement data — so you fund live programme activity, not a retrospective annual report.</a:t>
+            </a:r>
+            <a:endParaRPr lang="en-US" sz="1500" dirty="0"/>
+          </a:p>
+        </p:txBody>
+      </p:sp>
+      <p:sp>
+        <p:nvSpPr>
+          <p:cNvPr id="5" name="Text 3"/>
+          <p:cNvSpPr/>
+          <p:nvPr/>
+        </p:nvSpPr>
+        <p:spPr>
+          <a:xfrm>
+            <a:off x="640080" y="3657600"/>
+            <a:ext cx="5394960" cy="2194560"/>
+          </a:xfrm>
+          <a:prstGeom prst="rect">
+            <a:avLst/>
+          </a:prstGeom>
+          <a:noFill/>
+          <a:ln/>
+        </p:spPr>
+        <p:txBody>
+          <a:bodyPr wrap="square" lIns="0" tIns="0" rIns="0" bIns="0" rtlCol="0" anchor="ctr"/>
+          <a:lstStyle/>
+          <a:p>
+            <a:pPr marL="203200" indent="-203200">
+              <a:spcAft>
+                <a:spcPts val="1000"/>
+              </a:spcAft>
+              <a:buSzPct val="100000"/>
+              <a:buChar char="•"/>
+            </a:pPr>
+            <a:r>
               <a:rPr lang="en-US" sz="1400" dirty="0">
                 <a:solidFill>
-                  <a:srgbClr val="5D6B63"/>
-                </a:solidFill>
-                <a:latin typeface="Calibri" pitchFamily="34" charset="0"/>
-                <a:ea typeface="Calibri" pitchFamily="34" charset="-122"/>
-                <a:cs typeface="Calibri" pitchFamily="34" charset="-120"/>
-              </a:rPr>
-              <a:t>The banks, oil majors and state financiers shaping Kenya's energy future — each measured against their own public climate promises, and scored, with sources to follow.</a:t>
+                  <a:srgbClr val="1D2621"/>
+                </a:solidFill>
+                <a:latin typeface="Calibri" pitchFamily="34" charset="0"/>
+                <a:ea typeface="Calibri" pitchFamily="34" charset="-122"/>
+                <a:cs typeface="Calibri" pitchFamily="34" charset="-120"/>
+              </a:rPr>
+              <a:t>Fund a documentation partner in a top-gap county</a:t>
             </a:r>
             <a:endParaRPr lang="en-US" sz="1400" dirty="0"/>
           </a:p>
-        </p:txBody>
-      </p:sp>
-      <p:sp>
-        <p:nvSpPr>
-          <p:cNvPr id="5" name="Shape 3"/>
-          <p:cNvSpPr/>
-          <p:nvPr/>
-        </p:nvSpPr>
-        <p:spPr>
-          <a:xfrm>
-            <a:off x="548640" y="2468880"/>
-            <a:ext cx="3611880" cy="2834640"/>
+          <a:p>
+            <a:pPr marL="203200" indent="-203200">
+              <a:spcAft>
+                <a:spcPts val="1000"/>
+              </a:spcAft>
+              <a:buSzPct val="100000"/>
+              <a:buChar char="•"/>
+            </a:pPr>
+            <a:r>
+              <a:rPr lang="en-US" sz="1400" dirty="0">
+                <a:solidFill>
+                  <a:srgbClr val="1D2621"/>
+                </a:solidFill>
+                <a:latin typeface="Calibri" pitchFamily="34" charset="0"/>
+                <a:ea typeface="Calibri" pitchFamily="34" charset="-122"/>
+                <a:cs typeface="Calibri" pitchFamily="34" charset="-120"/>
+              </a:rPr>
+              <a:t>Back a live legal matter through to judgment</a:t>
+            </a:r>
+            <a:endParaRPr lang="en-US" sz="1400" dirty="0"/>
+          </a:p>
+          <a:p>
+            <a:pPr marL="203200" indent="-203200">
+              <a:buSzPct val="100000"/>
+              <a:buChar char="•"/>
+            </a:pPr>
+            <a:r>
+              <a:rPr lang="en-US" sz="1400" dirty="0">
+                <a:solidFill>
+                  <a:srgbClr val="1D2621"/>
+                </a:solidFill>
+                <a:latin typeface="Calibri" pitchFamily="34" charset="0"/>
+                <a:ea typeface="Calibri" pitchFamily="34" charset="-122"/>
+                <a:cs typeface="Calibri" pitchFamily="34" charset="-120"/>
+              </a:rPr>
+              <a:t>Support the coalition secretariat that keeps it current</a:t>
+            </a:r>
+            <a:endParaRPr lang="en-US" sz="1400" dirty="0"/>
+          </a:p>
+        </p:txBody>
+      </p:sp>
+      <p:sp>
+        <p:nvSpPr>
+          <p:cNvPr id="6" name="Shape 4"/>
+          <p:cNvSpPr/>
+          <p:nvPr/>
+        </p:nvSpPr>
+        <p:spPr>
+          <a:xfrm>
+            <a:off x="6400800" y="1554480"/>
+            <a:ext cx="2487168" cy="2103120"/>
           </a:xfrm>
           <a:prstGeom prst="roundRect">
             <a:avLst>
-              <a:gd name="adj" fmla="val 2581"/>
+              <a:gd name="adj" fmla="val 3478"/>
             </a:avLst>
           </a:prstGeom>
           <a:solidFill>
-            <a:srgbClr val="F1F5F3"/>
+            <a:srgbClr val="FFFFFF"/>
           </a:solidFill>
           <a:ln w="9525">
             <a:solidFill>
@@ -2238,34 +2409,14 @@
       </p:sp>
       <p:sp>
         <p:nvSpPr>
-          <p:cNvPr id="6" name="Shape 4"/>
-          <p:cNvSpPr/>
-          <p:nvPr/>
-        </p:nvSpPr>
-        <p:spPr>
-          <a:xfrm>
-            <a:off x="2029968" y="2697480"/>
-            <a:ext cx="640080" cy="640080"/>
-          </a:xfrm>
-          <a:prstGeom prst="ellipse">
-            <a:avLst/>
-          </a:prstGeom>
-          <a:solidFill>
-            <a:srgbClr val="1B6B4A"/>
-          </a:solidFill>
-          <a:ln/>
-        </p:spPr>
-      </p:sp>
-      <p:sp>
-        <p:nvSpPr>
           <p:cNvPr id="7" name="Text 5"/>
           <p:cNvSpPr/>
           <p:nvPr/>
         </p:nvSpPr>
         <p:spPr>
           <a:xfrm>
-            <a:off x="731520" y="3429000"/>
-            <a:ext cx="3246120" cy="457200"/>
+            <a:off x="6492240" y="1719072"/>
+            <a:ext cx="2304288" cy="822960"/>
           </a:xfrm>
           <a:prstGeom prst="rect">
             <a:avLst/>
@@ -2281,17 +2432,17 @@
               <a:buNone/>
             </a:pPr>
             <a:r>
-              <a:rPr lang="en-US" sz="1800" b="1" dirty="0">
-                <a:solidFill>
-                  <a:srgbClr val="1D2621"/>
-                </a:solidFill>
-                <a:latin typeface="Calibri" pitchFamily="34" charset="0"/>
-                <a:ea typeface="Calibri" pitchFamily="34" charset="-122"/>
-                <a:cs typeface="Calibri" pitchFamily="34" charset="-120"/>
-              </a:rPr>
-              <a:t>Kept</a:t>
-            </a:r>
-            <a:endParaRPr lang="en-US" sz="1800" dirty="0"/>
+              <a:rPr lang="en-US" sz="3400" b="1" dirty="0">
+                <a:solidFill>
+                  <a:srgbClr val="1B6B4A"/>
+                </a:solidFill>
+                <a:latin typeface="Cambria" pitchFamily="34" charset="0"/>
+                <a:ea typeface="Cambria" pitchFamily="34" charset="-122"/>
+                <a:cs typeface="Cambria" pitchFamily="34" charset="-120"/>
+              </a:rPr>
+              <a:t>47</a:t>
+            </a:r>
+            <a:endParaRPr lang="en-US" sz="3400" dirty="0"/>
           </a:p>
         </p:txBody>
       </p:sp>
@@ -2303,8 +2454,8 @@
         </p:nvSpPr>
         <p:spPr>
           <a:xfrm>
-            <a:off x="804672" y="3886200"/>
-            <a:ext cx="3108960" cy="1280160"/>
+            <a:off x="6510528" y="2514600"/>
+            <a:ext cx="2267712" cy="1097280"/>
           </a:xfrm>
           <a:prstGeom prst="rect">
             <a:avLst/>
@@ -2320,7 +2471,7 @@
               <a:buNone/>
             </a:pPr>
             <a:r>
-              <a:rPr lang="en-US" sz="1200" dirty="0">
+              <a:rPr lang="en-US" sz="1100" dirty="0">
                 <a:solidFill>
                   <a:srgbClr val="5D6B63"/>
                 </a:solidFill>
@@ -2328,9 +2479,9 @@
                 <a:ea typeface="Calibri" pitchFamily="34" charset="-122"/>
                 <a:cs typeface="Calibri" pitchFamily="34" charset="-120"/>
               </a:rPr>
-              <a:t>Promise matched by action — e.g. a bank declining to finance EACOP</a:t>
-            </a:r>
-            <a:endParaRPr lang="en-US" sz="1200" dirty="0"/>
+              <a:t>counties, one gap-ranked view</a:t>
+            </a:r>
+            <a:endParaRPr lang="en-US" sz="1100" dirty="0"/>
           </a:p>
         </p:txBody>
       </p:sp>
@@ -2342,16 +2493,16 @@
         </p:nvSpPr>
         <p:spPr>
           <a:xfrm>
-            <a:off x="4261104" y="2468880"/>
-            <a:ext cx="3611880" cy="2834640"/>
+            <a:off x="9052560" y="1554480"/>
+            <a:ext cx="2487168" cy="2103120"/>
           </a:xfrm>
           <a:prstGeom prst="roundRect">
             <a:avLst>
-              <a:gd name="adj" fmla="val 2581"/>
+              <a:gd name="adj" fmla="val 3478"/>
             </a:avLst>
           </a:prstGeom>
           <a:solidFill>
-            <a:srgbClr val="F1F5F3"/>
+            <a:srgbClr val="FFFFFF"/>
           </a:solidFill>
           <a:ln w="9525">
             <a:solidFill>
@@ -2370,23 +2521,42 @@
       </p:sp>
       <p:sp>
         <p:nvSpPr>
-          <p:cNvPr id="10" name="Shape 8"/>
-          <p:cNvSpPr/>
-          <p:nvPr/>
-        </p:nvSpPr>
-        <p:spPr>
-          <a:xfrm>
-            <a:off x="5742432" y="2697480"/>
-            <a:ext cx="640080" cy="640080"/>
-          </a:xfrm>
-          <a:prstGeom prst="ellipse">
-            <a:avLst/>
-          </a:prstGeom>
-          <a:solidFill>
-            <a:srgbClr val="EE9455"/>
-          </a:solidFill>
-          <a:ln/>
-        </p:spPr>
+          <p:cNvPr id="10" name="Text 8"/>
+          <p:cNvSpPr/>
+          <p:nvPr/>
+        </p:nvSpPr>
+        <p:spPr>
+          <a:xfrm>
+            <a:off x="9144000" y="1719072"/>
+            <a:ext cx="2304288" cy="822960"/>
+          </a:xfrm>
+          <a:prstGeom prst="rect">
+            <a:avLst/>
+          </a:prstGeom>
+          <a:noFill/>
+          <a:ln/>
+        </p:spPr>
+        <p:txBody>
+          <a:bodyPr wrap="square" lIns="0" tIns="0" rIns="0" bIns="0" rtlCol="0" anchor="ctr"/>
+          <a:lstStyle/>
+          <a:p>
+            <a:pPr algn="ctr" indent="0" marL="0">
+              <a:buNone/>
+            </a:pPr>
+            <a:r>
+              <a:rPr lang="en-US" sz="3400" b="1" dirty="0">
+                <a:solidFill>
+                  <a:srgbClr val="EE9455"/>
+                </a:solidFill>
+                <a:latin typeface="Cambria" pitchFamily="34" charset="0"/>
+                <a:ea typeface="Cambria" pitchFamily="34" charset="-122"/>
+                <a:cs typeface="Cambria" pitchFamily="34" charset="-120"/>
+              </a:rPr>
+              <a:t>3</a:t>
+            </a:r>
+            <a:endParaRPr lang="en-US" sz="3400" dirty="0"/>
+          </a:p>
+        </p:txBody>
       </p:sp>
       <p:sp>
         <p:nvSpPr>
@@ -2396,63 +2566,24 @@
         </p:nvSpPr>
         <p:spPr>
           <a:xfrm>
-            <a:off x="4443984" y="3429000"/>
-            <a:ext cx="3246120" cy="457200"/>
-          </a:xfrm>
-          <a:prstGeom prst="rect">
-            <a:avLst/>
-          </a:prstGeom>
-          <a:noFill/>
-          <a:ln/>
-        </p:spPr>
-        <p:txBody>
-          <a:bodyPr wrap="square" lIns="0" tIns="0" rIns="0" bIns="0" rtlCol="0" anchor="ctr"/>
+            <a:off x="9162288" y="2514600"/>
+            <a:ext cx="2267712" cy="1097280"/>
+          </a:xfrm>
+          <a:prstGeom prst="rect">
+            <a:avLst/>
+          </a:prstGeom>
+          <a:noFill/>
+          <a:ln/>
+        </p:spPr>
+        <p:txBody>
+          <a:bodyPr wrap="square" lIns="0" tIns="0" rIns="0" bIns="0" rtlCol="0" anchor="t"/>
           <a:lstStyle/>
           <a:p>
             <a:pPr algn="ctr" indent="0" marL="0">
               <a:buNone/>
             </a:pPr>
             <a:r>
-              <a:rPr lang="en-US" sz="1800" b="1" dirty="0">
-                <a:solidFill>
-                  <a:srgbClr val="1D2621"/>
-                </a:solidFill>
-                <a:latin typeface="Calibri" pitchFamily="34" charset="0"/>
-                <a:ea typeface="Calibri" pitchFamily="34" charset="-122"/>
-                <a:cs typeface="Calibri" pitchFamily="34" charset="-120"/>
-              </a:rPr>
-              <a:t>Partial</a:t>
-            </a:r>
-            <a:endParaRPr lang="en-US" sz="1800" dirty="0"/>
-          </a:p>
-        </p:txBody>
-      </p:sp>
-      <p:sp>
-        <p:nvSpPr>
-          <p:cNvPr id="12" name="Text 10"/>
-          <p:cNvSpPr/>
-          <p:nvPr/>
-        </p:nvSpPr>
-        <p:spPr>
-          <a:xfrm>
-            <a:off x="4517136" y="3886200"/>
-            <a:ext cx="3108960" cy="1280160"/>
-          </a:xfrm>
-          <a:prstGeom prst="rect">
-            <a:avLst/>
-          </a:prstGeom>
-          <a:noFill/>
-          <a:ln/>
-        </p:spPr>
-        <p:txBody>
-          <a:bodyPr wrap="square" lIns="0" tIns="0" rIns="0" bIns="0" rtlCol="0" anchor="t"/>
-          <a:lstStyle/>
-          <a:p>
-            <a:pPr algn="ctr" indent="0" marL="0">
-              <a:buNone/>
-            </a:pPr>
-            <a:r>
-              <a:rPr lang="en-US" sz="1200" dirty="0">
+              <a:rPr lang="en-US" sz="1100" dirty="0">
                 <a:solidFill>
                   <a:srgbClr val="5D6B63"/>
                 </a:solidFill>
@@ -2460,30 +2591,30 @@
                 <a:ea typeface="Calibri" pitchFamily="34" charset="-122"/>
                 <a:cs typeface="Calibri" pitchFamily="34" charset="-120"/>
               </a:rPr>
-              <a:t>Real movement, real gaps — e.g. a coal pledge with a legacy pipeline</a:t>
-            </a:r>
-            <a:endParaRPr lang="en-US" sz="1200" dirty="0"/>
-          </a:p>
-        </p:txBody>
-      </p:sp>
-      <p:sp>
-        <p:nvSpPr>
-          <p:cNvPr id="13" name="Shape 11"/>
-          <p:cNvSpPr/>
-          <p:nvPr/>
-        </p:nvSpPr>
-        <p:spPr>
-          <a:xfrm>
-            <a:off x="7973568" y="2468880"/>
-            <a:ext cx="3611880" cy="2834640"/>
+              <a:t>languages, public + members</a:t>
+            </a:r>
+            <a:endParaRPr lang="en-US" sz="1100" dirty="0"/>
+          </a:p>
+        </p:txBody>
+      </p:sp>
+      <p:sp>
+        <p:nvSpPr>
+          <p:cNvPr id="12" name="Shape 10"/>
+          <p:cNvSpPr/>
+          <p:nvPr/>
+        </p:nvSpPr>
+        <p:spPr>
+          <a:xfrm>
+            <a:off x="6400800" y="3794760"/>
+            <a:ext cx="5138928" cy="1920240"/>
           </a:xfrm>
           <a:prstGeom prst="roundRect">
             <a:avLst>
-              <a:gd name="adj" fmla="val 2581"/>
+              <a:gd name="adj" fmla="val 3810"/>
             </a:avLst>
           </a:prstGeom>
           <a:solidFill>
-            <a:srgbClr val="F1F5F3"/>
+            <a:srgbClr val="FFFFFF"/>
           </a:solidFill>
           <a:ln w="9525">
             <a:solidFill>
@@ -2502,105 +2633,85 @@
       </p:sp>
       <p:sp>
         <p:nvSpPr>
-          <p:cNvPr id="14" name="Shape 12"/>
-          <p:cNvSpPr/>
-          <p:nvPr/>
-        </p:nvSpPr>
-        <p:spPr>
-          <a:xfrm>
-            <a:off x="9454896" y="2697480"/>
-            <a:ext cx="640080" cy="640080"/>
-          </a:xfrm>
-          <a:prstGeom prst="ellipse">
-            <a:avLst/>
-          </a:prstGeom>
-          <a:solidFill>
-            <a:srgbClr val="EE9455"/>
-          </a:solidFill>
-          <a:ln/>
-        </p:spPr>
+          <p:cNvPr id="13" name="Text 11"/>
+          <p:cNvSpPr/>
+          <p:nvPr/>
+        </p:nvSpPr>
+        <p:spPr>
+          <a:xfrm>
+            <a:off x="6492240" y="3959352"/>
+            <a:ext cx="4956048" cy="822960"/>
+          </a:xfrm>
+          <a:prstGeom prst="rect">
+            <a:avLst/>
+          </a:prstGeom>
+          <a:noFill/>
+          <a:ln/>
+        </p:spPr>
+        <p:txBody>
+          <a:bodyPr wrap="square" lIns="0" tIns="0" rIns="0" bIns="0" rtlCol="0" anchor="ctr"/>
+          <a:lstStyle/>
+          <a:p>
+            <a:pPr algn="ctr" indent="0" marL="0">
+              <a:buNone/>
+            </a:pPr>
+            <a:r>
+              <a:rPr lang="en-US" sz="3400" b="1" dirty="0">
+                <a:solidFill>
+                  <a:srgbClr val="2C7A55"/>
+                </a:solidFill>
+                <a:latin typeface="Cambria" pitchFamily="34" charset="0"/>
+                <a:ea typeface="Cambria" pitchFamily="34" charset="-122"/>
+                <a:cs typeface="Cambria" pitchFamily="34" charset="-120"/>
+              </a:rPr>
+              <a:t>Export</a:t>
+            </a:r>
+            <a:endParaRPr lang="en-US" sz="3400" dirty="0"/>
+          </a:p>
+        </p:txBody>
+      </p:sp>
+      <p:sp>
+        <p:nvSpPr>
+          <p:cNvPr id="14" name="Text 12"/>
+          <p:cNvSpPr/>
+          <p:nvPr/>
+        </p:nvSpPr>
+        <p:spPr>
+          <a:xfrm>
+            <a:off x="6510528" y="4754880"/>
+            <a:ext cx="4919472" cy="914400"/>
+          </a:xfrm>
+          <a:prstGeom prst="rect">
+            <a:avLst/>
+          </a:prstGeom>
+          <a:noFill/>
+          <a:ln/>
+        </p:spPr>
+        <p:txBody>
+          <a:bodyPr wrap="square" lIns="0" tIns="0" rIns="0" bIns="0" rtlCol="0" anchor="t"/>
+          <a:lstStyle/>
+          <a:p>
+            <a:pPr algn="ctr" indent="0" marL="0">
+              <a:buNone/>
+            </a:pPr>
+            <a:r>
+              <a:rPr lang="en-US" sz="1100" dirty="0">
+                <a:solidFill>
+                  <a:srgbClr val="5D6B63"/>
+                </a:solidFill>
+                <a:latin typeface="Calibri" pitchFamily="34" charset="0"/>
+                <a:ea typeface="Calibri" pitchFamily="34" charset="-122"/>
+                <a:cs typeface="Calibri" pitchFamily="34" charset="-120"/>
+              </a:rPr>
+              <a:t>reach · coverage · engagement, on demand</a:t>
+            </a:r>
+            <a:endParaRPr lang="en-US" sz="1100" dirty="0"/>
+          </a:p>
+        </p:txBody>
       </p:sp>
       <p:sp>
         <p:nvSpPr>
           <p:cNvPr id="15" name="Text 13"/>
-          <p:cNvSpPr/>
-          <p:nvPr/>
-        </p:nvSpPr>
-        <p:spPr>
-          <a:xfrm>
-            <a:off x="8156448" y="3429000"/>
-            <a:ext cx="3246120" cy="457200"/>
-          </a:xfrm>
-          <a:prstGeom prst="rect">
-            <a:avLst/>
-          </a:prstGeom>
-          <a:noFill/>
-          <a:ln/>
-        </p:spPr>
-        <p:txBody>
-          <a:bodyPr wrap="square" lIns="0" tIns="0" rIns="0" bIns="0" rtlCol="0" anchor="ctr"/>
-          <a:lstStyle/>
-          <a:p>
-            <a:pPr algn="ctr" indent="0" marL="0">
-              <a:buNone/>
-            </a:pPr>
-            <a:r>
-              <a:rPr lang="en-US" sz="1800" b="1" dirty="0">
-                <a:solidFill>
-                  <a:srgbClr val="1D2621"/>
-                </a:solidFill>
-                <a:latin typeface="Calibri" pitchFamily="34" charset="0"/>
-                <a:ea typeface="Calibri" pitchFamily="34" charset="-122"/>
-                <a:cs typeface="Calibri" pitchFamily="34" charset="-120"/>
-              </a:rPr>
-              <a:t>Lip-service</a:t>
-            </a:r>
-            <a:endParaRPr lang="en-US" sz="1800" dirty="0"/>
-          </a:p>
-        </p:txBody>
-      </p:sp>
-      <p:sp>
-        <p:nvSpPr>
-          <p:cNvPr id="16" name="Text 14"/>
-          <p:cNvSpPr/>
-          <p:nvPr/>
-        </p:nvSpPr>
-        <p:spPr>
-          <a:xfrm>
-            <a:off x="8229600" y="3886200"/>
-            <a:ext cx="3108960" cy="1280160"/>
-          </a:xfrm>
-          <a:prstGeom prst="rect">
-            <a:avLst/>
-          </a:prstGeom>
-          <a:noFill/>
-          <a:ln/>
-        </p:spPr>
-        <p:txBody>
-          <a:bodyPr wrap="square" lIns="0" tIns="0" rIns="0" bIns="0" rtlCol="0" anchor="t"/>
-          <a:lstStyle/>
-          <a:p>
-            <a:pPr algn="ctr" indent="0" marL="0">
-              <a:buNone/>
-            </a:pPr>
-            <a:r>
-              <a:rPr lang="en-US" sz="1200" dirty="0">
-                <a:solidFill>
-                  <a:srgbClr val="5D6B63"/>
-                </a:solidFill>
-                <a:latin typeface="Calibri" pitchFamily="34" charset="0"/>
-                <a:ea typeface="Calibri" pitchFamily="34" charset="-122"/>
-                <a:cs typeface="Calibri" pitchFamily="34" charset="-120"/>
-              </a:rPr>
-              <a:t>A claim, not conduct — e.g. “net zero” that ignores 85% of emissions</a:t>
-            </a:r>
-            <a:endParaRPr lang="en-US" sz="1200" dirty="0"/>
-          </a:p>
-        </p:txBody>
-      </p:sp>
-      <p:sp>
-        <p:nvSpPr>
-          <p:cNvPr id="17" name="Text 15"/>
           <p:cNvSpPr/>
           <p:nvPr/>
         </p:nvSpPr>
@@ -2702,6 +2813,590 @@
                 <a:ea typeface="Calibri" pitchFamily="34" charset="-122"/>
                 <a:cs typeface="Calibri" pitchFamily="34" charset="-120"/>
               </a:rPr>
+              <a:t>THE RECEIPTS</a:t>
+            </a:r>
+            <a:endParaRPr lang="en-US" sz="1200" dirty="0"/>
+          </a:p>
+        </p:txBody>
+      </p:sp>
+      <p:sp>
+        <p:nvSpPr>
+          <p:cNvPr id="3" name="Text 1"/>
+          <p:cNvSpPr/>
+          <p:nvPr/>
+        </p:nvSpPr>
+        <p:spPr>
+          <a:xfrm>
+            <a:off x="548640" y="658368"/>
+            <a:ext cx="11064240" cy="640080"/>
+          </a:xfrm>
+          <a:prstGeom prst="rect">
+            <a:avLst/>
+          </a:prstGeom>
+          <a:noFill/>
+          <a:ln/>
+        </p:spPr>
+        <p:txBody>
+          <a:bodyPr wrap="square" lIns="0" tIns="0" rIns="0" bIns="0" rtlCol="0" anchor="ctr"/>
+          <a:lstStyle/>
+          <a:p>
+            <a:pPr indent="0" marL="0">
+              <a:buNone/>
+            </a:pPr>
+            <a:r>
+              <a:rPr lang="en-US" sz="3000" b="1" dirty="0">
+                <a:solidFill>
+                  <a:srgbClr val="1B6B4A"/>
+                </a:solidFill>
+                <a:latin typeface="Cambria" pitchFamily="34" charset="0"/>
+                <a:ea typeface="Cambria" pitchFamily="34" charset="-122"/>
+                <a:cs typeface="Cambria" pitchFamily="34" charset="-120"/>
+              </a:rPr>
+              <a:t>An accountability index with sources</a:t>
+            </a:r>
+            <a:endParaRPr lang="en-US" sz="3000" dirty="0"/>
+          </a:p>
+        </p:txBody>
+      </p:sp>
+      <p:sp>
+        <p:nvSpPr>
+          <p:cNvPr id="4" name="Text 2"/>
+          <p:cNvSpPr/>
+          <p:nvPr/>
+        </p:nvSpPr>
+        <p:spPr>
+          <a:xfrm>
+            <a:off x="548640" y="1417320"/>
+            <a:ext cx="10972800" cy="822960"/>
+          </a:xfrm>
+          <a:prstGeom prst="rect">
+            <a:avLst/>
+          </a:prstGeom>
+          <a:noFill/>
+          <a:ln/>
+        </p:spPr>
+        <p:txBody>
+          <a:bodyPr wrap="square" lIns="0" tIns="0" rIns="0" bIns="0" rtlCol="0" anchor="t"/>
+          <a:lstStyle/>
+          <a:p>
+            <a:pPr indent="0" marL="0">
+              <a:buNone/>
+            </a:pPr>
+            <a:r>
+              <a:rPr lang="en-US" sz="1400" dirty="0">
+                <a:solidFill>
+                  <a:srgbClr val="5D6B63"/>
+                </a:solidFill>
+                <a:latin typeface="Calibri" pitchFamily="34" charset="0"/>
+                <a:ea typeface="Calibri" pitchFamily="34" charset="-122"/>
+                <a:cs typeface="Calibri" pitchFamily="34" charset="-120"/>
+              </a:rPr>
+              <a:t>The banks, oil majors and state financiers shaping Kenya's energy future — each measured against their own public climate promises, and scored, with sources to follow.</a:t>
+            </a:r>
+            <a:endParaRPr lang="en-US" sz="1400" dirty="0"/>
+          </a:p>
+        </p:txBody>
+      </p:sp>
+      <p:sp>
+        <p:nvSpPr>
+          <p:cNvPr id="5" name="Shape 3"/>
+          <p:cNvSpPr/>
+          <p:nvPr/>
+        </p:nvSpPr>
+        <p:spPr>
+          <a:xfrm>
+            <a:off x="548640" y="2468880"/>
+            <a:ext cx="3611880" cy="2834640"/>
+          </a:xfrm>
+          <a:prstGeom prst="roundRect">
+            <a:avLst>
+              <a:gd name="adj" fmla="val 2581"/>
+            </a:avLst>
+          </a:prstGeom>
+          <a:solidFill>
+            <a:srgbClr val="F1F5F3"/>
+          </a:solidFill>
+          <a:ln w="9525">
+            <a:solidFill>
+              <a:srgbClr val="D9E2DC"/>
+            </a:solidFill>
+            <a:prstDash val="solid"/>
+          </a:ln>
+          <a:effectLst>
+            <a:outerShdw sx="100000" sy="100000" kx="0" ky="0" algn="bl" rotWithShape="0" blurRad="76200" dist="25400" dir="5400000">
+              <a:srgbClr val="9AA8A0">
+                <a:alpha val="35000"/>
+              </a:srgbClr>
+            </a:outerShdw>
+          </a:effectLst>
+        </p:spPr>
+      </p:sp>
+      <p:sp>
+        <p:nvSpPr>
+          <p:cNvPr id="6" name="Shape 4"/>
+          <p:cNvSpPr/>
+          <p:nvPr/>
+        </p:nvSpPr>
+        <p:spPr>
+          <a:xfrm>
+            <a:off x="2029968" y="2697480"/>
+            <a:ext cx="640080" cy="640080"/>
+          </a:xfrm>
+          <a:prstGeom prst="ellipse">
+            <a:avLst/>
+          </a:prstGeom>
+          <a:solidFill>
+            <a:srgbClr val="1B6B4A"/>
+          </a:solidFill>
+          <a:ln/>
+        </p:spPr>
+      </p:sp>
+      <p:sp>
+        <p:nvSpPr>
+          <p:cNvPr id="7" name="Text 5"/>
+          <p:cNvSpPr/>
+          <p:nvPr/>
+        </p:nvSpPr>
+        <p:spPr>
+          <a:xfrm>
+            <a:off x="731520" y="3429000"/>
+            <a:ext cx="3246120" cy="457200"/>
+          </a:xfrm>
+          <a:prstGeom prst="rect">
+            <a:avLst/>
+          </a:prstGeom>
+          <a:noFill/>
+          <a:ln/>
+        </p:spPr>
+        <p:txBody>
+          <a:bodyPr wrap="square" lIns="0" tIns="0" rIns="0" bIns="0" rtlCol="0" anchor="ctr"/>
+          <a:lstStyle/>
+          <a:p>
+            <a:pPr algn="ctr" indent="0" marL="0">
+              <a:buNone/>
+            </a:pPr>
+            <a:r>
+              <a:rPr lang="en-US" sz="1800" b="1" dirty="0">
+                <a:solidFill>
+                  <a:srgbClr val="1D2621"/>
+                </a:solidFill>
+                <a:latin typeface="Calibri" pitchFamily="34" charset="0"/>
+                <a:ea typeface="Calibri" pitchFamily="34" charset="-122"/>
+                <a:cs typeface="Calibri" pitchFamily="34" charset="-120"/>
+              </a:rPr>
+              <a:t>Kept</a:t>
+            </a:r>
+            <a:endParaRPr lang="en-US" sz="1800" dirty="0"/>
+          </a:p>
+        </p:txBody>
+      </p:sp>
+      <p:sp>
+        <p:nvSpPr>
+          <p:cNvPr id="8" name="Text 6"/>
+          <p:cNvSpPr/>
+          <p:nvPr/>
+        </p:nvSpPr>
+        <p:spPr>
+          <a:xfrm>
+            <a:off x="804672" y="3886200"/>
+            <a:ext cx="3108960" cy="1280160"/>
+          </a:xfrm>
+          <a:prstGeom prst="rect">
+            <a:avLst/>
+          </a:prstGeom>
+          <a:noFill/>
+          <a:ln/>
+        </p:spPr>
+        <p:txBody>
+          <a:bodyPr wrap="square" lIns="0" tIns="0" rIns="0" bIns="0" rtlCol="0" anchor="t"/>
+          <a:lstStyle/>
+          <a:p>
+            <a:pPr algn="ctr" indent="0" marL="0">
+              <a:buNone/>
+            </a:pPr>
+            <a:r>
+              <a:rPr lang="en-US" sz="1200" dirty="0">
+                <a:solidFill>
+                  <a:srgbClr val="5D6B63"/>
+                </a:solidFill>
+                <a:latin typeface="Calibri" pitchFamily="34" charset="0"/>
+                <a:ea typeface="Calibri" pitchFamily="34" charset="-122"/>
+                <a:cs typeface="Calibri" pitchFamily="34" charset="-120"/>
+              </a:rPr>
+              <a:t>Promise matched by action — e.g. a bank declining to finance EACOP</a:t>
+            </a:r>
+            <a:endParaRPr lang="en-US" sz="1200" dirty="0"/>
+          </a:p>
+        </p:txBody>
+      </p:sp>
+      <p:sp>
+        <p:nvSpPr>
+          <p:cNvPr id="9" name="Shape 7"/>
+          <p:cNvSpPr/>
+          <p:nvPr/>
+        </p:nvSpPr>
+        <p:spPr>
+          <a:xfrm>
+            <a:off x="4261104" y="2468880"/>
+            <a:ext cx="3611880" cy="2834640"/>
+          </a:xfrm>
+          <a:prstGeom prst="roundRect">
+            <a:avLst>
+              <a:gd name="adj" fmla="val 2581"/>
+            </a:avLst>
+          </a:prstGeom>
+          <a:solidFill>
+            <a:srgbClr val="F1F5F3"/>
+          </a:solidFill>
+          <a:ln w="9525">
+            <a:solidFill>
+              <a:srgbClr val="D9E2DC"/>
+            </a:solidFill>
+            <a:prstDash val="solid"/>
+          </a:ln>
+          <a:effectLst>
+            <a:outerShdw sx="100000" sy="100000" kx="0" ky="0" algn="bl" rotWithShape="0" blurRad="76200" dist="25400" dir="5400000">
+              <a:srgbClr val="9AA8A0">
+                <a:alpha val="35000"/>
+              </a:srgbClr>
+            </a:outerShdw>
+          </a:effectLst>
+        </p:spPr>
+      </p:sp>
+      <p:sp>
+        <p:nvSpPr>
+          <p:cNvPr id="10" name="Shape 8"/>
+          <p:cNvSpPr/>
+          <p:nvPr/>
+        </p:nvSpPr>
+        <p:spPr>
+          <a:xfrm>
+            <a:off x="5742432" y="2697480"/>
+            <a:ext cx="640080" cy="640080"/>
+          </a:xfrm>
+          <a:prstGeom prst="ellipse">
+            <a:avLst/>
+          </a:prstGeom>
+          <a:solidFill>
+            <a:srgbClr val="EE9455"/>
+          </a:solidFill>
+          <a:ln/>
+        </p:spPr>
+      </p:sp>
+      <p:sp>
+        <p:nvSpPr>
+          <p:cNvPr id="11" name="Text 9"/>
+          <p:cNvSpPr/>
+          <p:nvPr/>
+        </p:nvSpPr>
+        <p:spPr>
+          <a:xfrm>
+            <a:off x="4443984" y="3429000"/>
+            <a:ext cx="3246120" cy="457200"/>
+          </a:xfrm>
+          <a:prstGeom prst="rect">
+            <a:avLst/>
+          </a:prstGeom>
+          <a:noFill/>
+          <a:ln/>
+        </p:spPr>
+        <p:txBody>
+          <a:bodyPr wrap="square" lIns="0" tIns="0" rIns="0" bIns="0" rtlCol="0" anchor="ctr"/>
+          <a:lstStyle/>
+          <a:p>
+            <a:pPr algn="ctr" indent="0" marL="0">
+              <a:buNone/>
+            </a:pPr>
+            <a:r>
+              <a:rPr lang="en-US" sz="1800" b="1" dirty="0">
+                <a:solidFill>
+                  <a:srgbClr val="1D2621"/>
+                </a:solidFill>
+                <a:latin typeface="Calibri" pitchFamily="34" charset="0"/>
+                <a:ea typeface="Calibri" pitchFamily="34" charset="-122"/>
+                <a:cs typeface="Calibri" pitchFamily="34" charset="-120"/>
+              </a:rPr>
+              <a:t>Partial</a:t>
+            </a:r>
+            <a:endParaRPr lang="en-US" sz="1800" dirty="0"/>
+          </a:p>
+        </p:txBody>
+      </p:sp>
+      <p:sp>
+        <p:nvSpPr>
+          <p:cNvPr id="12" name="Text 10"/>
+          <p:cNvSpPr/>
+          <p:nvPr/>
+        </p:nvSpPr>
+        <p:spPr>
+          <a:xfrm>
+            <a:off x="4517136" y="3886200"/>
+            <a:ext cx="3108960" cy="1280160"/>
+          </a:xfrm>
+          <a:prstGeom prst="rect">
+            <a:avLst/>
+          </a:prstGeom>
+          <a:noFill/>
+          <a:ln/>
+        </p:spPr>
+        <p:txBody>
+          <a:bodyPr wrap="square" lIns="0" tIns="0" rIns="0" bIns="0" rtlCol="0" anchor="t"/>
+          <a:lstStyle/>
+          <a:p>
+            <a:pPr algn="ctr" indent="0" marL="0">
+              <a:buNone/>
+            </a:pPr>
+            <a:r>
+              <a:rPr lang="en-US" sz="1200" dirty="0">
+                <a:solidFill>
+                  <a:srgbClr val="5D6B63"/>
+                </a:solidFill>
+                <a:latin typeface="Calibri" pitchFamily="34" charset="0"/>
+                <a:ea typeface="Calibri" pitchFamily="34" charset="-122"/>
+                <a:cs typeface="Calibri" pitchFamily="34" charset="-120"/>
+              </a:rPr>
+              <a:t>Real movement, real gaps — e.g. a coal pledge with a legacy pipeline</a:t>
+            </a:r>
+            <a:endParaRPr lang="en-US" sz="1200" dirty="0"/>
+          </a:p>
+        </p:txBody>
+      </p:sp>
+      <p:sp>
+        <p:nvSpPr>
+          <p:cNvPr id="13" name="Shape 11"/>
+          <p:cNvSpPr/>
+          <p:nvPr/>
+        </p:nvSpPr>
+        <p:spPr>
+          <a:xfrm>
+            <a:off x="7973568" y="2468880"/>
+            <a:ext cx="3611880" cy="2834640"/>
+          </a:xfrm>
+          <a:prstGeom prst="roundRect">
+            <a:avLst>
+              <a:gd name="adj" fmla="val 2581"/>
+            </a:avLst>
+          </a:prstGeom>
+          <a:solidFill>
+            <a:srgbClr val="F1F5F3"/>
+          </a:solidFill>
+          <a:ln w="9525">
+            <a:solidFill>
+              <a:srgbClr val="D9E2DC"/>
+            </a:solidFill>
+            <a:prstDash val="solid"/>
+          </a:ln>
+          <a:effectLst>
+            <a:outerShdw sx="100000" sy="100000" kx="0" ky="0" algn="bl" rotWithShape="0" blurRad="76200" dist="25400" dir="5400000">
+              <a:srgbClr val="9AA8A0">
+                <a:alpha val="35000"/>
+              </a:srgbClr>
+            </a:outerShdw>
+          </a:effectLst>
+        </p:spPr>
+      </p:sp>
+      <p:sp>
+        <p:nvSpPr>
+          <p:cNvPr id="14" name="Shape 12"/>
+          <p:cNvSpPr/>
+          <p:nvPr/>
+        </p:nvSpPr>
+        <p:spPr>
+          <a:xfrm>
+            <a:off x="9454896" y="2697480"/>
+            <a:ext cx="640080" cy="640080"/>
+          </a:xfrm>
+          <a:prstGeom prst="ellipse">
+            <a:avLst/>
+          </a:prstGeom>
+          <a:solidFill>
+            <a:srgbClr val="EE9455"/>
+          </a:solidFill>
+          <a:ln/>
+        </p:spPr>
+      </p:sp>
+      <p:sp>
+        <p:nvSpPr>
+          <p:cNvPr id="15" name="Text 13"/>
+          <p:cNvSpPr/>
+          <p:nvPr/>
+        </p:nvSpPr>
+        <p:spPr>
+          <a:xfrm>
+            <a:off x="8156448" y="3429000"/>
+            <a:ext cx="3246120" cy="457200"/>
+          </a:xfrm>
+          <a:prstGeom prst="rect">
+            <a:avLst/>
+          </a:prstGeom>
+          <a:noFill/>
+          <a:ln/>
+        </p:spPr>
+        <p:txBody>
+          <a:bodyPr wrap="square" lIns="0" tIns="0" rIns="0" bIns="0" rtlCol="0" anchor="ctr"/>
+          <a:lstStyle/>
+          <a:p>
+            <a:pPr algn="ctr" indent="0" marL="0">
+              <a:buNone/>
+            </a:pPr>
+            <a:r>
+              <a:rPr lang="en-US" sz="1800" b="1" dirty="0">
+                <a:solidFill>
+                  <a:srgbClr val="1D2621"/>
+                </a:solidFill>
+                <a:latin typeface="Calibri" pitchFamily="34" charset="0"/>
+                <a:ea typeface="Calibri" pitchFamily="34" charset="-122"/>
+                <a:cs typeface="Calibri" pitchFamily="34" charset="-120"/>
+              </a:rPr>
+              <a:t>Lip-service</a:t>
+            </a:r>
+            <a:endParaRPr lang="en-US" sz="1800" dirty="0"/>
+          </a:p>
+        </p:txBody>
+      </p:sp>
+      <p:sp>
+        <p:nvSpPr>
+          <p:cNvPr id="16" name="Text 14"/>
+          <p:cNvSpPr/>
+          <p:nvPr/>
+        </p:nvSpPr>
+        <p:spPr>
+          <a:xfrm>
+            <a:off x="8229600" y="3886200"/>
+            <a:ext cx="3108960" cy="1280160"/>
+          </a:xfrm>
+          <a:prstGeom prst="rect">
+            <a:avLst/>
+          </a:prstGeom>
+          <a:noFill/>
+          <a:ln/>
+        </p:spPr>
+        <p:txBody>
+          <a:bodyPr wrap="square" lIns="0" tIns="0" rIns="0" bIns="0" rtlCol="0" anchor="t"/>
+          <a:lstStyle/>
+          <a:p>
+            <a:pPr algn="ctr" indent="0" marL="0">
+              <a:buNone/>
+            </a:pPr>
+            <a:r>
+              <a:rPr lang="en-US" sz="1200" dirty="0">
+                <a:solidFill>
+                  <a:srgbClr val="5D6B63"/>
+                </a:solidFill>
+                <a:latin typeface="Calibri" pitchFamily="34" charset="0"/>
+                <a:ea typeface="Calibri" pitchFamily="34" charset="-122"/>
+                <a:cs typeface="Calibri" pitchFamily="34" charset="-120"/>
+              </a:rPr>
+              <a:t>A claim, not conduct — e.g. “net zero” that ignores 85% of emissions</a:t>
+            </a:r>
+            <a:endParaRPr lang="en-US" sz="1200" dirty="0"/>
+          </a:p>
+        </p:txBody>
+      </p:sp>
+      <p:sp>
+        <p:nvSpPr>
+          <p:cNvPr id="17" name="Text 15"/>
+          <p:cNvSpPr/>
+          <p:nvPr/>
+        </p:nvSpPr>
+        <p:spPr>
+          <a:xfrm>
+            <a:off x="548640" y="6446520"/>
+            <a:ext cx="11064240" cy="274320"/>
+          </a:xfrm>
+          <a:prstGeom prst="rect">
+            <a:avLst/>
+          </a:prstGeom>
+          <a:noFill/>
+          <a:ln/>
+        </p:spPr>
+        <p:txBody>
+          <a:bodyPr wrap="square" lIns="0" tIns="0" rIns="0" bIns="0" rtlCol="0" anchor="ctr"/>
+          <a:lstStyle/>
+          <a:p>
+            <a:pPr indent="0" marL="0">
+              <a:buNone/>
+            </a:pPr>
+            <a:r>
+              <a:rPr lang="en-US" sz="900" i="1" dirty="0">
+                <a:solidFill>
+                  <a:srgbClr val="5D6B63"/>
+                </a:solidFill>
+                <a:latin typeface="Calibri" pitchFamily="34" charset="0"/>
+                <a:ea typeface="Calibri" pitchFamily="34" charset="-122"/>
+                <a:cs typeface="Calibri" pitchFamily="34" charset="-120"/>
+              </a:rPr>
+              <a:t>MazingiraKenya · Partner prospectus</a:t>
+            </a:r>
+            <a:endParaRPr lang="en-US" sz="900" dirty="0"/>
+          </a:p>
+        </p:txBody>
+      </p:sp>
+    </p:spTree>
+  </p:cSld>
+  <p:clrMapOvr>
+    <a:masterClrMapping/>
+  </p:clrMapOvr>
+</p:sld>
+</file>
+
+<file path=ppt/slides/slide12.xml><?xml version="1.0" encoding="utf-8"?>
+<p:sld xmlns:a="http://schemas.openxmlformats.org/drawingml/2006/main" xmlns:r="http://schemas.openxmlformats.org/officeDocument/2006/relationships" xmlns:p="http://schemas.openxmlformats.org/presentationml/2006/main">
+  <p:cSld name="Slide 12">
+    <p:bg>
+      <p:bgPr>
+        <a:solidFill>
+          <a:srgbClr val="FFFFFF"/>
+        </a:solidFill>
+      </p:bgPr>
+    </p:bg>
+    <p:spTree>
+      <p:nvGrpSpPr>
+        <p:cNvPr id="1" name=""/>
+        <p:cNvGrpSpPr/>
+        <p:nvPr/>
+      </p:nvGrpSpPr>
+      <p:grpSpPr>
+        <a:xfrm>
+          <a:off x="0" y="0"/>
+          <a:ext cx="0" cy="0"/>
+          <a:chOff x="0" y="0"/>
+          <a:chExt cx="0" cy="0"/>
+        </a:xfrm>
+      </p:grpSpPr>
+      <p:sp>
+        <p:nvSpPr>
+          <p:cNvPr id="2" name="Text 0"/>
+          <p:cNvSpPr/>
+          <p:nvPr/>
+        </p:nvSpPr>
+        <p:spPr>
+          <a:xfrm>
+            <a:off x="548640" y="384048"/>
+            <a:ext cx="10972800" cy="274320"/>
+          </a:xfrm>
+          <a:prstGeom prst="rect">
+            <a:avLst/>
+          </a:prstGeom>
+          <a:noFill/>
+          <a:ln/>
+        </p:spPr>
+        <p:txBody>
+          <a:bodyPr wrap="square" lIns="0" tIns="0" rIns="0" bIns="0" rtlCol="0" anchor="ctr"/>
+          <a:lstStyle/>
+          <a:p>
+            <a:pPr indent="0" marL="0">
+              <a:buNone/>
+            </a:pPr>
+            <a:r>
+              <a:rPr lang="en-US" sz="1200" b="1" spc="200" kern="0" dirty="0">
+                <a:solidFill>
+                  <a:srgbClr val="EE9455"/>
+                </a:solidFill>
+                <a:latin typeface="Calibri" pitchFamily="34" charset="0"/>
+                <a:ea typeface="Calibri" pitchFamily="34" charset="-122"/>
+                <a:cs typeface="Calibri" pitchFamily="34" charset="-120"/>
+              </a:rPr>
               <a:t>WHY PARTNER NOW</a:t>
             </a:r>
             <a:endParaRPr lang="en-US" sz="1200" dirty="0"/>
@@ -3169,9 +3864,9 @@
 </p:sld>
 </file>
 
-<file path=ppt/slides/slide12.xml><?xml version="1.0" encoding="utf-8"?>
+<file path=ppt/slides/slide13.xml><?xml version="1.0" encoding="utf-8"?>
 <p:sld xmlns:a="http://schemas.openxmlformats.org/drawingml/2006/main" xmlns:r="http://schemas.openxmlformats.org/officeDocument/2006/relationships" xmlns:p="http://schemas.openxmlformats.org/presentationml/2006/main">
-  <p:cSld name="Slide 12">
+  <p:cSld name="Slide 13">
     <p:bg>
       <p:bgPr>
         <a:solidFill>
@@ -7624,7 +8319,7 @@
                 <a:ea typeface="Calibri" pitchFamily="34" charset="-122"/>
                 <a:cs typeface="Calibri" pitchFamily="34" charset="-120"/>
               </a:rPr>
-              <a:t>WHY IT'S USEFUL</a:t>
+              <a:t>ACTIVE BROKERING</a:t>
             </a:r>
             <a:endParaRPr lang="en-US" sz="1200" dirty="0"/>
           </a:p>
@@ -7663,7 +8358,7 @@
                 <a:ea typeface="Cambria" pitchFamily="34" charset="-122"/>
                 <a:cs typeface="Cambria" pitchFamily="34" charset="-120"/>
               </a:rPr>
-              <a:t>From information to leverage</a:t>
+              <a:t>It doesn't just list opportunities — it delivers them</a:t>
             </a:r>
             <a:endParaRPr lang="en-US" sz="3000" dirty="0"/>
           </a:p>
@@ -7677,12 +8372,12 @@
         </p:nvSpPr>
         <p:spPr>
           <a:xfrm>
-            <a:off x="548640" y="1554480"/>
-            <a:ext cx="11064240" cy="1051560"/>
+            <a:off x="548640" y="1600200"/>
+            <a:ext cx="3566160" cy="2788920"/>
           </a:xfrm>
           <a:prstGeom prst="roundRect">
             <a:avLst>
-              <a:gd name="adj" fmla="val 6957"/>
+              <a:gd name="adj" fmla="val 2623"/>
             </a:avLst>
           </a:prstGeom>
           <a:solidFill>
@@ -7711,8 +8406,8 @@
         </p:nvSpPr>
         <p:spPr>
           <a:xfrm>
-            <a:off x="749808" y="1773936"/>
-            <a:ext cx="457200" cy="457200"/>
+            <a:off x="1965960" y="1828800"/>
+            <a:ext cx="731520" cy="731520"/>
           </a:xfrm>
           <a:prstGeom prst="ellipse">
             <a:avLst/>
@@ -7731,8 +8426,8 @@
         </p:nvSpPr>
         <p:spPr>
           <a:xfrm>
-            <a:off x="749808" y="1773936"/>
-            <a:ext cx="457200" cy="457200"/>
+            <a:off x="1965960" y="1828800"/>
+            <a:ext cx="731520" cy="731520"/>
           </a:xfrm>
           <a:prstGeom prst="rect">
             <a:avLst/>
@@ -7748,7 +8443,7 @@
               <a:buNone/>
             </a:pPr>
             <a:r>
-              <a:rPr lang="en-US" sz="1500" b="1" dirty="0">
+              <a:rPr lang="en-US" sz="2200" b="1" dirty="0">
                 <a:solidFill>
                   <a:srgbClr val="FFFFFF"/>
                 </a:solidFill>
@@ -7756,9 +8451,9 @@
                 <a:ea typeface="Calibri" pitchFamily="34" charset="-122"/>
                 <a:cs typeface="Calibri" pitchFamily="34" charset="-120"/>
               </a:rPr>
-              <a:t>✓</a:t>
-            </a:r>
-            <a:endParaRPr lang="en-US" sz="1500" dirty="0"/>
+              <a:t>1</a:t>
+            </a:r>
+            <a:endParaRPr lang="en-US" sz="2200" dirty="0"/>
           </a:p>
         </p:txBody>
       </p:sp>
@@ -7770,24 +8465,24 @@
         </p:nvSpPr>
         <p:spPr>
           <a:xfrm>
-            <a:off x="1371600" y="1700784"/>
-            <a:ext cx="10104120" cy="310896"/>
-          </a:xfrm>
-          <a:prstGeom prst="rect">
-            <a:avLst/>
-          </a:prstGeom>
-          <a:noFill/>
-          <a:ln/>
-        </p:spPr>
-        <p:txBody>
-          <a:bodyPr wrap="square" lIns="0" tIns="0" rIns="0" bIns="0" rtlCol="0" anchor="ctr"/>
-          <a:lstStyle/>
-          <a:p>
-            <a:pPr indent="0" marL="0">
-              <a:buNone/>
-            </a:pPr>
-            <a:r>
-              <a:rPr lang="en-US" sz="1400" b="1" dirty="0">
+            <a:off x="731520" y="2697480"/>
+            <a:ext cx="3200400" cy="365760"/>
+          </a:xfrm>
+          <a:prstGeom prst="rect">
+            <a:avLst/>
+          </a:prstGeom>
+          <a:noFill/>
+          <a:ln/>
+        </p:spPr>
+        <p:txBody>
+          <a:bodyPr wrap="square" lIns="0" tIns="0" rIns="0" bIns="0" rtlCol="0" anchor="ctr"/>
+          <a:lstStyle/>
+          <a:p>
+            <a:pPr algn="ctr" indent="0" marL="0">
+              <a:buNone/>
+            </a:pPr>
+            <a:r>
+              <a:rPr lang="en-US" sz="1600" b="1" dirty="0">
                 <a:solidFill>
                   <a:srgbClr val="1D2621"/>
                 </a:solidFill>
@@ -7795,9 +8490,9 @@
                 <a:ea typeface="Calibri" pitchFamily="34" charset="-122"/>
                 <a:cs typeface="Calibri" pitchFamily="34" charset="-120"/>
               </a:rPr>
-              <a:t>See the whole board</a:t>
-            </a:r>
-            <a:endParaRPr lang="en-US" sz="1400" dirty="0"/>
+              <a:t>Scan</a:t>
+            </a:r>
+            <a:endParaRPr lang="en-US" sz="1600" dirty="0"/>
           </a:p>
         </p:txBody>
       </p:sp>
@@ -7809,8 +8504,8 @@
         </p:nvSpPr>
         <p:spPr>
           <a:xfrm>
-            <a:off x="1371600" y="2011680"/>
-            <a:ext cx="10104120" cy="502920"/>
+            <a:off x="822960" y="3108960"/>
+            <a:ext cx="3017520" cy="1234440"/>
           </a:xfrm>
           <a:prstGeom prst="rect">
             <a:avLst/>
@@ -7822,7 +8517,7 @@
           <a:bodyPr wrap="square" lIns="0" tIns="0" rIns="0" bIns="0" rtlCol="0" anchor="t"/>
           <a:lstStyle/>
           <a:p>
-            <a:pPr indent="0" marL="0">
+            <a:pPr algn="ctr" indent="0" marL="0">
               <a:buNone/>
             </a:pPr>
             <a:r>
@@ -7834,7 +8529,7 @@
                 <a:ea typeface="Calibri" pitchFamily="34" charset="-122"/>
                 <a:cs typeface="Calibri" pitchFamily="34" charset="-120"/>
               </a:rPr>
-              <a:t>Every pressure and every responder in one view — the picture no single org holds.</a:t>
+              <a:t>A weekly watcher finds open grants, fellowships and accreditation windows for Kenya &amp; Africa — with deadlines, amounts and eligibility.</a:t>
             </a:r>
             <a:endParaRPr lang="en-US" sz="1150" dirty="0"/>
           </a:p>
@@ -7848,12 +8543,12 @@
         </p:nvSpPr>
         <p:spPr>
           <a:xfrm>
-            <a:off x="548640" y="2724912"/>
-            <a:ext cx="11064240" cy="1051560"/>
+            <a:off x="4261104" y="1600200"/>
+            <a:ext cx="3566160" cy="2788920"/>
           </a:xfrm>
           <a:prstGeom prst="roundRect">
             <a:avLst>
-              <a:gd name="adj" fmla="val 6957"/>
+              <a:gd name="adj" fmla="val 2623"/>
             </a:avLst>
           </a:prstGeom>
           <a:solidFill>
@@ -7882,8 +8577,8 @@
         </p:nvSpPr>
         <p:spPr>
           <a:xfrm>
-            <a:off x="749808" y="2944368"/>
-            <a:ext cx="457200" cy="457200"/>
+            <a:off x="5678424" y="1828800"/>
+            <a:ext cx="731520" cy="731520"/>
           </a:xfrm>
           <a:prstGeom prst="ellipse">
             <a:avLst/>
@@ -7902,8 +8597,8 @@
         </p:nvSpPr>
         <p:spPr>
           <a:xfrm>
-            <a:off x="749808" y="2944368"/>
-            <a:ext cx="457200" cy="457200"/>
+            <a:off x="5678424" y="1828800"/>
+            <a:ext cx="731520" cy="731520"/>
           </a:xfrm>
           <a:prstGeom prst="rect">
             <a:avLst/>
@@ -7919,7 +8614,7 @@
               <a:buNone/>
             </a:pPr>
             <a:r>
-              <a:rPr lang="en-US" sz="1500" b="1" dirty="0">
+              <a:rPr lang="en-US" sz="2200" b="1" dirty="0">
                 <a:solidFill>
                   <a:srgbClr val="FFFFFF"/>
                 </a:solidFill>
@@ -7927,9 +8622,9 @@
                 <a:ea typeface="Calibri" pitchFamily="34" charset="-122"/>
                 <a:cs typeface="Calibri" pitchFamily="34" charset="-120"/>
               </a:rPr>
-              <a:t>✓</a:t>
-            </a:r>
-            <a:endParaRPr lang="en-US" sz="1500" dirty="0"/>
+              <a:t>2</a:t>
+            </a:r>
+            <a:endParaRPr lang="en-US" sz="2200" dirty="0"/>
           </a:p>
         </p:txBody>
       </p:sp>
@@ -7941,24 +8636,24 @@
         </p:nvSpPr>
         <p:spPr>
           <a:xfrm>
-            <a:off x="1371600" y="2871216"/>
-            <a:ext cx="10104120" cy="310896"/>
-          </a:xfrm>
-          <a:prstGeom prst="rect">
-            <a:avLst/>
-          </a:prstGeom>
-          <a:noFill/>
-          <a:ln/>
-        </p:spPr>
-        <p:txBody>
-          <a:bodyPr wrap="square" lIns="0" tIns="0" rIns="0" bIns="0" rtlCol="0" anchor="ctr"/>
-          <a:lstStyle/>
-          <a:p>
-            <a:pPr indent="0" marL="0">
-              <a:buNone/>
-            </a:pPr>
-            <a:r>
-              <a:rPr lang="en-US" sz="1400" b="1" dirty="0">
+            <a:off x="4443984" y="2697480"/>
+            <a:ext cx="3200400" cy="365760"/>
+          </a:xfrm>
+          <a:prstGeom prst="rect">
+            <a:avLst/>
+          </a:prstGeom>
+          <a:noFill/>
+          <a:ln/>
+        </p:spPr>
+        <p:txBody>
+          <a:bodyPr wrap="square" lIns="0" tIns="0" rIns="0" bIns="0" rtlCol="0" anchor="ctr"/>
+          <a:lstStyle/>
+          <a:p>
+            <a:pPr algn="ctr" indent="0" marL="0">
+              <a:buNone/>
+            </a:pPr>
+            <a:r>
+              <a:rPr lang="en-US" sz="1600" b="1" dirty="0">
                 <a:solidFill>
                   <a:srgbClr val="1D2621"/>
                 </a:solidFill>
@@ -7966,9 +8661,9 @@
                 <a:ea typeface="Calibri" pitchFamily="34" charset="-122"/>
                 <a:cs typeface="Calibri" pitchFamily="34" charset="-120"/>
               </a:rPr>
-              <a:t>Find the gaps</a:t>
-            </a:r>
-            <a:endParaRPr lang="en-US" sz="1400" dirty="0"/>
+              <a:t>Review</a:t>
+            </a:r>
+            <a:endParaRPr lang="en-US" sz="1600" dirty="0"/>
           </a:p>
         </p:txBody>
       </p:sp>
@@ -7980,8 +8675,8 @@
         </p:nvSpPr>
         <p:spPr>
           <a:xfrm>
-            <a:off x="1371600" y="3182112"/>
-            <a:ext cx="10104120" cy="502920"/>
+            <a:off x="4535424" y="3108960"/>
+            <a:ext cx="3017520" cy="1234440"/>
           </a:xfrm>
           <a:prstGeom prst="rect">
             <a:avLst/>
@@ -7993,7 +8688,7 @@
           <a:bodyPr wrap="square" lIns="0" tIns="0" rIns="0" bIns="0" rtlCol="0" anchor="t"/>
           <a:lstStyle/>
           <a:p>
-            <a:pPr indent="0" marL="0">
+            <a:pPr algn="ctr" indent="0" marL="0">
               <a:buNone/>
             </a:pPr>
             <a:r>
@@ -8005,7 +8700,7 @@
                 <a:ea typeface="Calibri" pitchFamily="34" charset="-122"/>
                 <a:cs typeface="Calibri" pitchFamily="34" charset="-120"/>
               </a:rPr>
-              <a:t>A ranking that shows exactly where a marginal effort or grant counts most.</a:t>
+              <a:t>An editor vets each one in the admin console. Nothing goes out unchecked.</a:t>
             </a:r>
             <a:endParaRPr lang="en-US" sz="1150" dirty="0"/>
           </a:p>
@@ -8019,12 +8714,12 @@
         </p:nvSpPr>
         <p:spPr>
           <a:xfrm>
-            <a:off x="548640" y="3895344"/>
-            <a:ext cx="11064240" cy="1051560"/>
+            <a:off x="7973568" y="1600200"/>
+            <a:ext cx="3566160" cy="2788920"/>
           </a:xfrm>
           <a:prstGeom prst="roundRect">
             <a:avLst>
-              <a:gd name="adj" fmla="val 6957"/>
+              <a:gd name="adj" fmla="val 2623"/>
             </a:avLst>
           </a:prstGeom>
           <a:solidFill>
@@ -8053,8 +8748,8 @@
         </p:nvSpPr>
         <p:spPr>
           <a:xfrm>
-            <a:off x="749808" y="4114800"/>
-            <a:ext cx="457200" cy="457200"/>
+            <a:off x="9390888" y="1828800"/>
+            <a:ext cx="731520" cy="731520"/>
           </a:xfrm>
           <a:prstGeom prst="ellipse">
             <a:avLst/>
@@ -8073,8 +8768,8 @@
         </p:nvSpPr>
         <p:spPr>
           <a:xfrm>
-            <a:off x="749808" y="4114800"/>
-            <a:ext cx="457200" cy="457200"/>
+            <a:off x="9390888" y="1828800"/>
+            <a:ext cx="731520" cy="731520"/>
           </a:xfrm>
           <a:prstGeom prst="rect">
             <a:avLst/>
@@ -8090,7 +8785,7 @@
               <a:buNone/>
             </a:pPr>
             <a:r>
-              <a:rPr lang="en-US" sz="1500" b="1" dirty="0">
+              <a:rPr lang="en-US" sz="2200" b="1" dirty="0">
                 <a:solidFill>
                   <a:srgbClr val="FFFFFF"/>
                 </a:solidFill>
@@ -8098,9 +8793,9 @@
                 <a:ea typeface="Calibri" pitchFamily="34" charset="-122"/>
                 <a:cs typeface="Calibri" pitchFamily="34" charset="-120"/>
               </a:rPr>
-              <a:t>✓</a:t>
-            </a:r>
-            <a:endParaRPr lang="en-US" sz="1500" dirty="0"/>
+              <a:t>3</a:t>
+            </a:r>
+            <a:endParaRPr lang="en-US" sz="2200" dirty="0"/>
           </a:p>
         </p:txBody>
       </p:sp>
@@ -8112,24 +8807,24 @@
         </p:nvSpPr>
         <p:spPr>
           <a:xfrm>
-            <a:off x="1371600" y="4041648"/>
-            <a:ext cx="10104120" cy="310896"/>
-          </a:xfrm>
-          <a:prstGeom prst="rect">
-            <a:avLst/>
-          </a:prstGeom>
-          <a:noFill/>
-          <a:ln/>
-        </p:spPr>
-        <p:txBody>
-          <a:bodyPr wrap="square" lIns="0" tIns="0" rIns="0" bIns="0" rtlCol="0" anchor="ctr"/>
-          <a:lstStyle/>
-          <a:p>
-            <a:pPr indent="0" marL="0">
-              <a:buNone/>
-            </a:pPr>
-            <a:r>
-              <a:rPr lang="en-US" sz="1400" b="1" dirty="0">
+            <a:off x="8156448" y="2697480"/>
+            <a:ext cx="3200400" cy="365760"/>
+          </a:xfrm>
+          <a:prstGeom prst="rect">
+            <a:avLst/>
+          </a:prstGeom>
+          <a:noFill/>
+          <a:ln/>
+        </p:spPr>
+        <p:txBody>
+          <a:bodyPr wrap="square" lIns="0" tIns="0" rIns="0" bIns="0" rtlCol="0" anchor="ctr"/>
+          <a:lstStyle/>
+          <a:p>
+            <a:pPr algn="ctr" indent="0" marL="0">
+              <a:buNone/>
+            </a:pPr>
+            <a:r>
+              <a:rPr lang="en-US" sz="1600" b="1" dirty="0">
                 <a:solidFill>
                   <a:srgbClr val="1D2621"/>
                 </a:solidFill>
@@ -8137,9 +8832,9 @@
                 <a:ea typeface="Calibri" pitchFamily="34" charset="-122"/>
                 <a:cs typeface="Calibri" pitchFamily="34" charset="-120"/>
               </a:rPr>
-              <a:t>Coordinate &amp; convene</a:t>
-            </a:r>
-            <a:endParaRPr lang="en-US" sz="1400" dirty="0"/>
+              <a:t>Match &amp; notify</a:t>
+            </a:r>
+            <a:endParaRPr lang="en-US" sz="1600" dirty="0"/>
           </a:p>
         </p:txBody>
       </p:sp>
@@ -8151,8 +8846,8 @@
         </p:nvSpPr>
         <p:spPr>
           <a:xfrm>
-            <a:off x="1371600" y="4352544"/>
-            <a:ext cx="10104120" cy="502920"/>
+            <a:off x="8247888" y="3108960"/>
+            <a:ext cx="3017520" cy="1234440"/>
           </a:xfrm>
           <a:prstGeom prst="rect">
             <a:avLst/>
@@ -8164,7 +8859,7 @@
           <a:bodyPr wrap="square" lIns="0" tIns="0" rIns="0" bIns="0" rtlCol="0" anchor="t"/>
           <a:lstStyle/>
           <a:p>
-            <a:pPr indent="0" marL="0">
+            <a:pPr algn="ctr" indent="0" marL="0">
               <a:buNone/>
             </a:pPr>
             <a:r>
@@ -8176,7 +8871,7 @@
                 <a:ea typeface="Calibri" pitchFamily="34" charset="-122"/>
                 <a:cs typeface="Calibri" pitchFamily="34" charset="-120"/>
               </a:rPr>
-              <a:t>Directory, resource exchange and one-click video calls keep the coalition moving together.</a:t>
+              <a:t>The hub matches each opportunity to partners by focus area and emails the right organisations — automatically.</a:t>
             </a:r>
             <a:endParaRPr lang="en-US" sz="1150" dirty="0"/>
           </a:p>
@@ -8190,16 +8885,16 @@
         </p:nvSpPr>
         <p:spPr>
           <a:xfrm>
-            <a:off x="548640" y="5065776"/>
-            <a:ext cx="11064240" cy="1051560"/>
+            <a:off x="548640" y="4663440"/>
+            <a:ext cx="11064240" cy="1280160"/>
           </a:xfrm>
           <a:prstGeom prst="roundRect">
             <a:avLst>
-              <a:gd name="adj" fmla="val 6957"/>
+              <a:gd name="adj" fmla="val 5714"/>
             </a:avLst>
           </a:prstGeom>
           <a:solidFill>
-            <a:srgbClr val="F1F5F3"/>
+            <a:srgbClr val="0F2A20"/>
           </a:solidFill>
           <a:ln w="9525">
             <a:solidFill>
@@ -8218,144 +8913,46 @@
       </p:sp>
       <p:sp>
         <p:nvSpPr>
-          <p:cNvPr id="20" name="Shape 18"/>
-          <p:cNvSpPr/>
-          <p:nvPr/>
-        </p:nvSpPr>
-        <p:spPr>
-          <a:xfrm>
-            <a:off x="749808" y="5285232"/>
-            <a:ext cx="457200" cy="457200"/>
-          </a:xfrm>
-          <a:prstGeom prst="ellipse">
-            <a:avLst/>
-          </a:prstGeom>
-          <a:solidFill>
-            <a:srgbClr val="1B6B4A"/>
-          </a:solidFill>
-          <a:ln/>
-        </p:spPr>
+          <p:cNvPr id="20" name="Text 18"/>
+          <p:cNvSpPr/>
+          <p:nvPr/>
+        </p:nvSpPr>
+        <p:spPr>
+          <a:xfrm>
+            <a:off x="822960" y="4663440"/>
+            <a:ext cx="10515600" cy="1280160"/>
+          </a:xfrm>
+          <a:prstGeom prst="rect">
+            <a:avLst/>
+          </a:prstGeom>
+          <a:noFill/>
+          <a:ln/>
+        </p:spPr>
+        <p:txBody>
+          <a:bodyPr wrap="square" lIns="0" tIns="0" rIns="0" bIns="0" rtlCol="0" anchor="ctr"/>
+          <a:lstStyle/>
+          <a:p>
+            <a:pPr indent="0" marL="0">
+              <a:buNone/>
+            </a:pPr>
+            <a:r>
+              <a:rPr lang="en-US" sz="1600" i="1" dirty="0">
+                <a:solidFill>
+                  <a:srgbClr val="E7F0EA"/>
+                </a:solidFill>
+                <a:latin typeface="Cambria" pitchFamily="34" charset="0"/>
+                <a:ea typeface="Cambria" pitchFamily="34" charset="-122"/>
+                <a:cs typeface="Cambria" pitchFamily="34" charset="-120"/>
+              </a:rPr>
+              <a:t>From an open call to the right inbox — automatically. The coalition stops missing funding it was eligible for, and partners stop hearing about opportunities only after they've closed.</a:t>
+            </a:r>
+            <a:endParaRPr lang="en-US" sz="1600" dirty="0"/>
+          </a:p>
+        </p:txBody>
       </p:sp>
       <p:sp>
         <p:nvSpPr>
           <p:cNvPr id="21" name="Text 19"/>
-          <p:cNvSpPr/>
-          <p:nvPr/>
-        </p:nvSpPr>
-        <p:spPr>
-          <a:xfrm>
-            <a:off x="749808" y="5285232"/>
-            <a:ext cx="457200" cy="457200"/>
-          </a:xfrm>
-          <a:prstGeom prst="rect">
-            <a:avLst/>
-          </a:prstGeom>
-          <a:noFill/>
-          <a:ln/>
-        </p:spPr>
-        <p:txBody>
-          <a:bodyPr wrap="square" lIns="0" tIns="0" rIns="0" bIns="0" rtlCol="0" anchor="ctr"/>
-          <a:lstStyle/>
-          <a:p>
-            <a:pPr algn="ctr" indent="0" marL="0">
-              <a:buNone/>
-            </a:pPr>
-            <a:r>
-              <a:rPr lang="en-US" sz="1500" b="1" dirty="0">
-                <a:solidFill>
-                  <a:srgbClr val="FFFFFF"/>
-                </a:solidFill>
-                <a:latin typeface="Calibri" pitchFamily="34" charset="0"/>
-                <a:ea typeface="Calibri" pitchFamily="34" charset="-122"/>
-                <a:cs typeface="Calibri" pitchFamily="34" charset="-120"/>
-              </a:rPr>
-              <a:t>✓</a:t>
-            </a:r>
-            <a:endParaRPr lang="en-US" sz="1500" dirty="0"/>
-          </a:p>
-        </p:txBody>
-      </p:sp>
-      <p:sp>
-        <p:nvSpPr>
-          <p:cNvPr id="22" name="Text 20"/>
-          <p:cNvSpPr/>
-          <p:nvPr/>
-        </p:nvSpPr>
-        <p:spPr>
-          <a:xfrm>
-            <a:off x="1371600" y="5212080"/>
-            <a:ext cx="10104120" cy="310896"/>
-          </a:xfrm>
-          <a:prstGeom prst="rect">
-            <a:avLst/>
-          </a:prstGeom>
-          <a:noFill/>
-          <a:ln/>
-        </p:spPr>
-        <p:txBody>
-          <a:bodyPr wrap="square" lIns="0" tIns="0" rIns="0" bIns="0" rtlCol="0" anchor="ctr"/>
-          <a:lstStyle/>
-          <a:p>
-            <a:pPr indent="0" marL="0">
-              <a:buNone/>
-            </a:pPr>
-            <a:r>
-              <a:rPr lang="en-US" sz="1400" b="1" dirty="0">
-                <a:solidFill>
-                  <a:srgbClr val="1D2621"/>
-                </a:solidFill>
-                <a:latin typeface="Calibri" pitchFamily="34" charset="0"/>
-                <a:ea typeface="Calibri" pitchFamily="34" charset="-122"/>
-                <a:cs typeface="Calibri" pitchFamily="34" charset="-120"/>
-              </a:rPr>
-              <a:t>Amplify &amp; mobilise</a:t>
-            </a:r>
-            <a:endParaRPr lang="en-US" sz="1400" dirty="0"/>
-          </a:p>
-        </p:txBody>
-      </p:sp>
-      <p:sp>
-        <p:nvSpPr>
-          <p:cNvPr id="23" name="Text 21"/>
-          <p:cNvSpPr/>
-          <p:nvPr/>
-        </p:nvSpPr>
-        <p:spPr>
-          <a:xfrm>
-            <a:off x="1371600" y="5522976"/>
-            <a:ext cx="10104120" cy="502920"/>
-          </a:xfrm>
-          <a:prstGeom prst="rect">
-            <a:avLst/>
-          </a:prstGeom>
-          <a:noFill/>
-          <a:ln/>
-        </p:spPr>
-        <p:txBody>
-          <a:bodyPr wrap="square" lIns="0" tIns="0" rIns="0" bIns="0" rtlCol="0" anchor="t"/>
-          <a:lstStyle/>
-          <a:p>
-            <a:pPr indent="0" marL="0">
-              <a:buNone/>
-            </a:pPr>
-            <a:r>
-              <a:rPr lang="en-US" sz="1150" dirty="0">
-                <a:solidFill>
-                  <a:srgbClr val="5D6B63"/>
-                </a:solidFill>
-                <a:latin typeface="Calibri" pitchFamily="34" charset="0"/>
-                <a:ea typeface="Calibri" pitchFamily="34" charset="-122"/>
-                <a:cs typeface="Calibri" pitchFamily="34" charset="-120"/>
-              </a:rPr>
-              <a:t>Petitions, public debunks and social sharing turn evidence into pressure.</a:t>
-            </a:r>
-            <a:endParaRPr lang="en-US" sz="1150" dirty="0"/>
-          </a:p>
-        </p:txBody>
-      </p:sp>
-      <p:sp>
-        <p:nvSpPr>
-          <p:cNvPr id="24" name="Text 22"/>
           <p:cNvSpPr/>
           <p:nvPr/>
         </p:nvSpPr>
@@ -8457,7 +9054,7 @@
                 <a:ea typeface="Calibri" pitchFamily="34" charset="-122"/>
                 <a:cs typeface="Calibri" pitchFamily="34" charset="-120"/>
               </a:rPr>
-              <a:t>BUILT FOR HOW YOU WORK</a:t>
+              <a:t>WHY IT'S USEFUL</a:t>
             </a:r>
             <a:endParaRPr lang="en-US" sz="1200" dirty="0"/>
           </a:p>
@@ -8496,7 +9093,7 @@
                 <a:ea typeface="Cambria" pitchFamily="34" charset="-122"/>
                 <a:cs typeface="Cambria" pitchFamily="34" charset="-120"/>
               </a:rPr>
-              <a:t>No friction, no training, no app store</a:t>
+              <a:t>From information to leverage</a:t>
             </a:r>
             <a:endParaRPr lang="en-US" sz="3000" dirty="0"/>
           </a:p>
@@ -8510,12 +9107,12 @@
         </p:nvSpPr>
         <p:spPr>
           <a:xfrm>
-            <a:off x="548640" y="1600200"/>
-            <a:ext cx="3566160" cy="1600200"/>
+            <a:off x="548640" y="1554480"/>
+            <a:ext cx="11064240" cy="1051560"/>
           </a:xfrm>
           <a:prstGeom prst="roundRect">
             <a:avLst>
-              <a:gd name="adj" fmla="val 4571"/>
+              <a:gd name="adj" fmla="val 6957"/>
             </a:avLst>
           </a:prstGeom>
           <a:solidFill>
@@ -8544,14 +9141,14 @@
         </p:nvSpPr>
         <p:spPr>
           <a:xfrm>
-            <a:off x="749808" y="1819656"/>
+            <a:off x="749808" y="1773936"/>
             <a:ext cx="457200" cy="457200"/>
           </a:xfrm>
           <a:prstGeom prst="ellipse">
             <a:avLst/>
           </a:prstGeom>
           <a:solidFill>
-            <a:srgbClr val="EE9455"/>
+            <a:srgbClr val="1B6B4A"/>
           </a:solidFill>
           <a:ln/>
         </p:spPr>
@@ -8564,7 +9161,7 @@
         </p:nvSpPr>
         <p:spPr>
           <a:xfrm>
-            <a:off x="749808" y="1819656"/>
+            <a:off x="749808" y="1773936"/>
             <a:ext cx="457200" cy="457200"/>
           </a:xfrm>
           <a:prstGeom prst="rect">
@@ -8589,7 +9186,7 @@
                 <a:ea typeface="Calibri" pitchFamily="34" charset="-122"/>
                 <a:cs typeface="Calibri" pitchFamily="34" charset="-120"/>
               </a:rPr>
-              <a:t>★</a:t>
+              <a:t>✓</a:t>
             </a:r>
             <a:endParaRPr lang="en-US" sz="1500" dirty="0"/>
           </a:p>
@@ -8603,8 +9200,8 @@
         </p:nvSpPr>
         <p:spPr>
           <a:xfrm>
-            <a:off x="1371600" y="1746504"/>
-            <a:ext cx="2606040" cy="310896"/>
+            <a:off x="1371600" y="1700784"/>
+            <a:ext cx="10104120" cy="310896"/>
           </a:xfrm>
           <a:prstGeom prst="rect">
             <a:avLst/>
@@ -8628,7 +9225,7 @@
                 <a:ea typeface="Calibri" pitchFamily="34" charset="-122"/>
                 <a:cs typeface="Calibri" pitchFamily="34" charset="-120"/>
               </a:rPr>
-              <a:t>Any phone</a:t>
+              <a:t>See the whole board</a:t>
             </a:r>
             <a:endParaRPr lang="en-US" sz="1400" dirty="0"/>
           </a:p>
@@ -8642,8 +9239,8 @@
         </p:nvSpPr>
         <p:spPr>
           <a:xfrm>
-            <a:off x="1371600" y="2057400"/>
-            <a:ext cx="2606040" cy="1051560"/>
+            <a:off x="1371600" y="2011680"/>
+            <a:ext cx="10104120" cy="502920"/>
           </a:xfrm>
           <a:prstGeom prst="rect">
             <a:avLst/>
@@ -8667,7 +9264,7 @@
                 <a:ea typeface="Calibri" pitchFamily="34" charset="-122"/>
                 <a:cs typeface="Calibri" pitchFamily="34" charset="-120"/>
               </a:rPr>
-              <a:t>Installs like an app from the browser — a Progressive Web App, works on modest devices</a:t>
+              <a:t>Every pressure and every responder in one view — the picture no single org holds.</a:t>
             </a:r>
             <a:endParaRPr lang="en-US" sz="1150" dirty="0"/>
           </a:p>
@@ -8681,12 +9278,12 @@
         </p:nvSpPr>
         <p:spPr>
           <a:xfrm>
-            <a:off x="4261104" y="1600200"/>
-            <a:ext cx="3566160" cy="1600200"/>
+            <a:off x="548640" y="2724912"/>
+            <a:ext cx="11064240" cy="1051560"/>
           </a:xfrm>
           <a:prstGeom prst="roundRect">
             <a:avLst>
-              <a:gd name="adj" fmla="val 4571"/>
+              <a:gd name="adj" fmla="val 6957"/>
             </a:avLst>
           </a:prstGeom>
           <a:solidFill>
@@ -8715,14 +9312,14 @@
         </p:nvSpPr>
         <p:spPr>
           <a:xfrm>
-            <a:off x="4462272" y="1819656"/>
+            <a:off x="749808" y="2944368"/>
             <a:ext cx="457200" cy="457200"/>
           </a:xfrm>
           <a:prstGeom prst="ellipse">
             <a:avLst/>
           </a:prstGeom>
           <a:solidFill>
-            <a:srgbClr val="EE9455"/>
+            <a:srgbClr val="1B6B4A"/>
           </a:solidFill>
           <a:ln/>
         </p:spPr>
@@ -8735,7 +9332,7 @@
         </p:nvSpPr>
         <p:spPr>
           <a:xfrm>
-            <a:off x="4462272" y="1819656"/>
+            <a:off x="749808" y="2944368"/>
             <a:ext cx="457200" cy="457200"/>
           </a:xfrm>
           <a:prstGeom prst="rect">
@@ -8760,7 +9357,7 @@
                 <a:ea typeface="Calibri" pitchFamily="34" charset="-122"/>
                 <a:cs typeface="Calibri" pitchFamily="34" charset="-120"/>
               </a:rPr>
-              <a:t>★</a:t>
+              <a:t>✓</a:t>
             </a:r>
             <a:endParaRPr lang="en-US" sz="1500" dirty="0"/>
           </a:p>
@@ -8774,8 +9371,8 @@
         </p:nvSpPr>
         <p:spPr>
           <a:xfrm>
-            <a:off x="5084064" y="1746504"/>
-            <a:ext cx="2606040" cy="310896"/>
+            <a:off x="1371600" y="2871216"/>
+            <a:ext cx="10104120" cy="310896"/>
           </a:xfrm>
           <a:prstGeom prst="rect">
             <a:avLst/>
@@ -8799,7 +9396,7 @@
                 <a:ea typeface="Calibri" pitchFamily="34" charset="-122"/>
                 <a:cs typeface="Calibri" pitchFamily="34" charset="-120"/>
               </a:rPr>
-              <a:t>Works offline</a:t>
+              <a:t>Find the gaps</a:t>
             </a:r>
             <a:endParaRPr lang="en-US" sz="1400" dirty="0"/>
           </a:p>
@@ -8813,8 +9410,8 @@
         </p:nvSpPr>
         <p:spPr>
           <a:xfrm>
-            <a:off x="5084064" y="2057400"/>
-            <a:ext cx="2606040" cy="1051560"/>
+            <a:off x="1371600" y="3182112"/>
+            <a:ext cx="10104120" cy="502920"/>
           </a:xfrm>
           <a:prstGeom prst="rect">
             <a:avLst/>
@@ -8838,7 +9435,7 @@
                 <a:ea typeface="Calibri" pitchFamily="34" charset="-122"/>
                 <a:cs typeface="Calibri" pitchFamily="34" charset="-120"/>
               </a:rPr>
-              <a:t>Caches so it opens fast and keeps working on a weak connection</a:t>
+              <a:t>A ranking that shows exactly where a marginal effort or grant counts most.</a:t>
             </a:r>
             <a:endParaRPr lang="en-US" sz="1150" dirty="0"/>
           </a:p>
@@ -8852,12 +9449,12 @@
         </p:nvSpPr>
         <p:spPr>
           <a:xfrm>
-            <a:off x="7973568" y="1600200"/>
-            <a:ext cx="3566160" cy="1600200"/>
+            <a:off x="548640" y="3895344"/>
+            <a:ext cx="11064240" cy="1051560"/>
           </a:xfrm>
           <a:prstGeom prst="roundRect">
             <a:avLst>
-              <a:gd name="adj" fmla="val 4571"/>
+              <a:gd name="adj" fmla="val 6957"/>
             </a:avLst>
           </a:prstGeom>
           <a:solidFill>
@@ -8886,14 +9483,14 @@
         </p:nvSpPr>
         <p:spPr>
           <a:xfrm>
-            <a:off x="8174736" y="1819656"/>
+            <a:off x="749808" y="4114800"/>
             <a:ext cx="457200" cy="457200"/>
           </a:xfrm>
           <a:prstGeom prst="ellipse">
             <a:avLst/>
           </a:prstGeom>
           <a:solidFill>
-            <a:srgbClr val="EE9455"/>
+            <a:srgbClr val="1B6B4A"/>
           </a:solidFill>
           <a:ln/>
         </p:spPr>
@@ -8906,7 +9503,7 @@
         </p:nvSpPr>
         <p:spPr>
           <a:xfrm>
-            <a:off x="8174736" y="1819656"/>
+            <a:off x="749808" y="4114800"/>
             <a:ext cx="457200" cy="457200"/>
           </a:xfrm>
           <a:prstGeom prst="rect">
@@ -8931,7 +9528,7 @@
                 <a:ea typeface="Calibri" pitchFamily="34" charset="-122"/>
                 <a:cs typeface="Calibri" pitchFamily="34" charset="-120"/>
               </a:rPr>
-              <a:t>★</a:t>
+              <a:t>✓</a:t>
             </a:r>
             <a:endParaRPr lang="en-US" sz="1500" dirty="0"/>
           </a:p>
@@ -8945,8 +9542,8 @@
         </p:nvSpPr>
         <p:spPr>
           <a:xfrm>
-            <a:off x="8796528" y="1746504"/>
-            <a:ext cx="2606040" cy="310896"/>
+            <a:off x="1371600" y="4041648"/>
+            <a:ext cx="10104120" cy="310896"/>
           </a:xfrm>
           <a:prstGeom prst="rect">
             <a:avLst/>
@@ -8970,7 +9567,7 @@
                 <a:ea typeface="Calibri" pitchFamily="34" charset="-122"/>
                 <a:cs typeface="Calibri" pitchFamily="34" charset="-120"/>
               </a:rPr>
-              <a:t>Three languages</a:t>
+              <a:t>Coordinate &amp; convene</a:t>
             </a:r>
             <a:endParaRPr lang="en-US" sz="1400" dirty="0"/>
           </a:p>
@@ -8984,8 +9581,8 @@
         </p:nvSpPr>
         <p:spPr>
           <a:xfrm>
-            <a:off x="8796528" y="2057400"/>
-            <a:ext cx="2606040" cy="1051560"/>
+            <a:off x="1371600" y="4352544"/>
+            <a:ext cx="10104120" cy="502920"/>
           </a:xfrm>
           <a:prstGeom prst="rect">
             <a:avLst/>
@@ -9009,7 +9606,7 @@
                 <a:ea typeface="Calibri" pitchFamily="34" charset="-122"/>
                 <a:cs typeface="Calibri" pitchFamily="34" charset="-120"/>
               </a:rPr>
-              <a:t>English, Kiswahili and Sheng — meet people where they are</a:t>
+              <a:t>Directory, resource exchange and one-click video calls keep the coalition moving together.</a:t>
             </a:r>
             <a:endParaRPr lang="en-US" sz="1150" dirty="0"/>
           </a:p>
@@ -9023,12 +9620,12 @@
         </p:nvSpPr>
         <p:spPr>
           <a:xfrm>
-            <a:off x="548640" y="3383280"/>
-            <a:ext cx="3566160" cy="1600200"/>
+            <a:off x="548640" y="5065776"/>
+            <a:ext cx="11064240" cy="1051560"/>
           </a:xfrm>
           <a:prstGeom prst="roundRect">
             <a:avLst>
-              <a:gd name="adj" fmla="val 4571"/>
+              <a:gd name="adj" fmla="val 6957"/>
             </a:avLst>
           </a:prstGeom>
           <a:solidFill>
@@ -9057,14 +9654,14 @@
         </p:nvSpPr>
         <p:spPr>
           <a:xfrm>
-            <a:off x="749808" y="3602736"/>
+            <a:off x="749808" y="5285232"/>
             <a:ext cx="457200" cy="457200"/>
           </a:xfrm>
           <a:prstGeom prst="ellipse">
             <a:avLst/>
           </a:prstGeom>
           <a:solidFill>
-            <a:srgbClr val="EE9455"/>
+            <a:srgbClr val="1B6B4A"/>
           </a:solidFill>
           <a:ln/>
         </p:spPr>
@@ -9077,7 +9674,7 @@
         </p:nvSpPr>
         <p:spPr>
           <a:xfrm>
-            <a:off x="749808" y="3602736"/>
+            <a:off x="749808" y="5285232"/>
             <a:ext cx="457200" cy="457200"/>
           </a:xfrm>
           <a:prstGeom prst="rect">
@@ -9102,7 +9699,7 @@
                 <a:ea typeface="Calibri" pitchFamily="34" charset="-122"/>
                 <a:cs typeface="Calibri" pitchFamily="34" charset="-120"/>
               </a:rPr>
-              <a:t>★</a:t>
+              <a:t>✓</a:t>
             </a:r>
             <a:endParaRPr lang="en-US" sz="1500" dirty="0"/>
           </a:p>
@@ -9116,8 +9713,8 @@
         </p:nvSpPr>
         <p:spPr>
           <a:xfrm>
-            <a:off x="1371600" y="3529584"/>
-            <a:ext cx="2606040" cy="310896"/>
+            <a:off x="1371600" y="5212080"/>
+            <a:ext cx="10104120" cy="310896"/>
           </a:xfrm>
           <a:prstGeom prst="rect">
             <a:avLst/>
@@ -9141,7 +9738,7 @@
                 <a:ea typeface="Calibri" pitchFamily="34" charset="-122"/>
                 <a:cs typeface="Calibri" pitchFamily="34" charset="-120"/>
               </a:rPr>
-              <a:t>Members-only &amp; secure</a:t>
+              <a:t>Amplify &amp; mobilise</a:t>
             </a:r>
             <a:endParaRPr lang="en-US" sz="1400" dirty="0"/>
           </a:p>
@@ -9155,8 +9752,8 @@
         </p:nvSpPr>
         <p:spPr>
           <a:xfrm>
-            <a:off x="1371600" y="3840480"/>
-            <a:ext cx="2606040" cy="1051560"/>
+            <a:off x="1371600" y="5522976"/>
+            <a:ext cx="10104120" cy="502920"/>
           </a:xfrm>
           <a:prstGeom prst="rect">
             <a:avLst/>
@@ -9180,7 +9777,7 @@
                 <a:ea typeface="Calibri" pitchFamily="34" charset="-122"/>
                 <a:cs typeface="Calibri" pitchFamily="34" charset="-120"/>
               </a:rPr>
-              <a:t>Invite-only sign-in; your coordination stays inside the coalition</a:t>
+              <a:t>Petitions, public debunks and social sharing turn evidence into pressure.</a:t>
             </a:r>
             <a:endParaRPr lang="en-US" sz="1150" dirty="0"/>
           </a:p>
@@ -9188,349 +9785,7 @@
       </p:sp>
       <p:sp>
         <p:nvSpPr>
-          <p:cNvPr id="24" name="Shape 22"/>
-          <p:cNvSpPr/>
-          <p:nvPr/>
-        </p:nvSpPr>
-        <p:spPr>
-          <a:xfrm>
-            <a:off x="4261104" y="3383280"/>
-            <a:ext cx="3566160" cy="1600200"/>
-          </a:xfrm>
-          <a:prstGeom prst="roundRect">
-            <a:avLst>
-              <a:gd name="adj" fmla="val 4571"/>
-            </a:avLst>
-          </a:prstGeom>
-          <a:solidFill>
-            <a:srgbClr val="F1F5F3"/>
-          </a:solidFill>
-          <a:ln w="9525">
-            <a:solidFill>
-              <a:srgbClr val="D9E2DC"/>
-            </a:solidFill>
-            <a:prstDash val="solid"/>
-          </a:ln>
-          <a:effectLst>
-            <a:outerShdw sx="100000" sy="100000" kx="0" ky="0" algn="bl" rotWithShape="0" blurRad="76200" dist="25400" dir="5400000">
-              <a:srgbClr val="9AA8A0">
-                <a:alpha val="35000"/>
-              </a:srgbClr>
-            </a:outerShdw>
-          </a:effectLst>
-        </p:spPr>
-      </p:sp>
-      <p:sp>
-        <p:nvSpPr>
-          <p:cNvPr id="25" name="Shape 23"/>
-          <p:cNvSpPr/>
-          <p:nvPr/>
-        </p:nvSpPr>
-        <p:spPr>
-          <a:xfrm>
-            <a:off x="4462272" y="3602736"/>
-            <a:ext cx="457200" cy="457200"/>
-          </a:xfrm>
-          <a:prstGeom prst="ellipse">
-            <a:avLst/>
-          </a:prstGeom>
-          <a:solidFill>
-            <a:srgbClr val="EE9455"/>
-          </a:solidFill>
-          <a:ln/>
-        </p:spPr>
-      </p:sp>
-      <p:sp>
-        <p:nvSpPr>
-          <p:cNvPr id="26" name="Text 24"/>
-          <p:cNvSpPr/>
-          <p:nvPr/>
-        </p:nvSpPr>
-        <p:spPr>
-          <a:xfrm>
-            <a:off x="4462272" y="3602736"/>
-            <a:ext cx="457200" cy="457200"/>
-          </a:xfrm>
-          <a:prstGeom prst="rect">
-            <a:avLst/>
-          </a:prstGeom>
-          <a:noFill/>
-          <a:ln/>
-        </p:spPr>
-        <p:txBody>
-          <a:bodyPr wrap="square" lIns="0" tIns="0" rIns="0" bIns="0" rtlCol="0" anchor="ctr"/>
-          <a:lstStyle/>
-          <a:p>
-            <a:pPr algn="ctr" indent="0" marL="0">
-              <a:buNone/>
-            </a:pPr>
-            <a:r>
-              <a:rPr lang="en-US" sz="1500" b="1" dirty="0">
-                <a:solidFill>
-                  <a:srgbClr val="FFFFFF"/>
-                </a:solidFill>
-                <a:latin typeface="Calibri" pitchFamily="34" charset="0"/>
-                <a:ea typeface="Calibri" pitchFamily="34" charset="-122"/>
-                <a:cs typeface="Calibri" pitchFamily="34" charset="-120"/>
-              </a:rPr>
-              <a:t>★</a:t>
-            </a:r>
-            <a:endParaRPr lang="en-US" sz="1500" dirty="0"/>
-          </a:p>
-        </p:txBody>
-      </p:sp>
-      <p:sp>
-        <p:nvSpPr>
-          <p:cNvPr id="27" name="Text 25"/>
-          <p:cNvSpPr/>
-          <p:nvPr/>
-        </p:nvSpPr>
-        <p:spPr>
-          <a:xfrm>
-            <a:off x="5084064" y="3529584"/>
-            <a:ext cx="2606040" cy="310896"/>
-          </a:xfrm>
-          <a:prstGeom prst="rect">
-            <a:avLst/>
-          </a:prstGeom>
-          <a:noFill/>
-          <a:ln/>
-        </p:spPr>
-        <p:txBody>
-          <a:bodyPr wrap="square" lIns="0" tIns="0" rIns="0" bIns="0" rtlCol="0" anchor="ctr"/>
-          <a:lstStyle/>
-          <a:p>
-            <a:pPr indent="0" marL="0">
-              <a:buNone/>
-            </a:pPr>
-            <a:r>
-              <a:rPr lang="en-US" sz="1400" b="1" dirty="0">
-                <a:solidFill>
-                  <a:srgbClr val="1D2621"/>
-                </a:solidFill>
-                <a:latin typeface="Calibri" pitchFamily="34" charset="0"/>
-                <a:ea typeface="Calibri" pitchFamily="34" charset="-122"/>
-                <a:cs typeface="Calibri" pitchFamily="34" charset="-120"/>
-              </a:rPr>
-              <a:t>One tap in</a:t>
-            </a:r>
-            <a:endParaRPr lang="en-US" sz="1400" dirty="0"/>
-          </a:p>
-        </p:txBody>
-      </p:sp>
-      <p:sp>
-        <p:nvSpPr>
-          <p:cNvPr id="28" name="Text 26"/>
-          <p:cNvSpPr/>
-          <p:nvPr/>
-        </p:nvSpPr>
-        <p:spPr>
-          <a:xfrm>
-            <a:off x="5084064" y="3840480"/>
-            <a:ext cx="2606040" cy="1051560"/>
-          </a:xfrm>
-          <a:prstGeom prst="rect">
-            <a:avLst/>
-          </a:prstGeom>
-          <a:noFill/>
-          <a:ln/>
-        </p:spPr>
-        <p:txBody>
-          <a:bodyPr wrap="square" lIns="0" tIns="0" rIns="0" bIns="0" rtlCol="0" anchor="t"/>
-          <a:lstStyle/>
-          <a:p>
-            <a:pPr indent="0" marL="0">
-              <a:buNone/>
-            </a:pPr>
-            <a:r>
-              <a:rPr lang="en-US" sz="1150" dirty="0">
-                <a:solidFill>
-                  <a:srgbClr val="5D6B63"/>
-                </a:solidFill>
-                <a:latin typeface="Calibri" pitchFamily="34" charset="0"/>
-                <a:ea typeface="Calibri" pitchFamily="34" charset="-122"/>
-                <a:cs typeface="Calibri" pitchFamily="34" charset="-120"/>
-              </a:rPr>
-              <a:t>Magic-link or password sign-in — nothing to configure</a:t>
-            </a:r>
-            <a:endParaRPr lang="en-US" sz="1150" dirty="0"/>
-          </a:p>
-        </p:txBody>
-      </p:sp>
-      <p:sp>
-        <p:nvSpPr>
-          <p:cNvPr id="29" name="Shape 27"/>
-          <p:cNvSpPr/>
-          <p:nvPr/>
-        </p:nvSpPr>
-        <p:spPr>
-          <a:xfrm>
-            <a:off x="7973568" y="3383280"/>
-            <a:ext cx="3566160" cy="1600200"/>
-          </a:xfrm>
-          <a:prstGeom prst="roundRect">
-            <a:avLst>
-              <a:gd name="adj" fmla="val 4571"/>
-            </a:avLst>
-          </a:prstGeom>
-          <a:solidFill>
-            <a:srgbClr val="F1F5F3"/>
-          </a:solidFill>
-          <a:ln w="9525">
-            <a:solidFill>
-              <a:srgbClr val="D9E2DC"/>
-            </a:solidFill>
-            <a:prstDash val="solid"/>
-          </a:ln>
-          <a:effectLst>
-            <a:outerShdw sx="100000" sy="100000" kx="0" ky="0" algn="bl" rotWithShape="0" blurRad="76200" dist="25400" dir="5400000">
-              <a:srgbClr val="9AA8A0">
-                <a:alpha val="35000"/>
-              </a:srgbClr>
-            </a:outerShdw>
-          </a:effectLst>
-        </p:spPr>
-      </p:sp>
-      <p:sp>
-        <p:nvSpPr>
-          <p:cNvPr id="30" name="Shape 28"/>
-          <p:cNvSpPr/>
-          <p:nvPr/>
-        </p:nvSpPr>
-        <p:spPr>
-          <a:xfrm>
-            <a:off x="8174736" y="3602736"/>
-            <a:ext cx="457200" cy="457200"/>
-          </a:xfrm>
-          <a:prstGeom prst="ellipse">
-            <a:avLst/>
-          </a:prstGeom>
-          <a:solidFill>
-            <a:srgbClr val="EE9455"/>
-          </a:solidFill>
-          <a:ln/>
-        </p:spPr>
-      </p:sp>
-      <p:sp>
-        <p:nvSpPr>
-          <p:cNvPr id="31" name="Text 29"/>
-          <p:cNvSpPr/>
-          <p:nvPr/>
-        </p:nvSpPr>
-        <p:spPr>
-          <a:xfrm>
-            <a:off x="8174736" y="3602736"/>
-            <a:ext cx="457200" cy="457200"/>
-          </a:xfrm>
-          <a:prstGeom prst="rect">
-            <a:avLst/>
-          </a:prstGeom>
-          <a:noFill/>
-          <a:ln/>
-        </p:spPr>
-        <p:txBody>
-          <a:bodyPr wrap="square" lIns="0" tIns="0" rIns="0" bIns="0" rtlCol="0" anchor="ctr"/>
-          <a:lstStyle/>
-          <a:p>
-            <a:pPr algn="ctr" indent="0" marL="0">
-              <a:buNone/>
-            </a:pPr>
-            <a:r>
-              <a:rPr lang="en-US" sz="1500" b="1" dirty="0">
-                <a:solidFill>
-                  <a:srgbClr val="FFFFFF"/>
-                </a:solidFill>
-                <a:latin typeface="Calibri" pitchFamily="34" charset="0"/>
-                <a:ea typeface="Calibri" pitchFamily="34" charset="-122"/>
-                <a:cs typeface="Calibri" pitchFamily="34" charset="-120"/>
-              </a:rPr>
-              <a:t>★</a:t>
-            </a:r>
-            <a:endParaRPr lang="en-US" sz="1500" dirty="0"/>
-          </a:p>
-        </p:txBody>
-      </p:sp>
-      <p:sp>
-        <p:nvSpPr>
-          <p:cNvPr id="32" name="Text 30"/>
-          <p:cNvSpPr/>
-          <p:nvPr/>
-        </p:nvSpPr>
-        <p:spPr>
-          <a:xfrm>
-            <a:off x="8796528" y="3529584"/>
-            <a:ext cx="2606040" cy="310896"/>
-          </a:xfrm>
-          <a:prstGeom prst="rect">
-            <a:avLst/>
-          </a:prstGeom>
-          <a:noFill/>
-          <a:ln/>
-        </p:spPr>
-        <p:txBody>
-          <a:bodyPr wrap="square" lIns="0" tIns="0" rIns="0" bIns="0" rtlCol="0" anchor="ctr"/>
-          <a:lstStyle/>
-          <a:p>
-            <a:pPr indent="0" marL="0">
-              <a:buNone/>
-            </a:pPr>
-            <a:r>
-              <a:rPr lang="en-US" sz="1400" b="1" dirty="0">
-                <a:solidFill>
-                  <a:srgbClr val="1D2621"/>
-                </a:solidFill>
-                <a:latin typeface="Calibri" pitchFamily="34" charset="0"/>
-                <a:ea typeface="Calibri" pitchFamily="34" charset="-122"/>
-                <a:cs typeface="Calibri" pitchFamily="34" charset="-120"/>
-              </a:rPr>
-              <a:t>Sourced &amp; honest</a:t>
-            </a:r>
-            <a:endParaRPr lang="en-US" sz="1400" dirty="0"/>
-          </a:p>
-        </p:txBody>
-      </p:sp>
-      <p:sp>
-        <p:nvSpPr>
-          <p:cNvPr id="33" name="Text 31"/>
-          <p:cNvSpPr/>
-          <p:nvPr/>
-        </p:nvSpPr>
-        <p:spPr>
-          <a:xfrm>
-            <a:off x="8796528" y="3840480"/>
-            <a:ext cx="2606040" cy="1051560"/>
-          </a:xfrm>
-          <a:prstGeom prst="rect">
-            <a:avLst/>
-          </a:prstGeom>
-          <a:noFill/>
-          <a:ln/>
-        </p:spPr>
-        <p:txBody>
-          <a:bodyPr wrap="square" lIns="0" tIns="0" rIns="0" bIns="0" rtlCol="0" anchor="t"/>
-          <a:lstStyle/>
-          <a:p>
-            <a:pPr indent="0" marL="0">
-              <a:buNone/>
-            </a:pPr>
-            <a:r>
-              <a:rPr lang="en-US" sz="1150" dirty="0">
-                <a:solidFill>
-                  <a:srgbClr val="5D6B63"/>
-                </a:solidFill>
-                <a:latin typeface="Calibri" pitchFamily="34" charset="0"/>
-                <a:ea typeface="Calibri" pitchFamily="34" charset="-122"/>
-                <a:cs typeface="Calibri" pitchFamily="34" charset="-120"/>
-              </a:rPr>
-              <a:t>Every claim links to its source; no fabricated data</a:t>
-            </a:r>
-            <a:endParaRPr lang="en-US" sz="1150" dirty="0"/>
-          </a:p>
-        </p:txBody>
-      </p:sp>
-      <p:sp>
-        <p:nvSpPr>
-          <p:cNvPr id="34" name="Text 32"/>
+          <p:cNvPr id="24" name="Text 22"/>
           <p:cNvSpPr/>
           <p:nvPr/>
         </p:nvSpPr>
@@ -9632,7 +9887,7 @@
                 <a:ea typeface="Calibri" pitchFamily="34" charset="-122"/>
                 <a:cs typeface="Calibri" pitchFamily="34" charset="-120"/>
               </a:rPr>
-              <a:t>FOR FUNDERS</a:t>
+              <a:t>BUILT FOR HOW YOU WORK</a:t>
             </a:r>
             <a:endParaRPr lang="en-US" sz="1200" dirty="0"/>
           </a:p>
@@ -9671,7 +9926,7 @@
                 <a:ea typeface="Cambria" pitchFamily="34" charset="-122"/>
                 <a:cs typeface="Cambria" pitchFamily="34" charset="-120"/>
               </a:rPr>
-              <a:t>Where a marginal shilling moves the needle</a:t>
+              <a:t>No friction, no training, no app store</a:t>
             </a:r>
             <a:endParaRPr lang="en-US" sz="3000" dirty="0"/>
           </a:p>
@@ -9679,143 +9934,22 @@
       </p:sp>
       <p:sp>
         <p:nvSpPr>
-          <p:cNvPr id="4" name="Text 2"/>
-          <p:cNvSpPr/>
-          <p:nvPr/>
-        </p:nvSpPr>
-        <p:spPr>
-          <a:xfrm>
-            <a:off x="548640" y="1463040"/>
-            <a:ext cx="5486400" cy="2194560"/>
-          </a:xfrm>
-          <a:prstGeom prst="rect">
-            <a:avLst/>
-          </a:prstGeom>
-          <a:noFill/>
-          <a:ln/>
-        </p:spPr>
-        <p:txBody>
-          <a:bodyPr wrap="square" lIns="0" tIns="0" rIns="0" bIns="0" rtlCol="0" anchor="t"/>
-          <a:lstStyle/>
-          <a:p>
-            <a:pPr indent="0" marL="0">
-              <a:buNone/>
-            </a:pPr>
-            <a:r>
-              <a:rPr lang="en-US" sz="1500" dirty="0">
-                <a:solidFill>
-                  <a:srgbClr val="5D6B63"/>
-                </a:solidFill>
-                <a:latin typeface="Calibri" pitchFamily="34" charset="0"/>
-                <a:ea typeface="Calibri" pitchFamily="34" charset="-122"/>
-                <a:cs typeface="Calibri" pitchFamily="34" charset="-120"/>
-              </a:rPr>
-              <a:t>The map ranks counties by response gap and the platform exports reach, coverage and engagement data — so you fund live programme activity, not a retrospective annual report.</a:t>
-            </a:r>
-            <a:endParaRPr lang="en-US" sz="1500" dirty="0"/>
-          </a:p>
-        </p:txBody>
-      </p:sp>
-      <p:sp>
-        <p:nvSpPr>
-          <p:cNvPr id="5" name="Text 3"/>
-          <p:cNvSpPr/>
-          <p:nvPr/>
-        </p:nvSpPr>
-        <p:spPr>
-          <a:xfrm>
-            <a:off x="640080" y="3657600"/>
-            <a:ext cx="5394960" cy="2194560"/>
-          </a:xfrm>
-          <a:prstGeom prst="rect">
-            <a:avLst/>
-          </a:prstGeom>
-          <a:noFill/>
-          <a:ln/>
-        </p:spPr>
-        <p:txBody>
-          <a:bodyPr wrap="square" lIns="0" tIns="0" rIns="0" bIns="0" rtlCol="0" anchor="ctr"/>
-          <a:lstStyle/>
-          <a:p>
-            <a:pPr marL="203200" indent="-203200">
-              <a:spcAft>
-                <a:spcPts val="1000"/>
-              </a:spcAft>
-              <a:buSzPct val="100000"/>
-              <a:buChar char="•"/>
-            </a:pPr>
-            <a:r>
-              <a:rPr lang="en-US" sz="1400" dirty="0">
-                <a:solidFill>
-                  <a:srgbClr val="1D2621"/>
-                </a:solidFill>
-                <a:latin typeface="Calibri" pitchFamily="34" charset="0"/>
-                <a:ea typeface="Calibri" pitchFamily="34" charset="-122"/>
-                <a:cs typeface="Calibri" pitchFamily="34" charset="-120"/>
-              </a:rPr>
-              <a:t>Fund a documentation partner in a top-gap county</a:t>
-            </a:r>
-            <a:endParaRPr lang="en-US" sz="1400" dirty="0"/>
-          </a:p>
-          <a:p>
-            <a:pPr marL="203200" indent="-203200">
-              <a:spcAft>
-                <a:spcPts val="1000"/>
-              </a:spcAft>
-              <a:buSzPct val="100000"/>
-              <a:buChar char="•"/>
-            </a:pPr>
-            <a:r>
-              <a:rPr lang="en-US" sz="1400" dirty="0">
-                <a:solidFill>
-                  <a:srgbClr val="1D2621"/>
-                </a:solidFill>
-                <a:latin typeface="Calibri" pitchFamily="34" charset="0"/>
-                <a:ea typeface="Calibri" pitchFamily="34" charset="-122"/>
-                <a:cs typeface="Calibri" pitchFamily="34" charset="-120"/>
-              </a:rPr>
-              <a:t>Back a live legal matter through to judgment</a:t>
-            </a:r>
-            <a:endParaRPr lang="en-US" sz="1400" dirty="0"/>
-          </a:p>
-          <a:p>
-            <a:pPr marL="203200" indent="-203200">
-              <a:buSzPct val="100000"/>
-              <a:buChar char="•"/>
-            </a:pPr>
-            <a:r>
-              <a:rPr lang="en-US" sz="1400" dirty="0">
-                <a:solidFill>
-                  <a:srgbClr val="1D2621"/>
-                </a:solidFill>
-                <a:latin typeface="Calibri" pitchFamily="34" charset="0"/>
-                <a:ea typeface="Calibri" pitchFamily="34" charset="-122"/>
-                <a:cs typeface="Calibri" pitchFamily="34" charset="-120"/>
-              </a:rPr>
-              <a:t>Support the coalition secretariat that keeps it current</a:t>
-            </a:r>
-            <a:endParaRPr lang="en-US" sz="1400" dirty="0"/>
-          </a:p>
-        </p:txBody>
-      </p:sp>
-      <p:sp>
-        <p:nvSpPr>
-          <p:cNvPr id="6" name="Shape 4"/>
-          <p:cNvSpPr/>
-          <p:nvPr/>
-        </p:nvSpPr>
-        <p:spPr>
-          <a:xfrm>
-            <a:off x="6400800" y="1554480"/>
-            <a:ext cx="2487168" cy="2103120"/>
+          <p:cNvPr id="4" name="Shape 2"/>
+          <p:cNvSpPr/>
+          <p:nvPr/>
+        </p:nvSpPr>
+        <p:spPr>
+          <a:xfrm>
+            <a:off x="548640" y="1600200"/>
+            <a:ext cx="3566160" cy="1600200"/>
           </a:xfrm>
           <a:prstGeom prst="roundRect">
             <a:avLst>
-              <a:gd name="adj" fmla="val 3478"/>
+              <a:gd name="adj" fmla="val 4571"/>
             </a:avLst>
           </a:prstGeom>
           <a:solidFill>
-            <a:srgbClr val="FFFFFF"/>
+            <a:srgbClr val="F1F5F3"/>
           </a:solidFill>
           <a:ln w="9525">
             <a:solidFill>
@@ -9834,40 +9968,99 @@
       </p:sp>
       <p:sp>
         <p:nvSpPr>
+          <p:cNvPr id="5" name="Shape 3"/>
+          <p:cNvSpPr/>
+          <p:nvPr/>
+        </p:nvSpPr>
+        <p:spPr>
+          <a:xfrm>
+            <a:off x="749808" y="1819656"/>
+            <a:ext cx="457200" cy="457200"/>
+          </a:xfrm>
+          <a:prstGeom prst="ellipse">
+            <a:avLst/>
+          </a:prstGeom>
+          <a:solidFill>
+            <a:srgbClr val="EE9455"/>
+          </a:solidFill>
+          <a:ln/>
+        </p:spPr>
+      </p:sp>
+      <p:sp>
+        <p:nvSpPr>
+          <p:cNvPr id="6" name="Text 4"/>
+          <p:cNvSpPr/>
+          <p:nvPr/>
+        </p:nvSpPr>
+        <p:spPr>
+          <a:xfrm>
+            <a:off x="749808" y="1819656"/>
+            <a:ext cx="457200" cy="457200"/>
+          </a:xfrm>
+          <a:prstGeom prst="rect">
+            <a:avLst/>
+          </a:prstGeom>
+          <a:noFill/>
+          <a:ln/>
+        </p:spPr>
+        <p:txBody>
+          <a:bodyPr wrap="square" lIns="0" tIns="0" rIns="0" bIns="0" rtlCol="0" anchor="ctr"/>
+          <a:lstStyle/>
+          <a:p>
+            <a:pPr algn="ctr" indent="0" marL="0">
+              <a:buNone/>
+            </a:pPr>
+            <a:r>
+              <a:rPr lang="en-US" sz="1500" b="1" dirty="0">
+                <a:solidFill>
+                  <a:srgbClr val="FFFFFF"/>
+                </a:solidFill>
+                <a:latin typeface="Calibri" pitchFamily="34" charset="0"/>
+                <a:ea typeface="Calibri" pitchFamily="34" charset="-122"/>
+                <a:cs typeface="Calibri" pitchFamily="34" charset="-120"/>
+              </a:rPr>
+              <a:t>★</a:t>
+            </a:r>
+            <a:endParaRPr lang="en-US" sz="1500" dirty="0"/>
+          </a:p>
+        </p:txBody>
+      </p:sp>
+      <p:sp>
+        <p:nvSpPr>
           <p:cNvPr id="7" name="Text 5"/>
           <p:cNvSpPr/>
           <p:nvPr/>
         </p:nvSpPr>
         <p:spPr>
           <a:xfrm>
-            <a:off x="6492240" y="1719072"/>
-            <a:ext cx="2304288" cy="822960"/>
-          </a:xfrm>
-          <a:prstGeom prst="rect">
-            <a:avLst/>
-          </a:prstGeom>
-          <a:noFill/>
-          <a:ln/>
-        </p:spPr>
-        <p:txBody>
-          <a:bodyPr wrap="square" lIns="0" tIns="0" rIns="0" bIns="0" rtlCol="0" anchor="ctr"/>
-          <a:lstStyle/>
-          <a:p>
-            <a:pPr algn="ctr" indent="0" marL="0">
-              <a:buNone/>
-            </a:pPr>
-            <a:r>
-              <a:rPr lang="en-US" sz="3400" b="1" dirty="0">
-                <a:solidFill>
-                  <a:srgbClr val="1B6B4A"/>
-                </a:solidFill>
-                <a:latin typeface="Cambria" pitchFamily="34" charset="0"/>
-                <a:ea typeface="Cambria" pitchFamily="34" charset="-122"/>
-                <a:cs typeface="Cambria" pitchFamily="34" charset="-120"/>
-              </a:rPr>
-              <a:t>47</a:t>
-            </a:r>
-            <a:endParaRPr lang="en-US" sz="3400" dirty="0"/>
+            <a:off x="1371600" y="1746504"/>
+            <a:ext cx="2606040" cy="310896"/>
+          </a:xfrm>
+          <a:prstGeom prst="rect">
+            <a:avLst/>
+          </a:prstGeom>
+          <a:noFill/>
+          <a:ln/>
+        </p:spPr>
+        <p:txBody>
+          <a:bodyPr wrap="square" lIns="0" tIns="0" rIns="0" bIns="0" rtlCol="0" anchor="ctr"/>
+          <a:lstStyle/>
+          <a:p>
+            <a:pPr indent="0" marL="0">
+              <a:buNone/>
+            </a:pPr>
+            <a:r>
+              <a:rPr lang="en-US" sz="1400" b="1" dirty="0">
+                <a:solidFill>
+                  <a:srgbClr val="1D2621"/>
+                </a:solidFill>
+                <a:latin typeface="Calibri" pitchFamily="34" charset="0"/>
+                <a:ea typeface="Calibri" pitchFamily="34" charset="-122"/>
+                <a:cs typeface="Calibri" pitchFamily="34" charset="-120"/>
+              </a:rPr>
+              <a:t>Any phone</a:t>
+            </a:r>
+            <a:endParaRPr lang="en-US" sz="1400" dirty="0"/>
           </a:p>
         </p:txBody>
       </p:sp>
@@ -9879,8 +10072,8 @@
         </p:nvSpPr>
         <p:spPr>
           <a:xfrm>
-            <a:off x="6510528" y="2514600"/>
-            <a:ext cx="2267712" cy="1097280"/>
+            <a:off x="1371600" y="2057400"/>
+            <a:ext cx="2606040" cy="1051560"/>
           </a:xfrm>
           <a:prstGeom prst="rect">
             <a:avLst/>
@@ -9892,11 +10085,11 @@
           <a:bodyPr wrap="square" lIns="0" tIns="0" rIns="0" bIns="0" rtlCol="0" anchor="t"/>
           <a:lstStyle/>
           <a:p>
-            <a:pPr algn="ctr" indent="0" marL="0">
-              <a:buNone/>
-            </a:pPr>
-            <a:r>
-              <a:rPr lang="en-US" sz="1100" dirty="0">
+            <a:pPr indent="0" marL="0">
+              <a:buNone/>
+            </a:pPr>
+            <a:r>
+              <a:rPr lang="en-US" sz="1150" dirty="0">
                 <a:solidFill>
                   <a:srgbClr val="5D6B63"/>
                 </a:solidFill>
@@ -9904,9 +10097,9 @@
                 <a:ea typeface="Calibri" pitchFamily="34" charset="-122"/>
                 <a:cs typeface="Calibri" pitchFamily="34" charset="-120"/>
               </a:rPr>
-              <a:t>counties, one gap-ranked view</a:t>
-            </a:r>
-            <a:endParaRPr lang="en-US" sz="1100" dirty="0"/>
+              <a:t>Installs like an app from the browser — a Progressive Web App, works on modest devices</a:t>
+            </a:r>
+            <a:endParaRPr lang="en-US" sz="1150" dirty="0"/>
           </a:p>
         </p:txBody>
       </p:sp>
@@ -9918,16 +10111,16 @@
         </p:nvSpPr>
         <p:spPr>
           <a:xfrm>
-            <a:off x="9052560" y="1554480"/>
-            <a:ext cx="2487168" cy="2103120"/>
+            <a:off x="4261104" y="1600200"/>
+            <a:ext cx="3566160" cy="1600200"/>
           </a:xfrm>
           <a:prstGeom prst="roundRect">
             <a:avLst>
-              <a:gd name="adj" fmla="val 3478"/>
+              <a:gd name="adj" fmla="val 4571"/>
             </a:avLst>
           </a:prstGeom>
           <a:solidFill>
-            <a:srgbClr val="FFFFFF"/>
+            <a:srgbClr val="F1F5F3"/>
           </a:solidFill>
           <a:ln w="9525">
             <a:solidFill>
@@ -9946,14 +10139,34 @@
       </p:sp>
       <p:sp>
         <p:nvSpPr>
-          <p:cNvPr id="10" name="Text 8"/>
-          <p:cNvSpPr/>
-          <p:nvPr/>
-        </p:nvSpPr>
-        <p:spPr>
-          <a:xfrm>
-            <a:off x="9144000" y="1719072"/>
-            <a:ext cx="2304288" cy="822960"/>
+          <p:cNvPr id="10" name="Shape 8"/>
+          <p:cNvSpPr/>
+          <p:nvPr/>
+        </p:nvSpPr>
+        <p:spPr>
+          <a:xfrm>
+            <a:off x="4462272" y="1819656"/>
+            <a:ext cx="457200" cy="457200"/>
+          </a:xfrm>
+          <a:prstGeom prst="ellipse">
+            <a:avLst/>
+          </a:prstGeom>
+          <a:solidFill>
+            <a:srgbClr val="EE9455"/>
+          </a:solidFill>
+          <a:ln/>
+        </p:spPr>
+      </p:sp>
+      <p:sp>
+        <p:nvSpPr>
+          <p:cNvPr id="11" name="Text 9"/>
+          <p:cNvSpPr/>
+          <p:nvPr/>
+        </p:nvSpPr>
+        <p:spPr>
+          <a:xfrm>
+            <a:off x="4462272" y="1819656"/>
+            <a:ext cx="457200" cy="457200"/>
           </a:xfrm>
           <a:prstGeom prst="rect">
             <a:avLst/>
@@ -9969,30 +10182,69 @@
               <a:buNone/>
             </a:pPr>
             <a:r>
-              <a:rPr lang="en-US" sz="3400" b="1" dirty="0">
-                <a:solidFill>
-                  <a:srgbClr val="EE9455"/>
-                </a:solidFill>
-                <a:latin typeface="Cambria" pitchFamily="34" charset="0"/>
-                <a:ea typeface="Cambria" pitchFamily="34" charset="-122"/>
-                <a:cs typeface="Cambria" pitchFamily="34" charset="-120"/>
-              </a:rPr>
-              <a:t>3</a:t>
-            </a:r>
-            <a:endParaRPr lang="en-US" sz="3400" dirty="0"/>
-          </a:p>
-        </p:txBody>
-      </p:sp>
-      <p:sp>
-        <p:nvSpPr>
-          <p:cNvPr id="11" name="Text 9"/>
-          <p:cNvSpPr/>
-          <p:nvPr/>
-        </p:nvSpPr>
-        <p:spPr>
-          <a:xfrm>
-            <a:off x="9162288" y="2514600"/>
-            <a:ext cx="2267712" cy="1097280"/>
+              <a:rPr lang="en-US" sz="1500" b="1" dirty="0">
+                <a:solidFill>
+                  <a:srgbClr val="FFFFFF"/>
+                </a:solidFill>
+                <a:latin typeface="Calibri" pitchFamily="34" charset="0"/>
+                <a:ea typeface="Calibri" pitchFamily="34" charset="-122"/>
+                <a:cs typeface="Calibri" pitchFamily="34" charset="-120"/>
+              </a:rPr>
+              <a:t>★</a:t>
+            </a:r>
+            <a:endParaRPr lang="en-US" sz="1500" dirty="0"/>
+          </a:p>
+        </p:txBody>
+      </p:sp>
+      <p:sp>
+        <p:nvSpPr>
+          <p:cNvPr id="12" name="Text 10"/>
+          <p:cNvSpPr/>
+          <p:nvPr/>
+        </p:nvSpPr>
+        <p:spPr>
+          <a:xfrm>
+            <a:off x="5084064" y="1746504"/>
+            <a:ext cx="2606040" cy="310896"/>
+          </a:xfrm>
+          <a:prstGeom prst="rect">
+            <a:avLst/>
+          </a:prstGeom>
+          <a:noFill/>
+          <a:ln/>
+        </p:spPr>
+        <p:txBody>
+          <a:bodyPr wrap="square" lIns="0" tIns="0" rIns="0" bIns="0" rtlCol="0" anchor="ctr"/>
+          <a:lstStyle/>
+          <a:p>
+            <a:pPr indent="0" marL="0">
+              <a:buNone/>
+            </a:pPr>
+            <a:r>
+              <a:rPr lang="en-US" sz="1400" b="1" dirty="0">
+                <a:solidFill>
+                  <a:srgbClr val="1D2621"/>
+                </a:solidFill>
+                <a:latin typeface="Calibri" pitchFamily="34" charset="0"/>
+                <a:ea typeface="Calibri" pitchFamily="34" charset="-122"/>
+                <a:cs typeface="Calibri" pitchFamily="34" charset="-120"/>
+              </a:rPr>
+              <a:t>Works offline</a:t>
+            </a:r>
+            <a:endParaRPr lang="en-US" sz="1400" dirty="0"/>
+          </a:p>
+        </p:txBody>
+      </p:sp>
+      <p:sp>
+        <p:nvSpPr>
+          <p:cNvPr id="13" name="Text 11"/>
+          <p:cNvSpPr/>
+          <p:nvPr/>
+        </p:nvSpPr>
+        <p:spPr>
+          <a:xfrm>
+            <a:off x="5084064" y="2057400"/>
+            <a:ext cx="2606040" cy="1051560"/>
           </a:xfrm>
           <a:prstGeom prst="rect">
             <a:avLst/>
@@ -10004,11 +10256,11 @@
           <a:bodyPr wrap="square" lIns="0" tIns="0" rIns="0" bIns="0" rtlCol="0" anchor="t"/>
           <a:lstStyle/>
           <a:p>
-            <a:pPr algn="ctr" indent="0" marL="0">
-              <a:buNone/>
-            </a:pPr>
-            <a:r>
-              <a:rPr lang="en-US" sz="1100" dirty="0">
+            <a:pPr indent="0" marL="0">
+              <a:buNone/>
+            </a:pPr>
+            <a:r>
+              <a:rPr lang="en-US" sz="1150" dirty="0">
                 <a:solidFill>
                   <a:srgbClr val="5D6B63"/>
                 </a:solidFill>
@@ -10016,30 +10268,30 @@
                 <a:ea typeface="Calibri" pitchFamily="34" charset="-122"/>
                 <a:cs typeface="Calibri" pitchFamily="34" charset="-120"/>
               </a:rPr>
-              <a:t>languages, public + members</a:t>
-            </a:r>
-            <a:endParaRPr lang="en-US" sz="1100" dirty="0"/>
-          </a:p>
-        </p:txBody>
-      </p:sp>
-      <p:sp>
-        <p:nvSpPr>
-          <p:cNvPr id="12" name="Shape 10"/>
-          <p:cNvSpPr/>
-          <p:nvPr/>
-        </p:nvSpPr>
-        <p:spPr>
-          <a:xfrm>
-            <a:off x="6400800" y="3794760"/>
-            <a:ext cx="5138928" cy="1920240"/>
+              <a:t>Caches so it opens fast and keeps working on a weak connection</a:t>
+            </a:r>
+            <a:endParaRPr lang="en-US" sz="1150" dirty="0"/>
+          </a:p>
+        </p:txBody>
+      </p:sp>
+      <p:sp>
+        <p:nvSpPr>
+          <p:cNvPr id="14" name="Shape 12"/>
+          <p:cNvSpPr/>
+          <p:nvPr/>
+        </p:nvSpPr>
+        <p:spPr>
+          <a:xfrm>
+            <a:off x="7973568" y="1600200"/>
+            <a:ext cx="3566160" cy="1600200"/>
           </a:xfrm>
           <a:prstGeom prst="roundRect">
             <a:avLst>
-              <a:gd name="adj" fmla="val 3810"/>
+              <a:gd name="adj" fmla="val 4571"/>
             </a:avLst>
           </a:prstGeom>
           <a:solidFill>
-            <a:srgbClr val="FFFFFF"/>
+            <a:srgbClr val="F1F5F3"/>
           </a:solidFill>
           <a:ln w="9525">
             <a:solidFill>
@@ -10058,14 +10310,34 @@
       </p:sp>
       <p:sp>
         <p:nvSpPr>
-          <p:cNvPr id="13" name="Text 11"/>
-          <p:cNvSpPr/>
-          <p:nvPr/>
-        </p:nvSpPr>
-        <p:spPr>
-          <a:xfrm>
-            <a:off x="6492240" y="3959352"/>
-            <a:ext cx="4956048" cy="822960"/>
+          <p:cNvPr id="15" name="Shape 13"/>
+          <p:cNvSpPr/>
+          <p:nvPr/>
+        </p:nvSpPr>
+        <p:spPr>
+          <a:xfrm>
+            <a:off x="8174736" y="1819656"/>
+            <a:ext cx="457200" cy="457200"/>
+          </a:xfrm>
+          <a:prstGeom prst="ellipse">
+            <a:avLst/>
+          </a:prstGeom>
+          <a:solidFill>
+            <a:srgbClr val="EE9455"/>
+          </a:solidFill>
+          <a:ln/>
+        </p:spPr>
+      </p:sp>
+      <p:sp>
+        <p:nvSpPr>
+          <p:cNvPr id="16" name="Text 14"/>
+          <p:cNvSpPr/>
+          <p:nvPr/>
+        </p:nvSpPr>
+        <p:spPr>
+          <a:xfrm>
+            <a:off x="8174736" y="1819656"/>
+            <a:ext cx="457200" cy="457200"/>
           </a:xfrm>
           <a:prstGeom prst="rect">
             <a:avLst/>
@@ -10081,30 +10353,69 @@
               <a:buNone/>
             </a:pPr>
             <a:r>
-              <a:rPr lang="en-US" sz="3400" b="1" dirty="0">
-                <a:solidFill>
-                  <a:srgbClr val="2C7A55"/>
-                </a:solidFill>
-                <a:latin typeface="Cambria" pitchFamily="34" charset="0"/>
-                <a:ea typeface="Cambria" pitchFamily="34" charset="-122"/>
-                <a:cs typeface="Cambria" pitchFamily="34" charset="-120"/>
-              </a:rPr>
-              <a:t>Export</a:t>
-            </a:r>
-            <a:endParaRPr lang="en-US" sz="3400" dirty="0"/>
-          </a:p>
-        </p:txBody>
-      </p:sp>
-      <p:sp>
-        <p:nvSpPr>
-          <p:cNvPr id="14" name="Text 12"/>
-          <p:cNvSpPr/>
-          <p:nvPr/>
-        </p:nvSpPr>
-        <p:spPr>
-          <a:xfrm>
-            <a:off x="6510528" y="4754880"/>
-            <a:ext cx="4919472" cy="914400"/>
+              <a:rPr lang="en-US" sz="1500" b="1" dirty="0">
+                <a:solidFill>
+                  <a:srgbClr val="FFFFFF"/>
+                </a:solidFill>
+                <a:latin typeface="Calibri" pitchFamily="34" charset="0"/>
+                <a:ea typeface="Calibri" pitchFamily="34" charset="-122"/>
+                <a:cs typeface="Calibri" pitchFamily="34" charset="-120"/>
+              </a:rPr>
+              <a:t>★</a:t>
+            </a:r>
+            <a:endParaRPr lang="en-US" sz="1500" dirty="0"/>
+          </a:p>
+        </p:txBody>
+      </p:sp>
+      <p:sp>
+        <p:nvSpPr>
+          <p:cNvPr id="17" name="Text 15"/>
+          <p:cNvSpPr/>
+          <p:nvPr/>
+        </p:nvSpPr>
+        <p:spPr>
+          <a:xfrm>
+            <a:off x="8796528" y="1746504"/>
+            <a:ext cx="2606040" cy="310896"/>
+          </a:xfrm>
+          <a:prstGeom prst="rect">
+            <a:avLst/>
+          </a:prstGeom>
+          <a:noFill/>
+          <a:ln/>
+        </p:spPr>
+        <p:txBody>
+          <a:bodyPr wrap="square" lIns="0" tIns="0" rIns="0" bIns="0" rtlCol="0" anchor="ctr"/>
+          <a:lstStyle/>
+          <a:p>
+            <a:pPr indent="0" marL="0">
+              <a:buNone/>
+            </a:pPr>
+            <a:r>
+              <a:rPr lang="en-US" sz="1400" b="1" dirty="0">
+                <a:solidFill>
+                  <a:srgbClr val="1D2621"/>
+                </a:solidFill>
+                <a:latin typeface="Calibri" pitchFamily="34" charset="0"/>
+                <a:ea typeface="Calibri" pitchFamily="34" charset="-122"/>
+                <a:cs typeface="Calibri" pitchFamily="34" charset="-120"/>
+              </a:rPr>
+              <a:t>Three languages</a:t>
+            </a:r>
+            <a:endParaRPr lang="en-US" sz="1400" dirty="0"/>
+          </a:p>
+        </p:txBody>
+      </p:sp>
+      <p:sp>
+        <p:nvSpPr>
+          <p:cNvPr id="18" name="Text 16"/>
+          <p:cNvSpPr/>
+          <p:nvPr/>
+        </p:nvSpPr>
+        <p:spPr>
+          <a:xfrm>
+            <a:off x="8796528" y="2057400"/>
+            <a:ext cx="2606040" cy="1051560"/>
           </a:xfrm>
           <a:prstGeom prst="rect">
             <a:avLst/>
@@ -10116,11 +10427,182 @@
           <a:bodyPr wrap="square" lIns="0" tIns="0" rIns="0" bIns="0" rtlCol="0" anchor="t"/>
           <a:lstStyle/>
           <a:p>
+            <a:pPr indent="0" marL="0">
+              <a:buNone/>
+            </a:pPr>
+            <a:r>
+              <a:rPr lang="en-US" sz="1150" dirty="0">
+                <a:solidFill>
+                  <a:srgbClr val="5D6B63"/>
+                </a:solidFill>
+                <a:latin typeface="Calibri" pitchFamily="34" charset="0"/>
+                <a:ea typeface="Calibri" pitchFamily="34" charset="-122"/>
+                <a:cs typeface="Calibri" pitchFamily="34" charset="-120"/>
+              </a:rPr>
+              <a:t>English, Kiswahili and Sheng — meet people where they are</a:t>
+            </a:r>
+            <a:endParaRPr lang="en-US" sz="1150" dirty="0"/>
+          </a:p>
+        </p:txBody>
+      </p:sp>
+      <p:sp>
+        <p:nvSpPr>
+          <p:cNvPr id="19" name="Shape 17"/>
+          <p:cNvSpPr/>
+          <p:nvPr/>
+        </p:nvSpPr>
+        <p:spPr>
+          <a:xfrm>
+            <a:off x="548640" y="3383280"/>
+            <a:ext cx="3566160" cy="1600200"/>
+          </a:xfrm>
+          <a:prstGeom prst="roundRect">
+            <a:avLst>
+              <a:gd name="adj" fmla="val 4571"/>
+            </a:avLst>
+          </a:prstGeom>
+          <a:solidFill>
+            <a:srgbClr val="F1F5F3"/>
+          </a:solidFill>
+          <a:ln w="9525">
+            <a:solidFill>
+              <a:srgbClr val="D9E2DC"/>
+            </a:solidFill>
+            <a:prstDash val="solid"/>
+          </a:ln>
+          <a:effectLst>
+            <a:outerShdw sx="100000" sy="100000" kx="0" ky="0" algn="bl" rotWithShape="0" blurRad="76200" dist="25400" dir="5400000">
+              <a:srgbClr val="9AA8A0">
+                <a:alpha val="35000"/>
+              </a:srgbClr>
+            </a:outerShdw>
+          </a:effectLst>
+        </p:spPr>
+      </p:sp>
+      <p:sp>
+        <p:nvSpPr>
+          <p:cNvPr id="20" name="Shape 18"/>
+          <p:cNvSpPr/>
+          <p:nvPr/>
+        </p:nvSpPr>
+        <p:spPr>
+          <a:xfrm>
+            <a:off x="749808" y="3602736"/>
+            <a:ext cx="457200" cy="457200"/>
+          </a:xfrm>
+          <a:prstGeom prst="ellipse">
+            <a:avLst/>
+          </a:prstGeom>
+          <a:solidFill>
+            <a:srgbClr val="EE9455"/>
+          </a:solidFill>
+          <a:ln/>
+        </p:spPr>
+      </p:sp>
+      <p:sp>
+        <p:nvSpPr>
+          <p:cNvPr id="21" name="Text 19"/>
+          <p:cNvSpPr/>
+          <p:nvPr/>
+        </p:nvSpPr>
+        <p:spPr>
+          <a:xfrm>
+            <a:off x="749808" y="3602736"/>
+            <a:ext cx="457200" cy="457200"/>
+          </a:xfrm>
+          <a:prstGeom prst="rect">
+            <a:avLst/>
+          </a:prstGeom>
+          <a:noFill/>
+          <a:ln/>
+        </p:spPr>
+        <p:txBody>
+          <a:bodyPr wrap="square" lIns="0" tIns="0" rIns="0" bIns="0" rtlCol="0" anchor="ctr"/>
+          <a:lstStyle/>
+          <a:p>
             <a:pPr algn="ctr" indent="0" marL="0">
               <a:buNone/>
             </a:pPr>
             <a:r>
-              <a:rPr lang="en-US" sz="1100" dirty="0">
+              <a:rPr lang="en-US" sz="1500" b="1" dirty="0">
+                <a:solidFill>
+                  <a:srgbClr val="FFFFFF"/>
+                </a:solidFill>
+                <a:latin typeface="Calibri" pitchFamily="34" charset="0"/>
+                <a:ea typeface="Calibri" pitchFamily="34" charset="-122"/>
+                <a:cs typeface="Calibri" pitchFamily="34" charset="-120"/>
+              </a:rPr>
+              <a:t>★</a:t>
+            </a:r>
+            <a:endParaRPr lang="en-US" sz="1500" dirty="0"/>
+          </a:p>
+        </p:txBody>
+      </p:sp>
+      <p:sp>
+        <p:nvSpPr>
+          <p:cNvPr id="22" name="Text 20"/>
+          <p:cNvSpPr/>
+          <p:nvPr/>
+        </p:nvSpPr>
+        <p:spPr>
+          <a:xfrm>
+            <a:off x="1371600" y="3529584"/>
+            <a:ext cx="2606040" cy="310896"/>
+          </a:xfrm>
+          <a:prstGeom prst="rect">
+            <a:avLst/>
+          </a:prstGeom>
+          <a:noFill/>
+          <a:ln/>
+        </p:spPr>
+        <p:txBody>
+          <a:bodyPr wrap="square" lIns="0" tIns="0" rIns="0" bIns="0" rtlCol="0" anchor="ctr"/>
+          <a:lstStyle/>
+          <a:p>
+            <a:pPr indent="0" marL="0">
+              <a:buNone/>
+            </a:pPr>
+            <a:r>
+              <a:rPr lang="en-US" sz="1400" b="1" dirty="0">
+                <a:solidFill>
+                  <a:srgbClr val="1D2621"/>
+                </a:solidFill>
+                <a:latin typeface="Calibri" pitchFamily="34" charset="0"/>
+                <a:ea typeface="Calibri" pitchFamily="34" charset="-122"/>
+                <a:cs typeface="Calibri" pitchFamily="34" charset="-120"/>
+              </a:rPr>
+              <a:t>Members-only &amp; secure</a:t>
+            </a:r>
+            <a:endParaRPr lang="en-US" sz="1400" dirty="0"/>
+          </a:p>
+        </p:txBody>
+      </p:sp>
+      <p:sp>
+        <p:nvSpPr>
+          <p:cNvPr id="23" name="Text 21"/>
+          <p:cNvSpPr/>
+          <p:nvPr/>
+        </p:nvSpPr>
+        <p:spPr>
+          <a:xfrm>
+            <a:off x="1371600" y="3840480"/>
+            <a:ext cx="2606040" cy="1051560"/>
+          </a:xfrm>
+          <a:prstGeom prst="rect">
+            <a:avLst/>
+          </a:prstGeom>
+          <a:noFill/>
+          <a:ln/>
+        </p:spPr>
+        <p:txBody>
+          <a:bodyPr wrap="square" lIns="0" tIns="0" rIns="0" bIns="0" rtlCol="0" anchor="t"/>
+          <a:lstStyle/>
+          <a:p>
+            <a:pPr indent="0" marL="0">
+              <a:buNone/>
+            </a:pPr>
+            <a:r>
+              <a:rPr lang="en-US" sz="1150" dirty="0">
                 <a:solidFill>
                   <a:srgbClr val="5D6B63"/>
                 </a:solidFill>
@@ -10128,15 +10610,357 @@
                 <a:ea typeface="Calibri" pitchFamily="34" charset="-122"/>
                 <a:cs typeface="Calibri" pitchFamily="34" charset="-120"/>
               </a:rPr>
-              <a:t>reach · coverage · engagement, on demand</a:t>
-            </a:r>
-            <a:endParaRPr lang="en-US" sz="1100" dirty="0"/>
-          </a:p>
-        </p:txBody>
-      </p:sp>
-      <p:sp>
-        <p:nvSpPr>
-          <p:cNvPr id="15" name="Text 13"/>
+              <a:t>Invite-only sign-in; your coordination stays inside the coalition</a:t>
+            </a:r>
+            <a:endParaRPr lang="en-US" sz="1150" dirty="0"/>
+          </a:p>
+        </p:txBody>
+      </p:sp>
+      <p:sp>
+        <p:nvSpPr>
+          <p:cNvPr id="24" name="Shape 22"/>
+          <p:cNvSpPr/>
+          <p:nvPr/>
+        </p:nvSpPr>
+        <p:spPr>
+          <a:xfrm>
+            <a:off x="4261104" y="3383280"/>
+            <a:ext cx="3566160" cy="1600200"/>
+          </a:xfrm>
+          <a:prstGeom prst="roundRect">
+            <a:avLst>
+              <a:gd name="adj" fmla="val 4571"/>
+            </a:avLst>
+          </a:prstGeom>
+          <a:solidFill>
+            <a:srgbClr val="F1F5F3"/>
+          </a:solidFill>
+          <a:ln w="9525">
+            <a:solidFill>
+              <a:srgbClr val="D9E2DC"/>
+            </a:solidFill>
+            <a:prstDash val="solid"/>
+          </a:ln>
+          <a:effectLst>
+            <a:outerShdw sx="100000" sy="100000" kx="0" ky="0" algn="bl" rotWithShape="0" blurRad="76200" dist="25400" dir="5400000">
+              <a:srgbClr val="9AA8A0">
+                <a:alpha val="35000"/>
+              </a:srgbClr>
+            </a:outerShdw>
+          </a:effectLst>
+        </p:spPr>
+      </p:sp>
+      <p:sp>
+        <p:nvSpPr>
+          <p:cNvPr id="25" name="Shape 23"/>
+          <p:cNvSpPr/>
+          <p:nvPr/>
+        </p:nvSpPr>
+        <p:spPr>
+          <a:xfrm>
+            <a:off x="4462272" y="3602736"/>
+            <a:ext cx="457200" cy="457200"/>
+          </a:xfrm>
+          <a:prstGeom prst="ellipse">
+            <a:avLst/>
+          </a:prstGeom>
+          <a:solidFill>
+            <a:srgbClr val="EE9455"/>
+          </a:solidFill>
+          <a:ln/>
+        </p:spPr>
+      </p:sp>
+      <p:sp>
+        <p:nvSpPr>
+          <p:cNvPr id="26" name="Text 24"/>
+          <p:cNvSpPr/>
+          <p:nvPr/>
+        </p:nvSpPr>
+        <p:spPr>
+          <a:xfrm>
+            <a:off x="4462272" y="3602736"/>
+            <a:ext cx="457200" cy="457200"/>
+          </a:xfrm>
+          <a:prstGeom prst="rect">
+            <a:avLst/>
+          </a:prstGeom>
+          <a:noFill/>
+          <a:ln/>
+        </p:spPr>
+        <p:txBody>
+          <a:bodyPr wrap="square" lIns="0" tIns="0" rIns="0" bIns="0" rtlCol="0" anchor="ctr"/>
+          <a:lstStyle/>
+          <a:p>
+            <a:pPr algn="ctr" indent="0" marL="0">
+              <a:buNone/>
+            </a:pPr>
+            <a:r>
+              <a:rPr lang="en-US" sz="1500" b="1" dirty="0">
+                <a:solidFill>
+                  <a:srgbClr val="FFFFFF"/>
+                </a:solidFill>
+                <a:latin typeface="Calibri" pitchFamily="34" charset="0"/>
+                <a:ea typeface="Calibri" pitchFamily="34" charset="-122"/>
+                <a:cs typeface="Calibri" pitchFamily="34" charset="-120"/>
+              </a:rPr>
+              <a:t>★</a:t>
+            </a:r>
+            <a:endParaRPr lang="en-US" sz="1500" dirty="0"/>
+          </a:p>
+        </p:txBody>
+      </p:sp>
+      <p:sp>
+        <p:nvSpPr>
+          <p:cNvPr id="27" name="Text 25"/>
+          <p:cNvSpPr/>
+          <p:nvPr/>
+        </p:nvSpPr>
+        <p:spPr>
+          <a:xfrm>
+            <a:off x="5084064" y="3529584"/>
+            <a:ext cx="2606040" cy="310896"/>
+          </a:xfrm>
+          <a:prstGeom prst="rect">
+            <a:avLst/>
+          </a:prstGeom>
+          <a:noFill/>
+          <a:ln/>
+        </p:spPr>
+        <p:txBody>
+          <a:bodyPr wrap="square" lIns="0" tIns="0" rIns="0" bIns="0" rtlCol="0" anchor="ctr"/>
+          <a:lstStyle/>
+          <a:p>
+            <a:pPr indent="0" marL="0">
+              <a:buNone/>
+            </a:pPr>
+            <a:r>
+              <a:rPr lang="en-US" sz="1400" b="1" dirty="0">
+                <a:solidFill>
+                  <a:srgbClr val="1D2621"/>
+                </a:solidFill>
+                <a:latin typeface="Calibri" pitchFamily="34" charset="0"/>
+                <a:ea typeface="Calibri" pitchFamily="34" charset="-122"/>
+                <a:cs typeface="Calibri" pitchFamily="34" charset="-120"/>
+              </a:rPr>
+              <a:t>One tap in</a:t>
+            </a:r>
+            <a:endParaRPr lang="en-US" sz="1400" dirty="0"/>
+          </a:p>
+        </p:txBody>
+      </p:sp>
+      <p:sp>
+        <p:nvSpPr>
+          <p:cNvPr id="28" name="Text 26"/>
+          <p:cNvSpPr/>
+          <p:nvPr/>
+        </p:nvSpPr>
+        <p:spPr>
+          <a:xfrm>
+            <a:off x="5084064" y="3840480"/>
+            <a:ext cx="2606040" cy="1051560"/>
+          </a:xfrm>
+          <a:prstGeom prst="rect">
+            <a:avLst/>
+          </a:prstGeom>
+          <a:noFill/>
+          <a:ln/>
+        </p:spPr>
+        <p:txBody>
+          <a:bodyPr wrap="square" lIns="0" tIns="0" rIns="0" bIns="0" rtlCol="0" anchor="t"/>
+          <a:lstStyle/>
+          <a:p>
+            <a:pPr indent="0" marL="0">
+              <a:buNone/>
+            </a:pPr>
+            <a:r>
+              <a:rPr lang="en-US" sz="1150" dirty="0">
+                <a:solidFill>
+                  <a:srgbClr val="5D6B63"/>
+                </a:solidFill>
+                <a:latin typeface="Calibri" pitchFamily="34" charset="0"/>
+                <a:ea typeface="Calibri" pitchFamily="34" charset="-122"/>
+                <a:cs typeface="Calibri" pitchFamily="34" charset="-120"/>
+              </a:rPr>
+              <a:t>Magic-link or password sign-in — nothing to configure</a:t>
+            </a:r>
+            <a:endParaRPr lang="en-US" sz="1150" dirty="0"/>
+          </a:p>
+        </p:txBody>
+      </p:sp>
+      <p:sp>
+        <p:nvSpPr>
+          <p:cNvPr id="29" name="Shape 27"/>
+          <p:cNvSpPr/>
+          <p:nvPr/>
+        </p:nvSpPr>
+        <p:spPr>
+          <a:xfrm>
+            <a:off x="7973568" y="3383280"/>
+            <a:ext cx="3566160" cy="1600200"/>
+          </a:xfrm>
+          <a:prstGeom prst="roundRect">
+            <a:avLst>
+              <a:gd name="adj" fmla="val 4571"/>
+            </a:avLst>
+          </a:prstGeom>
+          <a:solidFill>
+            <a:srgbClr val="F1F5F3"/>
+          </a:solidFill>
+          <a:ln w="9525">
+            <a:solidFill>
+              <a:srgbClr val="D9E2DC"/>
+            </a:solidFill>
+            <a:prstDash val="solid"/>
+          </a:ln>
+          <a:effectLst>
+            <a:outerShdw sx="100000" sy="100000" kx="0" ky="0" algn="bl" rotWithShape="0" blurRad="76200" dist="25400" dir="5400000">
+              <a:srgbClr val="9AA8A0">
+                <a:alpha val="35000"/>
+              </a:srgbClr>
+            </a:outerShdw>
+          </a:effectLst>
+        </p:spPr>
+      </p:sp>
+      <p:sp>
+        <p:nvSpPr>
+          <p:cNvPr id="30" name="Shape 28"/>
+          <p:cNvSpPr/>
+          <p:nvPr/>
+        </p:nvSpPr>
+        <p:spPr>
+          <a:xfrm>
+            <a:off x="8174736" y="3602736"/>
+            <a:ext cx="457200" cy="457200"/>
+          </a:xfrm>
+          <a:prstGeom prst="ellipse">
+            <a:avLst/>
+          </a:prstGeom>
+          <a:solidFill>
+            <a:srgbClr val="EE9455"/>
+          </a:solidFill>
+          <a:ln/>
+        </p:spPr>
+      </p:sp>
+      <p:sp>
+        <p:nvSpPr>
+          <p:cNvPr id="31" name="Text 29"/>
+          <p:cNvSpPr/>
+          <p:nvPr/>
+        </p:nvSpPr>
+        <p:spPr>
+          <a:xfrm>
+            <a:off x="8174736" y="3602736"/>
+            <a:ext cx="457200" cy="457200"/>
+          </a:xfrm>
+          <a:prstGeom prst="rect">
+            <a:avLst/>
+          </a:prstGeom>
+          <a:noFill/>
+          <a:ln/>
+        </p:spPr>
+        <p:txBody>
+          <a:bodyPr wrap="square" lIns="0" tIns="0" rIns="0" bIns="0" rtlCol="0" anchor="ctr"/>
+          <a:lstStyle/>
+          <a:p>
+            <a:pPr algn="ctr" indent="0" marL="0">
+              <a:buNone/>
+            </a:pPr>
+            <a:r>
+              <a:rPr lang="en-US" sz="1500" b="1" dirty="0">
+                <a:solidFill>
+                  <a:srgbClr val="FFFFFF"/>
+                </a:solidFill>
+                <a:latin typeface="Calibri" pitchFamily="34" charset="0"/>
+                <a:ea typeface="Calibri" pitchFamily="34" charset="-122"/>
+                <a:cs typeface="Calibri" pitchFamily="34" charset="-120"/>
+              </a:rPr>
+              <a:t>★</a:t>
+            </a:r>
+            <a:endParaRPr lang="en-US" sz="1500" dirty="0"/>
+          </a:p>
+        </p:txBody>
+      </p:sp>
+      <p:sp>
+        <p:nvSpPr>
+          <p:cNvPr id="32" name="Text 30"/>
+          <p:cNvSpPr/>
+          <p:nvPr/>
+        </p:nvSpPr>
+        <p:spPr>
+          <a:xfrm>
+            <a:off x="8796528" y="3529584"/>
+            <a:ext cx="2606040" cy="310896"/>
+          </a:xfrm>
+          <a:prstGeom prst="rect">
+            <a:avLst/>
+          </a:prstGeom>
+          <a:noFill/>
+          <a:ln/>
+        </p:spPr>
+        <p:txBody>
+          <a:bodyPr wrap="square" lIns="0" tIns="0" rIns="0" bIns="0" rtlCol="0" anchor="ctr"/>
+          <a:lstStyle/>
+          <a:p>
+            <a:pPr indent="0" marL="0">
+              <a:buNone/>
+            </a:pPr>
+            <a:r>
+              <a:rPr lang="en-US" sz="1400" b="1" dirty="0">
+                <a:solidFill>
+                  <a:srgbClr val="1D2621"/>
+                </a:solidFill>
+                <a:latin typeface="Calibri" pitchFamily="34" charset="0"/>
+                <a:ea typeface="Calibri" pitchFamily="34" charset="-122"/>
+                <a:cs typeface="Calibri" pitchFamily="34" charset="-120"/>
+              </a:rPr>
+              <a:t>Sourced &amp; honest</a:t>
+            </a:r>
+            <a:endParaRPr lang="en-US" sz="1400" dirty="0"/>
+          </a:p>
+        </p:txBody>
+      </p:sp>
+      <p:sp>
+        <p:nvSpPr>
+          <p:cNvPr id="33" name="Text 31"/>
+          <p:cNvSpPr/>
+          <p:nvPr/>
+        </p:nvSpPr>
+        <p:spPr>
+          <a:xfrm>
+            <a:off x="8796528" y="3840480"/>
+            <a:ext cx="2606040" cy="1051560"/>
+          </a:xfrm>
+          <a:prstGeom prst="rect">
+            <a:avLst/>
+          </a:prstGeom>
+          <a:noFill/>
+          <a:ln/>
+        </p:spPr>
+        <p:txBody>
+          <a:bodyPr wrap="square" lIns="0" tIns="0" rIns="0" bIns="0" rtlCol="0" anchor="t"/>
+          <a:lstStyle/>
+          <a:p>
+            <a:pPr indent="0" marL="0">
+              <a:buNone/>
+            </a:pPr>
+            <a:r>
+              <a:rPr lang="en-US" sz="1150" dirty="0">
+                <a:solidFill>
+                  <a:srgbClr val="5D6B63"/>
+                </a:solidFill>
+                <a:latin typeface="Calibri" pitchFamily="34" charset="0"/>
+                <a:ea typeface="Calibri" pitchFamily="34" charset="-122"/>
+                <a:cs typeface="Calibri" pitchFamily="34" charset="-120"/>
+              </a:rPr>
+              <a:t>Every claim links to its source; no fabricated data</a:t>
+            </a:r>
+            <a:endParaRPr lang="en-US" sz="1150" dirty="0"/>
+          </a:p>
+        </p:txBody>
+      </p:sp>
+      <p:sp>
+        <p:nvSpPr>
+          <p:cNvPr id="34" name="Text 32"/>
           <p:cNvSpPr/>
           <p:nvPr/>
         </p:nvSpPr>

</xml_diff>